<commit_message>
Apresentação em tons escuros, com mais espaço entre linhas e frases com maiúscula
Co-Authored-By: Claude Opus 5.5 <noreply@anthropic.com>
Claude-Session: https://claude.ai/code/session_01RHnng4HnqckYC12h8qqyAi
</commit_message>
<xml_diff>
--- a/docs/apresentacao/Pioneiros-app-apresentacao.pptx
+++ b/docs/apresentacao/Pioneiros-app-apresentacao.pptx
@@ -123,25 +123,25 @@
   <p:extLst>
     <p:ext uri="{521415D9-36F7-43E2-AB2F-B90AF26B5E84}">
       <p14:sectionLst xmlns:p14="http://schemas.microsoft.com/office/powerpoint/2010/main">
-        <p14:section name="Abertura" id="{f0a1ef7d-74b3-9d83-5ad8-dd3e8a24be62}">
+        <p14:section name="Abertura" id="{dd864e87-9929-ca5d-8c0e-10546947a114}">
           <p14:sldIdLst>
             <p14:sldId id="256"/>
             <p14:sldId id="257"/>
           </p14:sldIdLst>
         </p14:section>
-        <p14:section name="Começar" id="{933e3b3b-c4f2-f931-81c2-a882ef823537}">
+        <p14:section name="Começar" id="{93c5cc62-e24b-ff00-1637-bd0d487f0b27}">
           <p14:sldIdLst>
             <p14:sldId id="258"/>
             <p14:sldId id="259"/>
           </p14:sldIdLst>
         </p14:section>
-        <p14:section name="Os teus trilhos" id="{7c8c37ce-e4ca-e799-eb4f-7e46ac0404c8}">
+        <p14:section name="Os teus trilhos" id="{9edac593-ff65-0b20-fd0a-d25ba54dc8c3}">
           <p14:sldIdLst>
             <p14:sldId id="260"/>
             <p14:sldId id="261"/>
           </p14:sldIdLst>
         </p14:section>
-        <p14:section name="Trabalhar e fechar" id="{26d14dd7-079c-d0be-dd2d-e008ce17b13c}">
+        <p14:section name="Trabalhar e fechar" id="{85c956f4-7797-0cd3-0e2f-0d554da48952}">
           <p14:sldIdLst>
             <p14:sldId id="262"/>
             <p14:sldId id="263"/>
@@ -149,21 +149,21 @@
             <p14:sldId id="265"/>
           </p14:sldIdLst>
         </p14:section>
-        <p14:section name="Acompanhar" id="{9a1ab718-8df6-06dc-37c4-544323e582b6}">
+        <p14:section name="Acompanhar" id="{dcba1786-9c2f-9ea7-0350-0bfe4d62bc01}">
           <p14:sldIdLst>
             <p14:sldId id="266"/>
             <p14:sldId id="267"/>
             <p14:sldId id="268"/>
           </p14:sldIdLst>
         </p14:section>
-        <p14:section name="Mais" id="{30d2e475-a1ec-4920-512c-369caa6955d5}">
+        <p14:section name="Mais" id="{1bc90961-8b15-4e02-eeb0-375679aab73f}">
           <p14:sldIdLst>
             <p14:sldId id="269"/>
             <p14:sldId id="270"/>
             <p14:sldId id="271"/>
           </p14:sldIdLst>
         </p14:section>
-        <p14:section name="Fecho" id="{86708c74-dac7-9dcd-b53e-6b378a9d24ca}">
+        <p14:section name="Fecho" id="{150c3ad5-7f94-7c6a-ce5f-e532a92c3867}">
           <p14:sldIdLst>
             <p14:sldId id="272"/>
           </p14:sldIdLst>
@@ -2058,7 +2058,7 @@
     <p:bg>
       <p:bgPr>
         <a:solidFill>
-          <a:srgbClr val="14213D"/>
+          <a:srgbClr val="0A1226"/>
         </a:solidFill>
       </p:bgPr>
     </p:bg>
@@ -2168,7 +2168,7 @@
     <p:bg>
       <p:bgPr>
         <a:solidFill>
-          <a:srgbClr val="FFFFFF"/>
+          <a:srgbClr val="101C36"/>
         </a:solidFill>
       </p:bgPr>
     </p:bg>
@@ -2212,7 +2212,7 @@
               <a:buNone/>
               <a:defRPr lang="en-US" sz="3200" b="1" dirty="0">
                 <a:solidFill>
-                  <a:schemeClr val="tx1"/>
+                  <a:srgbClr val="FFFFFF"/>
                 </a:solidFill>
               </a:defRPr>
             </a:lvl1pPr>
@@ -2255,7 +2255,7 @@
             <a:lvl1pPr>
               <a:defRPr sz="1000">
                 <a:solidFill>
-                  <a:srgbClr val="6B7A90"/>
+                  <a:srgbClr val="8FA3C7"/>
                 </a:solidFill>
               </a:defRPr>
             </a:lvl1pPr>
@@ -2325,7 +2325,7 @@
             <a:lvl1pPr>
               <a:defRPr sz="1000">
                 <a:solidFill>
-                  <a:srgbClr val="6B7A90"/>
+                  <a:srgbClr val="8FA3C7"/>
                 </a:solidFill>
               </a:defRPr>
             </a:lvl1pPr>
@@ -2772,11 +2772,11 @@
             </a:avLst>
           </a:prstGeom>
           <a:solidFill>
-            <a:srgbClr val="14213D"/>
+            <a:srgbClr val="3A4D75"/>
           </a:solidFill>
           <a:ln w="12700">
             <a:solidFill>
-              <a:srgbClr val="14213D"/>
+              <a:srgbClr val="3A4D75"/>
             </a:solidFill>
             <a:prstDash val="solid"/>
           </a:ln>
@@ -2867,7 +2867,7 @@
             <a:r>
               <a:rPr lang="en-US" sz="3200" b="1" dirty="0">
                 <a:solidFill>
-                  <a:schemeClr val="tx1"/>
+                  <a:srgbClr val="FFFFFF"/>
                 </a:solidFill>
               </a:rPr>
               <a:t>Quando um pedido fica «A rever»</a:t>
@@ -2884,18 +2884,18 @@
         </p:nvSpPr>
         <p:spPr>
           <a:xfrm>
-            <a:off x="548640" y="1508760"/>
+            <a:off x="548640" y="1600200"/>
             <a:ext cx="566928" cy="566928"/>
           </a:xfrm>
           <a:prstGeom prst="ellipse">
             <a:avLst/>
           </a:prstGeom>
           <a:solidFill>
-            <a:srgbClr val="1D4FA3"/>
+            <a:srgbClr val="2F6BD8"/>
           </a:solidFill>
           <a:ln w="12700">
             <a:solidFill>
-              <a:srgbClr val="1D4FA3"/>
+              <a:srgbClr val="2F6BD8"/>
             </a:solidFill>
             <a:prstDash val="solid"/>
           </a:ln>
@@ -2917,7 +2917,7 @@
         </p:blipFill>
         <p:spPr>
           <a:xfrm>
-            <a:off x="685800" y="1645920"/>
+            <a:off x="685800" y="1737360"/>
             <a:ext cx="292608" cy="292608"/>
           </a:xfrm>
           <a:prstGeom prst="rect">
@@ -2933,8 +2933,8 @@
         </p:nvSpPr>
         <p:spPr>
           <a:xfrm>
-            <a:off x="1325880" y="1472184"/>
-            <a:ext cx="6172200" cy="1097280"/>
+            <a:off x="1371600" y="1563624"/>
+            <a:ext cx="6126480" cy="1115568"/>
           </a:xfrm>
           <a:prstGeom prst="rect">
             <a:avLst/>
@@ -2947,15 +2947,18 @@
           <a:lstStyle/>
           <a:p>
             <a:pPr indent="0" marL="0">
+              <a:lnSpc>
+                <a:spcPct val="115000"/>
+              </a:lnSpc>
               <a:spcAft>
-                <a:spcPts val="200"/>
+                <a:spcPts val="400"/>
               </a:spcAft>
               <a:buNone/>
             </a:pPr>
             <a:r>
               <a:rPr lang="en-US" sz="1700" b="1" dirty="0">
                 <a:solidFill>
-                  <a:schemeClr val="tx1"/>
+                  <a:srgbClr val="FFFFFF"/>
                 </a:solidFill>
               </a:rPr>
               <a:t>Lê o comentário</a:t>
@@ -2964,15 +2967,15 @@
           </a:p>
           <a:p>
             <a:pPr indent="0" marL="0">
-              <a:spcAft>
-                <a:spcPts val="200"/>
-              </a:spcAft>
-              <a:buNone/>
-            </a:pPr>
-            <a:r>
-              <a:rPr lang="en-US" sz="1400" dirty="0">
-                <a:solidFill>
-                  <a:srgbClr val="44506A"/>
+              <a:lnSpc>
+                <a:spcPct val="115000"/>
+              </a:lnSpc>
+              <a:buNone/>
+            </a:pPr>
+            <a:r>
+              <a:rPr lang="en-US" sz="1500" dirty="0">
+                <a:solidFill>
+                  <a:srgbClr val="C9D6EE"/>
                 </a:solidFill>
               </a:rPr>
               <a:t>O guia ou o dirigente explica o que falta e que objetivos mostrar melhor.</a:t>
@@ -2989,18 +2992,18 @@
         </p:nvSpPr>
         <p:spPr>
           <a:xfrm>
-            <a:off x="548640" y="2697480"/>
+            <a:off x="548640" y="2788920"/>
             <a:ext cx="566928" cy="566928"/>
           </a:xfrm>
           <a:prstGeom prst="ellipse">
             <a:avLst/>
           </a:prstGeom>
           <a:solidFill>
-            <a:srgbClr val="1D4FA3"/>
+            <a:srgbClr val="2F6BD8"/>
           </a:solidFill>
           <a:ln w="12700">
             <a:solidFill>
-              <a:srgbClr val="1D4FA3"/>
+              <a:srgbClr val="2F6BD8"/>
             </a:solidFill>
             <a:prstDash val="solid"/>
           </a:ln>
@@ -3022,7 +3025,7 @@
         </p:blipFill>
         <p:spPr>
           <a:xfrm>
-            <a:off x="685800" y="2834640"/>
+            <a:off x="685800" y="2926080"/>
             <a:ext cx="292608" cy="292608"/>
           </a:xfrm>
           <a:prstGeom prst="rect">
@@ -3038,8 +3041,8 @@
         </p:nvSpPr>
         <p:spPr>
           <a:xfrm>
-            <a:off x="1325880" y="2660904"/>
-            <a:ext cx="6172200" cy="1097280"/>
+            <a:off x="1371600" y="2752344"/>
+            <a:ext cx="6126480" cy="1115568"/>
           </a:xfrm>
           <a:prstGeom prst="rect">
             <a:avLst/>
@@ -3052,15 +3055,18 @@
           <a:lstStyle/>
           <a:p>
             <a:pPr indent="0" marL="0">
+              <a:lnSpc>
+                <a:spcPct val="115000"/>
+              </a:lnSpc>
               <a:spcAft>
-                <a:spcPts val="200"/>
+                <a:spcPts val="400"/>
               </a:spcAft>
               <a:buNone/>
             </a:pPr>
             <a:r>
               <a:rPr lang="en-US" sz="1700" b="1" dirty="0">
                 <a:solidFill>
-                  <a:schemeClr val="tx1"/>
+                  <a:srgbClr val="FFFFFF"/>
                 </a:solidFill>
               </a:rPr>
               <a:t>Corrige a justificação</a:t>
@@ -3069,15 +3075,15 @@
           </a:p>
           <a:p>
             <a:pPr indent="0" marL="0">
-              <a:spcAft>
-                <a:spcPts val="200"/>
-              </a:spcAft>
-              <a:buNone/>
-            </a:pPr>
-            <a:r>
-              <a:rPr lang="en-US" sz="1400" dirty="0">
-                <a:solidFill>
-                  <a:srgbClr val="44506A"/>
+              <a:lnSpc>
+                <a:spcPct val="115000"/>
+              </a:lnSpc>
+              <a:buNone/>
+            </a:pPr>
+            <a:r>
+              <a:rPr lang="en-US" sz="1500" dirty="0">
+                <a:solidFill>
+                  <a:srgbClr val="C9D6EE"/>
                 </a:solidFill>
               </a:rPr>
               <a:t>O teu texto anterior já lá está: só tens de completar.</a:t>
@@ -3094,18 +3100,18 @@
         </p:nvSpPr>
         <p:spPr>
           <a:xfrm>
-            <a:off x="548640" y="3886200"/>
+            <a:off x="548640" y="3977640"/>
             <a:ext cx="566928" cy="566928"/>
           </a:xfrm>
           <a:prstGeom prst="ellipse">
             <a:avLst/>
           </a:prstGeom>
           <a:solidFill>
-            <a:srgbClr val="1D4FA3"/>
+            <a:srgbClr val="2F6BD8"/>
           </a:solidFill>
           <a:ln w="12700">
             <a:solidFill>
-              <a:srgbClr val="1D4FA3"/>
+              <a:srgbClr val="2F6BD8"/>
             </a:solidFill>
             <a:prstDash val="solid"/>
           </a:ln>
@@ -3127,7 +3133,7 @@
         </p:blipFill>
         <p:spPr>
           <a:xfrm>
-            <a:off x="685800" y="4023360"/>
+            <a:off x="685800" y="4114800"/>
             <a:ext cx="292608" cy="292608"/>
           </a:xfrm>
           <a:prstGeom prst="rect">
@@ -3143,8 +3149,8 @@
         </p:nvSpPr>
         <p:spPr>
           <a:xfrm>
-            <a:off x="1325880" y="3849624"/>
-            <a:ext cx="6172200" cy="1097280"/>
+            <a:off x="1371600" y="3941064"/>
+            <a:ext cx="6126480" cy="1115568"/>
           </a:xfrm>
           <a:prstGeom prst="rect">
             <a:avLst/>
@@ -3157,15 +3163,18 @@
           <a:lstStyle/>
           <a:p>
             <a:pPr indent="0" marL="0">
+              <a:lnSpc>
+                <a:spcPct val="115000"/>
+              </a:lnSpc>
               <a:spcAft>
-                <a:spcPts val="200"/>
+                <a:spcPts val="400"/>
               </a:spcAft>
               <a:buNone/>
             </a:pPr>
             <a:r>
               <a:rPr lang="en-US" sz="1700" b="1" dirty="0">
                 <a:solidFill>
-                  <a:schemeClr val="tx1"/>
+                  <a:srgbClr val="FFFFFF"/>
                 </a:solidFill>
               </a:rPr>
               <a:t>Volta a pedir a validação</a:t>
@@ -3174,15 +3183,15 @@
           </a:p>
           <a:p>
             <a:pPr indent="0" marL="0">
-              <a:spcAft>
-                <a:spcPts val="200"/>
-              </a:spcAft>
-              <a:buNone/>
-            </a:pPr>
-            <a:r>
-              <a:rPr lang="en-US" sz="1400" dirty="0">
-                <a:solidFill>
-                  <a:srgbClr val="44506A"/>
+              <a:lnSpc>
+                <a:spcPct val="115000"/>
+              </a:lnSpc>
+              <a:buNone/>
+            </a:pPr>
+            <a:r>
+              <a:rPr lang="en-US" sz="1500" dirty="0">
+                <a:solidFill>
+                  <a:srgbClr val="C9D6EE"/>
                 </a:solidFill>
               </a:rPr>
               <a:t>O histórico fica guardado; nada se perde.</a:t>
@@ -3281,10 +3290,10 @@
             <a:r>
               <a:rPr lang="en-US" sz="1600" b="1" dirty="0">
                 <a:solidFill>
-                  <a:schemeClr val="tx1"/>
-                </a:solidFill>
-              </a:rPr>
-              <a:t>não é um «chumbo» — é um «quase»!</a:t>
+                  <a:srgbClr val="FFFFFF"/>
+                </a:solidFill>
+              </a:rPr>
+              <a:t>Não é um «chumbo»: é um «quase»!</a:t>
             </a:r>
             <a:endParaRPr lang="en-US" sz="1600" dirty="0"/>
           </a:p>
@@ -3307,11 +3316,11 @@
             </a:avLst>
           </a:prstGeom>
           <a:solidFill>
-            <a:srgbClr val="14213D"/>
+            <a:srgbClr val="3A4D75"/>
           </a:solidFill>
           <a:ln w="12700">
             <a:solidFill>
-              <a:srgbClr val="14213D"/>
+              <a:srgbClr val="3A4D75"/>
             </a:solidFill>
             <a:prstDash val="solid"/>
           </a:ln>
@@ -3378,7 +3387,7 @@
             <a:lvl1pPr>
               <a:defRPr sz="1000">
                 <a:solidFill>
-                  <a:srgbClr val="6B7A90"/>
+                  <a:srgbClr val="8FA3C7"/>
                 </a:solidFill>
               </a:defRPr>
             </a:lvl1pPr>
@@ -3447,7 +3456,7 @@
             <a:r>
               <a:rPr lang="en-US" sz="3200" b="1" dirty="0">
                 <a:solidFill>
-                  <a:schemeClr val="tx1"/>
+                  <a:srgbClr val="FFFFFF"/>
                 </a:solidFill>
               </a:rPr>
               <a:t>Pedidos e progresso validado</a:t>
@@ -3464,7 +3473,7 @@
         </p:nvSpPr>
         <p:spPr>
           <a:xfrm>
-            <a:off x="548640" y="1508760"/>
+            <a:off x="548640" y="1600200"/>
             <a:ext cx="5669280" cy="3840480"/>
           </a:xfrm>
           <a:prstGeom prst="rect">
@@ -3478,12 +3487,15 @@
           <a:lstStyle/>
           <a:p>
             <a:pPr indent="0" marL="0">
+              <a:lnSpc>
+                <a:spcPct val="120000"/>
+              </a:lnSpc>
               <a:buNone/>
             </a:pPr>
             <a:r>
               <a:rPr lang="en-US" sz="1800" b="1" dirty="0">
                 <a:solidFill>
-                  <a:schemeClr val="tx1"/>
+                  <a:srgbClr val="FFFFFF"/>
                 </a:solidFill>
               </a:rPr>
               <a:t>Os meus pedidos</a:t>
@@ -3492,12 +3504,15 @@
           </a:p>
           <a:p>
             <a:pPr indent="0" marL="0">
+              <a:lnSpc>
+                <a:spcPct val="120000"/>
+              </a:lnSpc>
               <a:buNone/>
             </a:pPr>
             <a:r>
               <a:rPr lang="en-US" sz="1500" dirty="0">
                 <a:solidFill>
-                  <a:srgbClr val="44506A"/>
+                  <a:srgbClr val="C9D6EE"/>
                 </a:solidFill>
               </a:rPr>
               <a:t>Todos os pedidos com trilho, data, estado e a resposta recebida. Filtra por Em validação, A rever ou Validados.</a:t>
@@ -3506,10 +3521,13 @@
           </a:p>
           <a:p>
             <a:pPr indent="0" marL="0">
-              <a:buNone/>
-            </a:pPr>
-            <a:r>
-              <a:rPr lang="en-US" sz="1000" dirty="0">
+              <a:lnSpc>
+                <a:spcPct val="120000"/>
+              </a:lnSpc>
+              <a:buNone/>
+            </a:pPr>
+            <a:r>
+              <a:rPr lang="en-US" sz="1600" dirty="0">
                 <a:solidFill>
                   <a:srgbClr val="000000"/>
                 </a:solidFill>
@@ -3520,12 +3538,15 @@
           </a:p>
           <a:p>
             <a:pPr indent="0" marL="0">
+              <a:lnSpc>
+                <a:spcPct val="120000"/>
+              </a:lnSpc>
               <a:buNone/>
             </a:pPr>
             <a:r>
               <a:rPr lang="en-US" sz="1800" b="1" dirty="0">
                 <a:solidFill>
-                  <a:schemeClr val="tx1"/>
+                  <a:srgbClr val="FFFFFF"/>
                 </a:solidFill>
               </a:rPr>
               <a:t>Progresso validado</a:t>
@@ -3534,12 +3555,15 @@
           </a:p>
           <a:p>
             <a:pPr indent="0" marL="0">
+              <a:lnSpc>
+                <a:spcPct val="120000"/>
+              </a:lnSpc>
               <a:buNone/>
             </a:pPr>
             <a:r>
               <a:rPr lang="en-US" sz="1500" dirty="0">
                 <a:solidFill>
-                  <a:srgbClr val="44506A"/>
+                  <a:srgbClr val="C9D6EE"/>
                 </a:solidFill>
               </a:rPr>
               <a:t>Os trilhos que já fechaste, por área, com a data da decisão.</a:t>
@@ -3565,11 +3589,11 @@
             </a:avLst>
           </a:prstGeom>
           <a:solidFill>
-            <a:srgbClr val="14213D"/>
+            <a:srgbClr val="3A4D75"/>
           </a:solidFill>
           <a:ln w="12700">
             <a:solidFill>
-              <a:srgbClr val="14213D"/>
+              <a:srgbClr val="3A4D75"/>
             </a:solidFill>
             <a:prstDash val="solid"/>
           </a:ln>
@@ -3623,11 +3647,11 @@
             </a:avLst>
           </a:prstGeom>
           <a:solidFill>
-            <a:srgbClr val="14213D"/>
+            <a:srgbClr val="3A4D75"/>
           </a:solidFill>
           <a:ln w="12700">
             <a:solidFill>
-              <a:srgbClr val="14213D"/>
+              <a:srgbClr val="3A4D75"/>
             </a:solidFill>
             <a:prstDash val="solid"/>
           </a:ln>
@@ -3694,7 +3718,7 @@
             <a:lvl1pPr>
               <a:defRPr sz="1000">
                 <a:solidFill>
-                  <a:srgbClr val="6B7A90"/>
+                  <a:srgbClr val="8FA3C7"/>
                 </a:solidFill>
               </a:defRPr>
             </a:lvl1pPr>
@@ -3763,7 +3787,7 @@
             <a:r>
               <a:rPr lang="en-US" sz="3200" b="1" dirty="0">
                 <a:solidFill>
-                  <a:schemeClr val="tx1"/>
+                  <a:srgbClr val="FFFFFF"/>
                 </a:solidFill>
               </a:rPr>
               <a:t>O meu percurso</a:t>
@@ -3780,18 +3804,18 @@
         </p:nvSpPr>
         <p:spPr>
           <a:xfrm>
-            <a:off x="548640" y="1508760"/>
+            <a:off x="548640" y="1600200"/>
             <a:ext cx="566928" cy="566928"/>
           </a:xfrm>
           <a:prstGeom prst="ellipse">
             <a:avLst/>
           </a:prstGeom>
           <a:solidFill>
-            <a:srgbClr val="1D4FA3"/>
+            <a:srgbClr val="2F6BD8"/>
           </a:solidFill>
           <a:ln w="12700">
             <a:solidFill>
-              <a:srgbClr val="1D4FA3"/>
+              <a:srgbClr val="2F6BD8"/>
             </a:solidFill>
             <a:prstDash val="solid"/>
           </a:ln>
@@ -3813,7 +3837,7 @@
         </p:blipFill>
         <p:spPr>
           <a:xfrm>
-            <a:off x="685800" y="1645920"/>
+            <a:off x="685800" y="1737360"/>
             <a:ext cx="292608" cy="292608"/>
           </a:xfrm>
           <a:prstGeom prst="rect">
@@ -3829,8 +3853,8 @@
         </p:nvSpPr>
         <p:spPr>
           <a:xfrm>
-            <a:off x="1325880" y="1472184"/>
-            <a:ext cx="6172200" cy="932688"/>
+            <a:off x="1371600" y="1563624"/>
+            <a:ext cx="6126480" cy="1024128"/>
           </a:xfrm>
           <a:prstGeom prst="rect">
             <a:avLst/>
@@ -3843,15 +3867,18 @@
           <a:lstStyle/>
           <a:p>
             <a:pPr indent="0" marL="0">
+              <a:lnSpc>
+                <a:spcPct val="115000"/>
+              </a:lnSpc>
               <a:spcAft>
-                <a:spcPts val="200"/>
+                <a:spcPts val="400"/>
               </a:spcAft>
               <a:buNone/>
             </a:pPr>
             <a:r>
               <a:rPr lang="en-US" sz="1700" b="1" dirty="0">
                 <a:solidFill>
-                  <a:schemeClr val="tx1"/>
+                  <a:srgbClr val="FFFFFF"/>
                 </a:solidFill>
               </a:rPr>
               <a:t>Etapa atual</a:t>
@@ -3860,15 +3887,15 @@
           </a:p>
           <a:p>
             <a:pPr indent="0" marL="0">
-              <a:spcAft>
-                <a:spcPts val="200"/>
-              </a:spcAft>
-              <a:buNone/>
-            </a:pPr>
-            <a:r>
-              <a:rPr lang="en-US" sz="1400" dirty="0">
-                <a:solidFill>
-                  <a:srgbClr val="44506A"/>
+              <a:lnSpc>
+                <a:spcPct val="115000"/>
+              </a:lnSpc>
+              <a:buNone/>
+            </a:pPr>
+            <a:r>
+              <a:rPr lang="en-US" sz="1500" dirty="0">
+                <a:solidFill>
+                  <a:srgbClr val="C9D6EE"/>
                 </a:solidFill>
               </a:rPr>
               <a:t>Quantas áreas já têm trilho validado nesta etapa.</a:t>
@@ -3885,18 +3912,18 @@
         </p:nvSpPr>
         <p:spPr>
           <a:xfrm>
-            <a:off x="548640" y="2532888"/>
+            <a:off x="548640" y="2697480"/>
             <a:ext cx="566928" cy="566928"/>
           </a:xfrm>
           <a:prstGeom prst="ellipse">
             <a:avLst/>
           </a:prstGeom>
           <a:solidFill>
-            <a:srgbClr val="1D4FA3"/>
+            <a:srgbClr val="2F6BD8"/>
           </a:solidFill>
           <a:ln w="12700">
             <a:solidFill>
-              <a:srgbClr val="1D4FA3"/>
+              <a:srgbClr val="2F6BD8"/>
             </a:solidFill>
             <a:prstDash val="solid"/>
           </a:ln>
@@ -3918,7 +3945,7 @@
         </p:blipFill>
         <p:spPr>
           <a:xfrm>
-            <a:off x="685800" y="2670048"/>
+            <a:off x="685800" y="2834640"/>
             <a:ext cx="292608" cy="292608"/>
           </a:xfrm>
           <a:prstGeom prst="rect">
@@ -3934,8 +3961,8 @@
         </p:nvSpPr>
         <p:spPr>
           <a:xfrm>
-            <a:off x="1325880" y="2496312"/>
-            <a:ext cx="6172200" cy="932688"/>
+            <a:off x="1371600" y="2660904"/>
+            <a:ext cx="6126480" cy="1024128"/>
           </a:xfrm>
           <a:prstGeom prst="rect">
             <a:avLst/>
@@ -3948,15 +3975,18 @@
           <a:lstStyle/>
           <a:p>
             <a:pPr indent="0" marL="0">
+              <a:lnSpc>
+                <a:spcPct val="115000"/>
+              </a:lnSpc>
               <a:spcAft>
-                <a:spcPts val="200"/>
+                <a:spcPts val="400"/>
               </a:spcAft>
               <a:buNone/>
             </a:pPr>
             <a:r>
               <a:rPr lang="en-US" sz="1700" b="1" dirty="0">
                 <a:solidFill>
-                  <a:schemeClr val="tx1"/>
+                  <a:srgbClr val="FFFFFF"/>
                 </a:solidFill>
               </a:rPr>
               <a:t>As seis áreas da etapa</a:t>
@@ -3965,15 +3995,15 @@
           </a:p>
           <a:p>
             <a:pPr indent="0" marL="0">
-              <a:spcAft>
-                <a:spcPts val="200"/>
-              </a:spcAft>
-              <a:buNone/>
-            </a:pPr>
-            <a:r>
-              <a:rPr lang="en-US" sz="1400" dirty="0">
-                <a:solidFill>
-                  <a:srgbClr val="44506A"/>
+              <a:lnSpc>
+                <a:spcPct val="115000"/>
+              </a:lnSpc>
+              <a:buNone/>
+            </a:pPr>
+            <a:r>
+              <a:rPr lang="en-US" sz="1500" dirty="0">
+                <a:solidFill>
+                  <a:srgbClr val="C9D6EE"/>
                 </a:solidFill>
               </a:rPr>
               <a:t>O trilho combinado em cada área e o seu estado.</a:t>
@@ -3990,18 +4020,18 @@
         </p:nvSpPr>
         <p:spPr>
           <a:xfrm>
-            <a:off x="548640" y="3557016"/>
+            <a:off x="548640" y="3794760"/>
             <a:ext cx="566928" cy="566928"/>
           </a:xfrm>
           <a:prstGeom prst="ellipse">
             <a:avLst/>
           </a:prstGeom>
           <a:solidFill>
-            <a:srgbClr val="1D4FA3"/>
+            <a:srgbClr val="2F6BD8"/>
           </a:solidFill>
           <a:ln w="12700">
             <a:solidFill>
-              <a:srgbClr val="1D4FA3"/>
+              <a:srgbClr val="2F6BD8"/>
             </a:solidFill>
             <a:prstDash val="solid"/>
           </a:ln>
@@ -4023,7 +4053,7 @@
         </p:blipFill>
         <p:spPr>
           <a:xfrm>
-            <a:off x="685800" y="3694176"/>
+            <a:off x="685800" y="3931920"/>
             <a:ext cx="292608" cy="292608"/>
           </a:xfrm>
           <a:prstGeom prst="rect">
@@ -4039,8 +4069,8 @@
         </p:nvSpPr>
         <p:spPr>
           <a:xfrm>
-            <a:off x="1325880" y="3520440"/>
-            <a:ext cx="6172200" cy="932688"/>
+            <a:off x="1371600" y="3758184"/>
+            <a:ext cx="6126480" cy="1024128"/>
           </a:xfrm>
           <a:prstGeom prst="rect">
             <a:avLst/>
@@ -4053,15 +4083,18 @@
           <a:lstStyle/>
           <a:p>
             <a:pPr indent="0" marL="0">
+              <a:lnSpc>
+                <a:spcPct val="115000"/>
+              </a:lnSpc>
               <a:spcAft>
-                <a:spcPts val="200"/>
+                <a:spcPts val="400"/>
               </a:spcAft>
               <a:buNone/>
             </a:pPr>
             <a:r>
               <a:rPr lang="en-US" sz="1700" b="1" dirty="0">
                 <a:solidFill>
-                  <a:schemeClr val="tx1"/>
+                  <a:srgbClr val="FFFFFF"/>
                 </a:solidFill>
               </a:rPr>
               <a:t>Validação da etapa</a:t>
@@ -4070,15 +4103,15 @@
           </a:p>
           <a:p>
             <a:pPr indent="0" marL="0">
-              <a:spcAft>
-                <a:spcPts val="200"/>
-              </a:spcAft>
-              <a:buNone/>
-            </a:pPr>
-            <a:r>
-              <a:rPr lang="en-US" sz="1400" dirty="0">
-                <a:solidFill>
-                  <a:srgbClr val="44506A"/>
+              <a:lnSpc>
+                <a:spcPct val="115000"/>
+              </a:lnSpc>
+              <a:buNone/>
+            </a:pPr>
+            <a:r>
+              <a:rPr lang="en-US" sz="1500" dirty="0">
+                <a:solidFill>
+                  <a:srgbClr val="C9D6EE"/>
                 </a:solidFill>
               </a:rPr>
               <a:t>Com um trilho validado em cada área, pedes a validação da etapa ao Conselho de Guias.</a:t>
@@ -4095,18 +4128,18 @@
         </p:nvSpPr>
         <p:spPr>
           <a:xfrm>
-            <a:off x="548640" y="4581144"/>
+            <a:off x="548640" y="4892040"/>
             <a:ext cx="566928" cy="566928"/>
           </a:xfrm>
           <a:prstGeom prst="ellipse">
             <a:avLst/>
           </a:prstGeom>
           <a:solidFill>
-            <a:srgbClr val="1D4FA3"/>
+            <a:srgbClr val="2F6BD8"/>
           </a:solidFill>
           <a:ln w="12700">
             <a:solidFill>
-              <a:srgbClr val="1D4FA3"/>
+              <a:srgbClr val="2F6BD8"/>
             </a:solidFill>
             <a:prstDash val="solid"/>
           </a:ln>
@@ -4128,7 +4161,7 @@
         </p:blipFill>
         <p:spPr>
           <a:xfrm>
-            <a:off x="685800" y="4718304"/>
+            <a:off x="685800" y="5029200"/>
             <a:ext cx="292608" cy="292608"/>
           </a:xfrm>
           <a:prstGeom prst="rect">
@@ -4144,8 +4177,8 @@
         </p:nvSpPr>
         <p:spPr>
           <a:xfrm>
-            <a:off x="1325880" y="4544568"/>
-            <a:ext cx="6172200" cy="932688"/>
+            <a:off x="1371600" y="4855464"/>
+            <a:ext cx="6126480" cy="1024128"/>
           </a:xfrm>
           <a:prstGeom prst="rect">
             <a:avLst/>
@@ -4158,15 +4191,18 @@
           <a:lstStyle/>
           <a:p>
             <a:pPr indent="0" marL="0">
+              <a:lnSpc>
+                <a:spcPct val="115000"/>
+              </a:lnSpc>
               <a:spcAft>
-                <a:spcPts val="200"/>
+                <a:spcPts val="400"/>
               </a:spcAft>
               <a:buNone/>
             </a:pPr>
             <a:r>
               <a:rPr lang="en-US" sz="1700" b="1" dirty="0">
                 <a:solidFill>
-                  <a:schemeClr val="tx1"/>
+                  <a:srgbClr val="FFFFFF"/>
                 </a:solidFill>
               </a:rPr>
               <a:t>Mapa do caminho</a:t>
@@ -4175,15 +4211,15 @@
           </a:p>
           <a:p>
             <a:pPr indent="0" marL="0">
-              <a:spcAft>
-                <a:spcPts val="200"/>
-              </a:spcAft>
-              <a:buNone/>
-            </a:pPr>
-            <a:r>
-              <a:rPr lang="en-US" sz="1400" dirty="0">
-                <a:solidFill>
-                  <a:srgbClr val="44506A"/>
+              <a:lnSpc>
+                <a:spcPct val="115000"/>
+              </a:lnSpc>
+              <a:buNone/>
+            </a:pPr>
+            <a:r>
+              <a:rPr lang="en-US" sz="1500" dirty="0">
+                <a:solidFill>
+                  <a:srgbClr val="C9D6EE"/>
                 </a:solidFill>
               </a:rPr>
               <a:t>Início de Pista › Promessa › Conhecimento › Vontade › Construção.</a:t>
@@ -4209,11 +4245,11 @@
             </a:avLst>
           </a:prstGeom>
           <a:solidFill>
-            <a:srgbClr val="14213D"/>
+            <a:srgbClr val="3A4D75"/>
           </a:solidFill>
           <a:ln w="12700">
             <a:solidFill>
-              <a:srgbClr val="14213D"/>
+              <a:srgbClr val="3A4D75"/>
             </a:solidFill>
             <a:prstDash val="solid"/>
           </a:ln>
@@ -4280,7 +4316,7 @@
             <a:lvl1pPr>
               <a:defRPr sz="1000">
                 <a:solidFill>
-                  <a:srgbClr val="6B7A90"/>
+                  <a:srgbClr val="8FA3C7"/>
                 </a:solidFill>
               </a:defRPr>
             </a:lvl1pPr>
@@ -4349,7 +4385,7 @@
             <a:r>
               <a:rPr lang="en-US" sz="3200" b="1" dirty="0">
                 <a:solidFill>
-                  <a:schemeClr val="tx1"/>
+                  <a:srgbClr val="FFFFFF"/>
                 </a:solidFill>
               </a:rPr>
               <a:t>O caminho da secção</a:t>
@@ -4385,7 +4421,7 @@
             <a:r>
               <a:rPr lang="en-US" sz="1700" dirty="0">
                 <a:solidFill>
-                  <a:srgbClr val="44506A"/>
+                  <a:srgbClr val="C9D6EE"/>
                 </a:solidFill>
               </a:rPr>
               <a:t>Um mapa com os marcos do caminho e quantos pioneiros estão em cada um.</a:t>
@@ -4409,11 +4445,11 @@
             <a:avLst/>
           </a:prstGeom>
           <a:solidFill>
-            <a:srgbClr val="1D4FA3"/>
+            <a:srgbClr val="2F6BD8"/>
           </a:solidFill>
           <a:ln w="12700">
             <a:solidFill>
-              <a:srgbClr val="1D4FA3"/>
+              <a:srgbClr val="2F6BD8"/>
             </a:solidFill>
             <a:prstDash val="solid"/>
           </a:ln>
@@ -4451,8 +4487,8 @@
         </p:nvSpPr>
         <p:spPr>
           <a:xfrm>
-            <a:off x="1325880" y="2432304"/>
-            <a:ext cx="6172200" cy="1097280"/>
+            <a:off x="1371600" y="2432304"/>
+            <a:ext cx="6126480" cy="1115568"/>
           </a:xfrm>
           <a:prstGeom prst="rect">
             <a:avLst/>
@@ -4465,15 +4501,18 @@
           <a:lstStyle/>
           <a:p>
             <a:pPr indent="0" marL="0">
+              <a:lnSpc>
+                <a:spcPct val="115000"/>
+              </a:lnSpc>
               <a:spcAft>
-                <a:spcPts val="200"/>
+                <a:spcPts val="400"/>
               </a:spcAft>
               <a:buNone/>
             </a:pPr>
             <a:r>
               <a:rPr lang="en-US" sz="1700" b="1" dirty="0">
                 <a:solidFill>
-                  <a:schemeClr val="tx1"/>
+                  <a:srgbClr val="FFFFFF"/>
                 </a:solidFill>
               </a:rPr>
               <a:t>Vês onde estás tu</a:t>
@@ -4482,15 +4521,15 @@
           </a:p>
           <a:p>
             <a:pPr indent="0" marL="0">
-              <a:spcAft>
-                <a:spcPts val="200"/>
-              </a:spcAft>
-              <a:buNone/>
-            </a:pPr>
-            <a:r>
-              <a:rPr lang="en-US" sz="1400" dirty="0">
-                <a:solidFill>
-                  <a:srgbClr val="44506A"/>
+              <a:lnSpc>
+                <a:spcPct val="115000"/>
+              </a:lnSpc>
+              <a:buNone/>
+            </a:pPr>
+            <a:r>
+              <a:rPr lang="en-US" sz="1500" dirty="0">
+                <a:solidFill>
+                  <a:srgbClr val="C9D6EE"/>
                 </a:solidFill>
               </a:rPr>
               <a:t>E, da tua equipa, onde está cada um.</a:t>
@@ -4514,11 +4553,11 @@
             <a:avLst/>
           </a:prstGeom>
           <a:solidFill>
-            <a:srgbClr val="1D4FA3"/>
+            <a:srgbClr val="2F6BD8"/>
           </a:solidFill>
           <a:ln w="12700">
             <a:solidFill>
-              <a:srgbClr val="1D4FA3"/>
+              <a:srgbClr val="2F6BD8"/>
             </a:solidFill>
             <a:prstDash val="solid"/>
           </a:ln>
@@ -4556,8 +4595,8 @@
         </p:nvSpPr>
         <p:spPr>
           <a:xfrm>
-            <a:off x="1325880" y="3621024"/>
-            <a:ext cx="6172200" cy="1097280"/>
+            <a:off x="1371600" y="3621024"/>
+            <a:ext cx="6126480" cy="1115568"/>
           </a:xfrm>
           <a:prstGeom prst="rect">
             <a:avLst/>
@@ -4570,15 +4609,18 @@
           <a:lstStyle/>
           <a:p>
             <a:pPr indent="0" marL="0">
+              <a:lnSpc>
+                <a:spcPct val="115000"/>
+              </a:lnSpc>
               <a:spcAft>
-                <a:spcPts val="200"/>
+                <a:spcPts val="400"/>
               </a:spcAft>
               <a:buNone/>
             </a:pPr>
             <a:r>
               <a:rPr lang="en-US" sz="1700" b="1" dirty="0">
                 <a:solidFill>
-                  <a:schemeClr val="tx1"/>
+                  <a:srgbClr val="FFFFFF"/>
                 </a:solidFill>
               </a:rPr>
               <a:t>Sem rankings</a:t>
@@ -4587,15 +4629,15 @@
           </a:p>
           <a:p>
             <a:pPr indent="0" marL="0">
-              <a:spcAft>
-                <a:spcPts val="200"/>
-              </a:spcAft>
-              <a:buNone/>
-            </a:pPr>
-            <a:r>
-              <a:rPr lang="en-US" sz="1400" dirty="0">
-                <a:solidFill>
-                  <a:srgbClr val="44506A"/>
+              <a:lnSpc>
+                <a:spcPct val="115000"/>
+              </a:lnSpc>
+              <a:buNone/>
+            </a:pPr>
+            <a:r>
+              <a:rPr lang="en-US" sz="1500" dirty="0">
+                <a:solidFill>
+                  <a:srgbClr val="C9D6EE"/>
                 </a:solidFill>
               </a:rPr>
               <a:t>Não há pontuações nem comparações: cada um faz o seu caminho.</a:t>
@@ -4621,11 +4663,11 @@
             </a:avLst>
           </a:prstGeom>
           <a:solidFill>
-            <a:srgbClr val="14213D"/>
+            <a:srgbClr val="3A4D75"/>
           </a:solidFill>
           <a:ln w="12700">
             <a:solidFill>
-              <a:srgbClr val="14213D"/>
+              <a:srgbClr val="3A4D75"/>
             </a:solidFill>
             <a:prstDash val="solid"/>
           </a:ln>
@@ -4692,7 +4734,7 @@
             <a:lvl1pPr>
               <a:defRPr sz="1000">
                 <a:solidFill>
-                  <a:srgbClr val="6B7A90"/>
+                  <a:srgbClr val="8FA3C7"/>
                 </a:solidFill>
               </a:defRPr>
             </a:lvl1pPr>
@@ -4761,7 +4803,7 @@
             <a:r>
               <a:rPr lang="en-US" sz="3200" b="1" dirty="0">
                 <a:solidFill>
-                  <a:schemeClr val="tx1"/>
+                  <a:srgbClr val="FFFFFF"/>
                 </a:solidFill>
               </a:rPr>
               <a:t>Consultar todos os trilhos</a:t>
@@ -4778,18 +4820,18 @@
         </p:nvSpPr>
         <p:spPr>
           <a:xfrm>
-            <a:off x="548640" y="1508760"/>
+            <a:off x="548640" y="1600200"/>
             <a:ext cx="566928" cy="566928"/>
           </a:xfrm>
           <a:prstGeom prst="ellipse">
             <a:avLst/>
           </a:prstGeom>
           <a:solidFill>
-            <a:srgbClr val="1D4FA3"/>
+            <a:srgbClr val="2F6BD8"/>
           </a:solidFill>
           <a:ln w="12700">
             <a:solidFill>
-              <a:srgbClr val="1D4FA3"/>
+              <a:srgbClr val="2F6BD8"/>
             </a:solidFill>
             <a:prstDash val="solid"/>
           </a:ln>
@@ -4811,7 +4853,7 @@
         </p:blipFill>
         <p:spPr>
           <a:xfrm>
-            <a:off x="685800" y="1645920"/>
+            <a:off x="685800" y="1737360"/>
             <a:ext cx="292608" cy="292608"/>
           </a:xfrm>
           <a:prstGeom prst="rect">
@@ -4827,8 +4869,8 @@
         </p:nvSpPr>
         <p:spPr>
           <a:xfrm>
-            <a:off x="1325880" y="1472184"/>
-            <a:ext cx="6172200" cy="1097280"/>
+            <a:off x="1371600" y="1563624"/>
+            <a:ext cx="6126480" cy="1115568"/>
           </a:xfrm>
           <a:prstGeom prst="rect">
             <a:avLst/>
@@ -4841,15 +4883,18 @@
           <a:lstStyle/>
           <a:p>
             <a:pPr indent="0" marL="0">
+              <a:lnSpc>
+                <a:spcPct val="115000"/>
+              </a:lnSpc>
               <a:spcAft>
-                <a:spcPts val="200"/>
+                <a:spcPts val="400"/>
               </a:spcAft>
               <a:buNone/>
             </a:pPr>
             <a:r>
               <a:rPr lang="en-US" sz="1700" b="1" dirty="0">
                 <a:solidFill>
-                  <a:schemeClr val="tx1"/>
+                  <a:srgbClr val="FFFFFF"/>
                 </a:solidFill>
               </a:rPr>
               <a:t>Árvore completa</a:t>
@@ -4858,15 +4903,15 @@
           </a:p>
           <a:p>
             <a:pPr indent="0" marL="0">
-              <a:spcAft>
-                <a:spcPts val="200"/>
-              </a:spcAft>
-              <a:buNone/>
-            </a:pPr>
-            <a:r>
-              <a:rPr lang="en-US" sz="1400" dirty="0">
-                <a:solidFill>
-                  <a:srgbClr val="44506A"/>
+              <a:lnSpc>
+                <a:spcPct val="115000"/>
+              </a:lnSpc>
+              <a:buNone/>
+            </a:pPr>
+            <a:r>
+              <a:rPr lang="en-US" sz="1500" dirty="0">
+                <a:solidFill>
+                  <a:srgbClr val="C9D6EE"/>
                 </a:solidFill>
               </a:rPr>
               <a:t>6 áreas › 18 trilhos › 38 objetivos, tal como no Manual.</a:t>
@@ -4883,18 +4928,18 @@
         </p:nvSpPr>
         <p:spPr>
           <a:xfrm>
-            <a:off x="548640" y="2697480"/>
+            <a:off x="548640" y="2788920"/>
             <a:ext cx="566928" cy="566928"/>
           </a:xfrm>
           <a:prstGeom prst="ellipse">
             <a:avLst/>
           </a:prstGeom>
           <a:solidFill>
-            <a:srgbClr val="1D4FA3"/>
+            <a:srgbClr val="2F6BD8"/>
           </a:solidFill>
           <a:ln w="12700">
             <a:solidFill>
-              <a:srgbClr val="1D4FA3"/>
+              <a:srgbClr val="2F6BD8"/>
             </a:solidFill>
             <a:prstDash val="solid"/>
           </a:ln>
@@ -4916,7 +4961,7 @@
         </p:blipFill>
         <p:spPr>
           <a:xfrm>
-            <a:off x="685800" y="2834640"/>
+            <a:off x="685800" y="2926080"/>
             <a:ext cx="292608" cy="292608"/>
           </a:xfrm>
           <a:prstGeom prst="rect">
@@ -4932,8 +4977,8 @@
         </p:nvSpPr>
         <p:spPr>
           <a:xfrm>
-            <a:off x="1325880" y="2660904"/>
-            <a:ext cx="6172200" cy="1097280"/>
+            <a:off x="1371600" y="2752344"/>
+            <a:ext cx="6126480" cy="1115568"/>
           </a:xfrm>
           <a:prstGeom prst="rect">
             <a:avLst/>
@@ -4946,15 +4991,18 @@
           <a:lstStyle/>
           <a:p>
             <a:pPr indent="0" marL="0">
+              <a:lnSpc>
+                <a:spcPct val="115000"/>
+              </a:lnSpc>
               <a:spcAft>
-                <a:spcPts val="200"/>
+                <a:spcPts val="400"/>
               </a:spcAft>
               <a:buNone/>
             </a:pPr>
             <a:r>
               <a:rPr lang="en-US" sz="1700" b="1" dirty="0">
                 <a:solidFill>
-                  <a:schemeClr val="tx1"/>
+                  <a:srgbClr val="FFFFFF"/>
                 </a:solidFill>
               </a:rPr>
               <a:t>Pesquisa</a:t>
@@ -4963,15 +5011,15 @@
           </a:p>
           <a:p>
             <a:pPr indent="0" marL="0">
-              <a:spcAft>
-                <a:spcPts val="200"/>
-              </a:spcAft>
-              <a:buNone/>
-            </a:pPr>
-            <a:r>
-              <a:rPr lang="en-US" sz="1400" dirty="0">
-                <a:solidFill>
-                  <a:srgbClr val="44506A"/>
+              <a:lnSpc>
+                <a:spcPct val="115000"/>
+              </a:lnSpc>
+              <a:buNone/>
+            </a:pPr>
+            <a:r>
+              <a:rPr lang="en-US" sz="1500" dirty="0">
+                <a:solidFill>
+                  <a:srgbClr val="C9D6EE"/>
                 </a:solidFill>
               </a:rPr>
               <a:t>Procura um trilho, um objetivo ou uma palavra-chave.</a:t>
@@ -4988,18 +5036,18 @@
         </p:nvSpPr>
         <p:spPr>
           <a:xfrm>
-            <a:off x="548640" y="3886200"/>
+            <a:off x="548640" y="3977640"/>
             <a:ext cx="566928" cy="566928"/>
           </a:xfrm>
           <a:prstGeom prst="ellipse">
             <a:avLst/>
           </a:prstGeom>
           <a:solidFill>
-            <a:srgbClr val="1D4FA3"/>
+            <a:srgbClr val="2F6BD8"/>
           </a:solidFill>
           <a:ln w="12700">
             <a:solidFill>
-              <a:srgbClr val="1D4FA3"/>
+              <a:srgbClr val="2F6BD8"/>
             </a:solidFill>
             <a:prstDash val="solid"/>
           </a:ln>
@@ -5021,7 +5069,7 @@
         </p:blipFill>
         <p:spPr>
           <a:xfrm>
-            <a:off x="685800" y="4023360"/>
+            <a:off x="685800" y="4114800"/>
             <a:ext cx="292608" cy="292608"/>
           </a:xfrm>
           <a:prstGeom prst="rect">
@@ -5037,8 +5085,8 @@
         </p:nvSpPr>
         <p:spPr>
           <a:xfrm>
-            <a:off x="1325880" y="3849624"/>
-            <a:ext cx="6172200" cy="1097280"/>
+            <a:off x="1371600" y="3941064"/>
+            <a:ext cx="6126480" cy="1115568"/>
           </a:xfrm>
           <a:prstGeom prst="rect">
             <a:avLst/>
@@ -5051,15 +5099,18 @@
           <a:lstStyle/>
           <a:p>
             <a:pPr indent="0" marL="0">
+              <a:lnSpc>
+                <a:spcPct val="115000"/>
+              </a:lnSpc>
               <a:spcAft>
-                <a:spcPts val="200"/>
+                <a:spcPts val="400"/>
               </a:spcAft>
               <a:buNone/>
             </a:pPr>
             <a:r>
               <a:rPr lang="en-US" sz="1700" b="1" dirty="0">
                 <a:solidFill>
-                  <a:schemeClr val="tx1"/>
+                  <a:srgbClr val="FFFFFF"/>
                 </a:solidFill>
               </a:rPr>
               <a:t>Exemplos</a:t>
@@ -5068,15 +5119,15 @@
           </a:p>
           <a:p>
             <a:pPr indent="0" marL="0">
-              <a:spcAft>
-                <a:spcPts val="200"/>
-              </a:spcAft>
-              <a:buNone/>
-            </a:pPr>
-            <a:r>
-              <a:rPr lang="en-US" sz="1400" dirty="0">
-                <a:solidFill>
-                  <a:srgbClr val="44506A"/>
+              <a:lnSpc>
+                <a:spcPct val="115000"/>
+              </a:lnSpc>
+              <a:buNone/>
+            </a:pPr>
+            <a:r>
+              <a:rPr lang="en-US" sz="1500" dirty="0">
+                <a:solidFill>
+                  <a:srgbClr val="C9D6EE"/>
                 </a:solidFill>
               </a:rPr>
               <a:t>Ideias de oportunidades educativas para cada trilho.</a:t>
@@ -5102,11 +5153,11 @@
             </a:avLst>
           </a:prstGeom>
           <a:solidFill>
-            <a:srgbClr val="14213D"/>
+            <a:srgbClr val="3A4D75"/>
           </a:solidFill>
           <a:ln w="12700">
             <a:solidFill>
-              <a:srgbClr val="14213D"/>
+              <a:srgbClr val="3A4D75"/>
             </a:solidFill>
             <a:prstDash val="solid"/>
           </a:ln>
@@ -5173,7 +5224,7 @@
             <a:lvl1pPr>
               <a:defRPr sz="1000">
                 <a:solidFill>
-                  <a:srgbClr val="6B7A90"/>
+                  <a:srgbClr val="8FA3C7"/>
                 </a:solidFill>
               </a:defRPr>
             </a:lvl1pPr>
@@ -5242,7 +5293,7 @@
             <a:r>
               <a:rPr lang="en-US" sz="3200" b="1" dirty="0">
                 <a:solidFill>
-                  <a:schemeClr val="tx1"/>
+                  <a:srgbClr val="FFFFFF"/>
                 </a:solidFill>
               </a:rPr>
               <a:t>Vivências: o teu diário</a:t>
@@ -5259,18 +5310,18 @@
         </p:nvSpPr>
         <p:spPr>
           <a:xfrm>
-            <a:off x="548640" y="1508760"/>
+            <a:off x="548640" y="1600200"/>
             <a:ext cx="566928" cy="566928"/>
           </a:xfrm>
           <a:prstGeom prst="ellipse">
             <a:avLst/>
           </a:prstGeom>
           <a:solidFill>
-            <a:srgbClr val="1D4FA3"/>
+            <a:srgbClr val="2F6BD8"/>
           </a:solidFill>
           <a:ln w="12700">
             <a:solidFill>
-              <a:srgbClr val="1D4FA3"/>
+              <a:srgbClr val="2F6BD8"/>
             </a:solidFill>
             <a:prstDash val="solid"/>
           </a:ln>
@@ -5292,7 +5343,7 @@
         </p:blipFill>
         <p:spPr>
           <a:xfrm>
-            <a:off x="685800" y="1645920"/>
+            <a:off x="685800" y="1737360"/>
             <a:ext cx="292608" cy="292608"/>
           </a:xfrm>
           <a:prstGeom prst="rect">
@@ -5308,8 +5359,8 @@
         </p:nvSpPr>
         <p:spPr>
           <a:xfrm>
-            <a:off x="1325880" y="1472184"/>
-            <a:ext cx="6172200" cy="1097280"/>
+            <a:off x="1371600" y="1563624"/>
+            <a:ext cx="6126480" cy="1115568"/>
           </a:xfrm>
           <a:prstGeom prst="rect">
             <a:avLst/>
@@ -5322,15 +5373,18 @@
           <a:lstStyle/>
           <a:p>
             <a:pPr indent="0" marL="0">
+              <a:lnSpc>
+                <a:spcPct val="115000"/>
+              </a:lnSpc>
               <a:spcAft>
-                <a:spcPts val="200"/>
+                <a:spcPts val="400"/>
               </a:spcAft>
               <a:buNone/>
             </a:pPr>
             <a:r>
               <a:rPr lang="en-US" sz="1700" b="1" dirty="0">
                 <a:solidFill>
-                  <a:schemeClr val="tx1"/>
+                  <a:srgbClr val="FFFFFF"/>
                 </a:solidFill>
               </a:rPr>
               <a:t>Regista o que viveste</a:t>
@@ -5339,15 +5393,15 @@
           </a:p>
           <a:p>
             <a:pPr indent="0" marL="0">
-              <a:spcAft>
-                <a:spcPts val="200"/>
-              </a:spcAft>
-              <a:buNone/>
-            </a:pPr>
-            <a:r>
-              <a:rPr lang="en-US" sz="1400" dirty="0">
-                <a:solidFill>
-                  <a:srgbClr val="44506A"/>
+              <a:lnSpc>
+                <a:spcPct val="115000"/>
+              </a:lnSpc>
+              <a:buNone/>
+            </a:pPr>
+            <a:r>
+              <a:rPr lang="en-US" sz="1500" dirty="0">
+                <a:solidFill>
+                  <a:srgbClr val="C9D6EE"/>
                 </a:solidFill>
               </a:rPr>
               <a:t>Atividades, momentos, reflexões — no escutismo, em casa ou na escola.</a:t>
@@ -5364,18 +5418,18 @@
         </p:nvSpPr>
         <p:spPr>
           <a:xfrm>
-            <a:off x="548640" y="2697480"/>
+            <a:off x="548640" y="2788920"/>
             <a:ext cx="566928" cy="566928"/>
           </a:xfrm>
           <a:prstGeom prst="ellipse">
             <a:avLst/>
           </a:prstGeom>
           <a:solidFill>
-            <a:srgbClr val="1D4FA3"/>
+            <a:srgbClr val="2F6BD8"/>
           </a:solidFill>
           <a:ln w="12700">
             <a:solidFill>
-              <a:srgbClr val="1D4FA3"/>
+              <a:srgbClr val="2F6BD8"/>
             </a:solidFill>
             <a:prstDash val="solid"/>
           </a:ln>
@@ -5397,7 +5451,7 @@
         </p:blipFill>
         <p:spPr>
           <a:xfrm>
-            <a:off x="685800" y="2834640"/>
+            <a:off x="685800" y="2926080"/>
             <a:ext cx="292608" cy="292608"/>
           </a:xfrm>
           <a:prstGeom prst="rect">
@@ -5413,8 +5467,8 @@
         </p:nvSpPr>
         <p:spPr>
           <a:xfrm>
-            <a:off x="1325880" y="2660904"/>
-            <a:ext cx="6172200" cy="1097280"/>
+            <a:off x="1371600" y="2752344"/>
+            <a:ext cx="6126480" cy="1115568"/>
           </a:xfrm>
           <a:prstGeom prst="rect">
             <a:avLst/>
@@ -5427,15 +5481,18 @@
           <a:lstStyle/>
           <a:p>
             <a:pPr indent="0" marL="0">
+              <a:lnSpc>
+                <a:spcPct val="115000"/>
+              </a:lnSpc>
               <a:spcAft>
-                <a:spcPts val="200"/>
+                <a:spcPts val="400"/>
               </a:spcAft>
               <a:buNone/>
             </a:pPr>
             <a:r>
               <a:rPr lang="en-US" sz="1700" b="1" dirty="0">
                 <a:solidFill>
-                  <a:schemeClr val="tx1"/>
+                  <a:srgbClr val="FFFFFF"/>
                 </a:solidFill>
               </a:rPr>
               <a:t>Só tu vês</a:t>
@@ -5444,15 +5501,15 @@
           </a:p>
           <a:p>
             <a:pPr indent="0" marL="0">
-              <a:spcAft>
-                <a:spcPts val="200"/>
-              </a:spcAft>
-              <a:buNone/>
-            </a:pPr>
-            <a:r>
-              <a:rPr lang="en-US" sz="1400" dirty="0">
-                <a:solidFill>
-                  <a:srgbClr val="44506A"/>
+              <a:lnSpc>
+                <a:spcPct val="115000"/>
+              </a:lnSpc>
+              <a:buNone/>
+            </a:pPr>
+            <a:r>
+              <a:rPr lang="en-US" sz="1500" dirty="0">
+                <a:solidFill>
+                  <a:srgbClr val="C9D6EE"/>
                 </a:solidFill>
               </a:rPr>
               <a:t>É um diário pessoal para te ajudar a preparar os pedidos.</a:t>
@@ -5469,18 +5526,18 @@
         </p:nvSpPr>
         <p:spPr>
           <a:xfrm>
-            <a:off x="548640" y="3886200"/>
+            <a:off x="548640" y="3977640"/>
             <a:ext cx="566928" cy="566928"/>
           </a:xfrm>
           <a:prstGeom prst="ellipse">
             <a:avLst/>
           </a:prstGeom>
           <a:solidFill>
-            <a:srgbClr val="1D4FA3"/>
+            <a:srgbClr val="2F6BD8"/>
           </a:solidFill>
           <a:ln w="12700">
             <a:solidFill>
-              <a:srgbClr val="1D4FA3"/>
+              <a:srgbClr val="2F6BD8"/>
             </a:solidFill>
             <a:prstDash val="solid"/>
           </a:ln>
@@ -5502,7 +5559,7 @@
         </p:blipFill>
         <p:spPr>
           <a:xfrm>
-            <a:off x="685800" y="4023360"/>
+            <a:off x="685800" y="4114800"/>
             <a:ext cx="292608" cy="292608"/>
           </a:xfrm>
           <a:prstGeom prst="rect">
@@ -5518,8 +5575,8 @@
         </p:nvSpPr>
         <p:spPr>
           <a:xfrm>
-            <a:off x="1325880" y="3849624"/>
-            <a:ext cx="6172200" cy="1097280"/>
+            <a:off x="1371600" y="3941064"/>
+            <a:ext cx="6126480" cy="1115568"/>
           </a:xfrm>
           <a:prstGeom prst="rect">
             <a:avLst/>
@@ -5532,15 +5589,18 @@
           <a:lstStyle/>
           <a:p>
             <a:pPr indent="0" marL="0">
+              <a:lnSpc>
+                <a:spcPct val="115000"/>
+              </a:lnSpc>
               <a:spcAft>
-                <a:spcPts val="200"/>
+                <a:spcPts val="400"/>
               </a:spcAft>
               <a:buNone/>
             </a:pPr>
             <a:r>
               <a:rPr lang="en-US" sz="1700" b="1" dirty="0">
                 <a:solidFill>
-                  <a:schemeClr val="tx1"/>
+                  <a:srgbClr val="FFFFFF"/>
                 </a:solidFill>
               </a:rPr>
               <a:t>Opcional</a:t>
@@ -5549,15 +5609,15 @@
           </a:p>
           <a:p>
             <a:pPr indent="0" marL="0">
-              <a:spcAft>
-                <a:spcPts val="200"/>
-              </a:spcAft>
-              <a:buNone/>
-            </a:pPr>
-            <a:r>
-              <a:rPr lang="en-US" sz="1400" dirty="0">
-                <a:solidFill>
-                  <a:srgbClr val="44506A"/>
+              <a:lnSpc>
+                <a:spcPct val="115000"/>
+              </a:lnSpc>
+              <a:buNone/>
+            </a:pPr>
+            <a:r>
+              <a:rPr lang="en-US" sz="1500" dirty="0">
+                <a:solidFill>
+                  <a:srgbClr val="C9D6EE"/>
                 </a:solidFill>
               </a:rPr>
               <a:t>Não é preciso registar vivências para pedir a validação.</a:t>
@@ -5583,11 +5643,11 @@
             </a:avLst>
           </a:prstGeom>
           <a:solidFill>
-            <a:srgbClr val="14213D"/>
+            <a:srgbClr val="3A4D75"/>
           </a:solidFill>
           <a:ln w="12700">
             <a:solidFill>
-              <a:srgbClr val="14213D"/>
+              <a:srgbClr val="3A4D75"/>
             </a:solidFill>
             <a:prstDash val="solid"/>
           </a:ln>
@@ -5654,7 +5714,7 @@
             <a:lvl1pPr>
               <a:defRPr sz="1000">
                 <a:solidFill>
-                  <a:srgbClr val="6B7A90"/>
+                  <a:srgbClr val="8FA3C7"/>
                 </a:solidFill>
               </a:defRPr>
             </a:lvl1pPr>
@@ -5723,7 +5783,7 @@
             <a:r>
               <a:rPr lang="en-US" sz="3200" b="1" dirty="0">
                 <a:solidFill>
-                  <a:schemeClr val="tx1"/>
+                  <a:srgbClr val="FFFFFF"/>
                 </a:solidFill>
               </a:rPr>
               <a:t>Notificações e perfil</a:t>
@@ -5740,7 +5800,7 @@
         </p:nvSpPr>
         <p:spPr>
           <a:xfrm>
-            <a:off x="548640" y="1508760"/>
+            <a:off x="548640" y="1600200"/>
             <a:ext cx="5669280" cy="4389120"/>
           </a:xfrm>
           <a:prstGeom prst="rect">
@@ -5754,12 +5814,15 @@
           <a:lstStyle/>
           <a:p>
             <a:pPr indent="0" marL="0">
+              <a:lnSpc>
+                <a:spcPct val="120000"/>
+              </a:lnSpc>
               <a:buNone/>
             </a:pPr>
             <a:r>
               <a:rPr lang="en-US" sz="1800" b="1" dirty="0">
                 <a:solidFill>
-                  <a:schemeClr val="tx1"/>
+                  <a:srgbClr val="FFFFFF"/>
                 </a:solidFill>
               </a:rPr>
               <a:t>Ativa as notificações</a:t>
@@ -5768,12 +5831,15 @@
           </a:p>
           <a:p>
             <a:pPr indent="0" marL="0">
+              <a:lnSpc>
+                <a:spcPct val="120000"/>
+              </a:lnSpc>
               <a:buNone/>
             </a:pPr>
             <a:r>
               <a:rPr lang="en-US" sz="1500" dirty="0">
                 <a:solidFill>
-                  <a:srgbClr val="44506A"/>
+                  <a:srgbClr val="C9D6EE"/>
                 </a:solidFill>
               </a:rPr>
               <a:t>Perfil › Notificações no telemóvel › Ativar. No iPhone, abre a app pelo ícone do ecrã principal.</a:t>
@@ -5782,10 +5848,13 @@
           </a:p>
           <a:p>
             <a:pPr indent="0" marL="0">
-              <a:buNone/>
-            </a:pPr>
-            <a:r>
-              <a:rPr lang="en-US" sz="1000" dirty="0">
+              <a:lnSpc>
+                <a:spcPct val="120000"/>
+              </a:lnSpc>
+              <a:buNone/>
+            </a:pPr>
+            <a:r>
+              <a:rPr lang="en-US" sz="1600" dirty="0">
                 <a:solidFill>
                   <a:srgbClr val="000000"/>
                 </a:solidFill>
@@ -5796,12 +5865,15 @@
           </a:p>
           <a:p>
             <a:pPr indent="0" marL="0">
+              <a:lnSpc>
+                <a:spcPct val="120000"/>
+              </a:lnSpc>
               <a:buNone/>
             </a:pPr>
             <a:r>
               <a:rPr lang="en-US" sz="1800" b="1" dirty="0">
                 <a:solidFill>
-                  <a:schemeClr val="tx1"/>
+                  <a:srgbClr val="FFFFFF"/>
                 </a:solidFill>
               </a:rPr>
               <a:t>O sino</a:t>
@@ -5810,12 +5882,15 @@
           </a:p>
           <a:p>
             <a:pPr indent="0" marL="0">
+              <a:lnSpc>
+                <a:spcPct val="120000"/>
+              </a:lnSpc>
               <a:buNone/>
             </a:pPr>
             <a:r>
               <a:rPr lang="en-US" sz="1500" dirty="0">
                 <a:solidFill>
-                  <a:srgbClr val="44506A"/>
+                  <a:srgbClr val="C9D6EE"/>
                 </a:solidFill>
               </a:rPr>
               <a:t>Todas as notificações ficam também no sino, no topo da app.</a:t>
@@ -5824,10 +5899,13 @@
           </a:p>
           <a:p>
             <a:pPr indent="0" marL="0">
-              <a:buNone/>
-            </a:pPr>
-            <a:r>
-              <a:rPr lang="en-US" sz="1000" dirty="0">
+              <a:lnSpc>
+                <a:spcPct val="120000"/>
+              </a:lnSpc>
+              <a:buNone/>
+            </a:pPr>
+            <a:r>
+              <a:rPr lang="en-US" sz="1600" dirty="0">
                 <a:solidFill>
                   <a:srgbClr val="000000"/>
                 </a:solidFill>
@@ -5838,12 +5916,15 @@
           </a:p>
           <a:p>
             <a:pPr indent="0" marL="0">
+              <a:lnSpc>
+                <a:spcPct val="120000"/>
+              </a:lnSpc>
               <a:buNone/>
             </a:pPr>
             <a:r>
               <a:rPr lang="en-US" sz="1800" b="1" dirty="0">
                 <a:solidFill>
-                  <a:schemeClr val="tx1"/>
+                  <a:srgbClr val="FFFFFF"/>
                 </a:solidFill>
               </a:rPr>
               <a:t>Perfil</a:t>
@@ -5852,12 +5933,15 @@
           </a:p>
           <a:p>
             <a:pPr indent="0" marL="0">
+              <a:lnSpc>
+                <a:spcPct val="120000"/>
+              </a:lnSpc>
               <a:buNone/>
             </a:pPr>
             <a:r>
               <a:rPr lang="en-US" sz="1500" dirty="0">
                 <a:solidFill>
-                  <a:srgbClr val="44506A"/>
+                  <a:srgbClr val="C9D6EE"/>
                 </a:solidFill>
               </a:rPr>
               <a:t>Nome, totem e fotografia (opcional, só vista pela tua equipa e dirigentes).</a:t>
@@ -5883,11 +5967,11 @@
             </a:avLst>
           </a:prstGeom>
           <a:solidFill>
-            <a:srgbClr val="14213D"/>
+            <a:srgbClr val="3A4D75"/>
           </a:solidFill>
           <a:ln w="12700">
             <a:solidFill>
-              <a:srgbClr val="14213D"/>
+              <a:srgbClr val="3A4D75"/>
             </a:solidFill>
             <a:prstDash val="solid"/>
           </a:ln>
@@ -5941,11 +6025,11 @@
             </a:avLst>
           </a:prstGeom>
           <a:solidFill>
-            <a:srgbClr val="14213D"/>
+            <a:srgbClr val="3A4D75"/>
           </a:solidFill>
           <a:ln w="12700">
             <a:solidFill>
-              <a:srgbClr val="14213D"/>
+              <a:srgbClr val="3A4D75"/>
             </a:solidFill>
             <a:prstDash val="solid"/>
           </a:ln>
@@ -6012,7 +6096,7 @@
             <a:lvl1pPr>
               <a:defRPr sz="1000">
                 <a:solidFill>
-                  <a:srgbClr val="6B7A90"/>
+                  <a:srgbClr val="8FA3C7"/>
                 </a:solidFill>
               </a:defRPr>
             </a:lvl1pPr>
@@ -6136,7 +6220,7 @@
         </p:nvSpPr>
         <p:spPr>
           <a:xfrm>
-            <a:off x="731520" y="4846320"/>
+            <a:off x="731520" y="5212080"/>
             <a:ext cx="822960" cy="822960"/>
           </a:xfrm>
           <a:prstGeom prst="ellipse">
@@ -6169,7 +6253,7 @@
         </p:blipFill>
         <p:spPr>
           <a:xfrm>
-            <a:off x="932688" y="5047488"/>
+            <a:off x="932688" y="5413248"/>
             <a:ext cx="420624" cy="420624"/>
           </a:xfrm>
           <a:prstGeom prst="rect">
@@ -6185,7 +6269,7 @@
         </p:nvSpPr>
         <p:spPr>
           <a:xfrm>
-            <a:off x="365760" y="5760720"/>
+            <a:off x="365760" y="6126480"/>
             <a:ext cx="1554480" cy="365760"/>
           </a:xfrm>
           <a:prstGeom prst="rect">
@@ -6221,7 +6305,7 @@
         </p:nvSpPr>
         <p:spPr>
           <a:xfrm>
-            <a:off x="2880360" y="4846320"/>
+            <a:off x="2880360" y="5212080"/>
             <a:ext cx="822960" cy="822960"/>
           </a:xfrm>
           <a:prstGeom prst="ellipse">
@@ -6254,7 +6338,7 @@
         </p:blipFill>
         <p:spPr>
           <a:xfrm>
-            <a:off x="3081528" y="5047488"/>
+            <a:off x="3081528" y="5413248"/>
             <a:ext cx="420624" cy="420624"/>
           </a:xfrm>
           <a:prstGeom prst="rect">
@@ -6270,7 +6354,7 @@
         </p:nvSpPr>
         <p:spPr>
           <a:xfrm>
-            <a:off x="2514600" y="5760720"/>
+            <a:off x="2514600" y="6126480"/>
             <a:ext cx="1554480" cy="365760"/>
           </a:xfrm>
           <a:prstGeom prst="rect">
@@ -6306,7 +6390,7 @@
         </p:nvSpPr>
         <p:spPr>
           <a:xfrm>
-            <a:off x="5029200" y="4846320"/>
+            <a:off x="5029200" y="5212080"/>
             <a:ext cx="822960" cy="822960"/>
           </a:xfrm>
           <a:prstGeom prst="ellipse">
@@ -6339,7 +6423,7 @@
         </p:blipFill>
         <p:spPr>
           <a:xfrm>
-            <a:off x="5230368" y="5047488"/>
+            <a:off x="5230368" y="5413248"/>
             <a:ext cx="420624" cy="420624"/>
           </a:xfrm>
           <a:prstGeom prst="rect">
@@ -6355,7 +6439,7 @@
         </p:nvSpPr>
         <p:spPr>
           <a:xfrm>
-            <a:off x="4663440" y="5760720"/>
+            <a:off x="4663440" y="6126480"/>
             <a:ext cx="1554480" cy="365760"/>
           </a:xfrm>
           <a:prstGeom prst="rect">
@@ -6391,7 +6475,7 @@
         </p:nvSpPr>
         <p:spPr>
           <a:xfrm>
-            <a:off x="7178040" y="4846320"/>
+            <a:off x="7178040" y="5212080"/>
             <a:ext cx="822960" cy="822960"/>
           </a:xfrm>
           <a:prstGeom prst="ellipse">
@@ -6424,7 +6508,7 @@
         </p:blipFill>
         <p:spPr>
           <a:xfrm>
-            <a:off x="7379208" y="5047488"/>
+            <a:off x="7379208" y="5413248"/>
             <a:ext cx="420624" cy="420624"/>
           </a:xfrm>
           <a:prstGeom prst="rect">
@@ -6440,7 +6524,7 @@
         </p:nvSpPr>
         <p:spPr>
           <a:xfrm>
-            <a:off x="6812280" y="5760720"/>
+            <a:off x="6812280" y="6126480"/>
             <a:ext cx="1554480" cy="365760"/>
           </a:xfrm>
           <a:prstGeom prst="rect">
@@ -6476,7 +6560,7 @@
         </p:nvSpPr>
         <p:spPr>
           <a:xfrm>
-            <a:off x="9326880" y="4846320"/>
+            <a:off x="9326880" y="5212080"/>
             <a:ext cx="822960" cy="822960"/>
           </a:xfrm>
           <a:prstGeom prst="ellipse">
@@ -6509,7 +6593,7 @@
         </p:blipFill>
         <p:spPr>
           <a:xfrm>
-            <a:off x="9528048" y="5047488"/>
+            <a:off x="9528048" y="5413248"/>
             <a:ext cx="420624" cy="420624"/>
           </a:xfrm>
           <a:prstGeom prst="rect">
@@ -6525,7 +6609,7 @@
         </p:nvSpPr>
         <p:spPr>
           <a:xfrm>
-            <a:off x="8961120" y="5760720"/>
+            <a:off x="8961120" y="6126480"/>
             <a:ext cx="1554480" cy="365760"/>
           </a:xfrm>
           <a:prstGeom prst="rect">
@@ -6561,7 +6645,7 @@
         </p:nvSpPr>
         <p:spPr>
           <a:xfrm>
-            <a:off x="731520" y="4434840"/>
+            <a:off x="731520" y="4617720"/>
             <a:ext cx="10058400" cy="320040"/>
           </a:xfrm>
           <a:prstGeom prst="rect">
@@ -6643,7 +6727,7 @@
             <a:r>
               <a:rPr lang="en-US" sz="3200" b="1" dirty="0">
                 <a:solidFill>
-                  <a:schemeClr val="tx1"/>
+                  <a:srgbClr val="FFFFFF"/>
                 </a:solidFill>
               </a:rPr>
               <a:t>Para que serve</a:t>
@@ -6660,18 +6744,18 @@
         </p:nvSpPr>
         <p:spPr>
           <a:xfrm>
-            <a:off x="548640" y="1508760"/>
+            <a:off x="548640" y="1600200"/>
             <a:ext cx="566928" cy="566928"/>
           </a:xfrm>
           <a:prstGeom prst="ellipse">
             <a:avLst/>
           </a:prstGeom>
           <a:solidFill>
-            <a:srgbClr val="1D4FA3"/>
+            <a:srgbClr val="2F6BD8"/>
           </a:solidFill>
           <a:ln w="12700">
             <a:solidFill>
-              <a:srgbClr val="1D4FA3"/>
+              <a:srgbClr val="2F6BD8"/>
             </a:solidFill>
             <a:prstDash val="solid"/>
           </a:ln>
@@ -6693,7 +6777,7 @@
         </p:blipFill>
         <p:spPr>
           <a:xfrm>
-            <a:off x="685800" y="1645920"/>
+            <a:off x="685800" y="1737360"/>
             <a:ext cx="292608" cy="292608"/>
           </a:xfrm>
           <a:prstGeom prst="rect">
@@ -6709,8 +6793,8 @@
         </p:nvSpPr>
         <p:spPr>
           <a:xfrm>
-            <a:off x="1325880" y="1472184"/>
-            <a:ext cx="6172200" cy="932688"/>
+            <a:off x="1371600" y="1563624"/>
+            <a:ext cx="6126480" cy="1024128"/>
           </a:xfrm>
           <a:prstGeom prst="rect">
             <a:avLst/>
@@ -6723,15 +6807,18 @@
           <a:lstStyle/>
           <a:p>
             <a:pPr indent="0" marL="0">
+              <a:lnSpc>
+                <a:spcPct val="115000"/>
+              </a:lnSpc>
               <a:spcAft>
-                <a:spcPts val="200"/>
+                <a:spcPts val="400"/>
               </a:spcAft>
               <a:buNone/>
             </a:pPr>
             <a:r>
               <a:rPr lang="en-US" sz="1700" b="1" dirty="0">
                 <a:solidFill>
-                  <a:schemeClr val="tx1"/>
+                  <a:srgbClr val="FFFFFF"/>
                 </a:solidFill>
               </a:rPr>
               <a:t>Ver o teu progresso</a:t>
@@ -6740,15 +6827,15 @@
           </a:p>
           <a:p>
             <a:pPr indent="0" marL="0">
-              <a:spcAft>
-                <a:spcPts val="200"/>
-              </a:spcAft>
-              <a:buNone/>
-            </a:pPr>
-            <a:r>
-              <a:rPr lang="en-US" sz="1400" dirty="0">
-                <a:solidFill>
-                  <a:srgbClr val="44506A"/>
+              <a:lnSpc>
+                <a:spcPct val="115000"/>
+              </a:lnSpc>
+              <a:buNone/>
+            </a:pPr>
+            <a:r>
+              <a:rPr lang="en-US" sz="1500" dirty="0">
+                <a:solidFill>
+                  <a:srgbClr val="C9D6EE"/>
                 </a:solidFill>
               </a:rPr>
               <a:t>As seis áreas FACEIS, os trilhos e a etapa em que estás.</a:t>
@@ -6765,18 +6852,18 @@
         </p:nvSpPr>
         <p:spPr>
           <a:xfrm>
-            <a:off x="548640" y="2532888"/>
+            <a:off x="548640" y="2697480"/>
             <a:ext cx="566928" cy="566928"/>
           </a:xfrm>
           <a:prstGeom prst="ellipse">
             <a:avLst/>
           </a:prstGeom>
           <a:solidFill>
-            <a:srgbClr val="1D4FA3"/>
+            <a:srgbClr val="2F6BD8"/>
           </a:solidFill>
           <a:ln w="12700">
             <a:solidFill>
-              <a:srgbClr val="1D4FA3"/>
+              <a:srgbClr val="2F6BD8"/>
             </a:solidFill>
             <a:prstDash val="solid"/>
           </a:ln>
@@ -6798,7 +6885,7 @@
         </p:blipFill>
         <p:spPr>
           <a:xfrm>
-            <a:off x="685800" y="2670048"/>
+            <a:off x="685800" y="2834640"/>
             <a:ext cx="292608" cy="292608"/>
           </a:xfrm>
           <a:prstGeom prst="rect">
@@ -6814,8 +6901,8 @@
         </p:nvSpPr>
         <p:spPr>
           <a:xfrm>
-            <a:off x="1325880" y="2496312"/>
-            <a:ext cx="6172200" cy="932688"/>
+            <a:off x="1371600" y="2660904"/>
+            <a:ext cx="6126480" cy="1024128"/>
           </a:xfrm>
           <a:prstGeom prst="rect">
             <a:avLst/>
@@ -6828,15 +6915,18 @@
           <a:lstStyle/>
           <a:p>
             <a:pPr indent="0" marL="0">
+              <a:lnSpc>
+                <a:spcPct val="115000"/>
+              </a:lnSpc>
               <a:spcAft>
-                <a:spcPts val="200"/>
+                <a:spcPts val="400"/>
               </a:spcAft>
               <a:buNone/>
             </a:pPr>
             <a:r>
               <a:rPr lang="en-US" sz="1700" b="1" dirty="0">
                 <a:solidFill>
-                  <a:schemeClr val="tx1"/>
+                  <a:srgbClr val="FFFFFF"/>
                 </a:solidFill>
               </a:rPr>
               <a:t>Dizer em que trilho queres trabalhar</a:t>
@@ -6845,15 +6935,15 @@
           </a:p>
           <a:p>
             <a:pPr indent="0" marL="0">
-              <a:spcAft>
-                <a:spcPts val="200"/>
-              </a:spcAft>
-              <a:buNone/>
-            </a:pPr>
-            <a:r>
-              <a:rPr lang="en-US" sz="1400" dirty="0">
-                <a:solidFill>
-                  <a:srgbClr val="44506A"/>
+              <a:lnSpc>
+                <a:spcPct val="115000"/>
+              </a:lnSpc>
+              <a:buNone/>
+            </a:pPr>
+            <a:r>
+              <a:rPr lang="en-US" sz="1500" dirty="0">
+                <a:solidFill>
+                  <a:srgbClr val="C9D6EE"/>
                 </a:solidFill>
               </a:rPr>
               <a:t>Propões à Equipa de Animação e combinam contigo.</a:t>
@@ -6870,18 +6960,18 @@
         </p:nvSpPr>
         <p:spPr>
           <a:xfrm>
-            <a:off x="548640" y="3557016"/>
+            <a:off x="548640" y="3794760"/>
             <a:ext cx="566928" cy="566928"/>
           </a:xfrm>
           <a:prstGeom prst="ellipse">
             <a:avLst/>
           </a:prstGeom>
           <a:solidFill>
-            <a:srgbClr val="1D4FA3"/>
+            <a:srgbClr val="2F6BD8"/>
           </a:solidFill>
           <a:ln w="12700">
             <a:solidFill>
-              <a:srgbClr val="1D4FA3"/>
+              <a:srgbClr val="2F6BD8"/>
             </a:solidFill>
             <a:prstDash val="solid"/>
           </a:ln>
@@ -6903,7 +6993,7 @@
         </p:blipFill>
         <p:spPr>
           <a:xfrm>
-            <a:off x="685800" y="3694176"/>
+            <a:off x="685800" y="3931920"/>
             <a:ext cx="292608" cy="292608"/>
           </a:xfrm>
           <a:prstGeom prst="rect">
@@ -6919,8 +7009,8 @@
         </p:nvSpPr>
         <p:spPr>
           <a:xfrm>
-            <a:off x="1325880" y="3520440"/>
-            <a:ext cx="6172200" cy="932688"/>
+            <a:off x="1371600" y="3758184"/>
+            <a:ext cx="6126480" cy="1024128"/>
           </a:xfrm>
           <a:prstGeom prst="rect">
             <a:avLst/>
@@ -6933,15 +7023,18 @@
           <a:lstStyle/>
           <a:p>
             <a:pPr indent="0" marL="0">
+              <a:lnSpc>
+                <a:spcPct val="115000"/>
+              </a:lnSpc>
               <a:spcAft>
-                <a:spcPts val="200"/>
+                <a:spcPts val="400"/>
               </a:spcAft>
               <a:buNone/>
             </a:pPr>
             <a:r>
               <a:rPr lang="en-US" sz="1700" b="1" dirty="0">
                 <a:solidFill>
-                  <a:schemeClr val="tx1"/>
+                  <a:srgbClr val="FFFFFF"/>
                 </a:solidFill>
               </a:rPr>
               <a:t>Pedir para fechar um trilho</a:t>
@@ -6950,15 +7043,15 @@
           </a:p>
           <a:p>
             <a:pPr indent="0" marL="0">
-              <a:spcAft>
-                <a:spcPts val="200"/>
-              </a:spcAft>
-              <a:buNone/>
-            </a:pPr>
-            <a:r>
-              <a:rPr lang="en-US" sz="1400" dirty="0">
-                <a:solidFill>
-                  <a:srgbClr val="44506A"/>
+              <a:lnSpc>
+                <a:spcPct val="115000"/>
+              </a:lnSpc>
+              <a:buNone/>
+            </a:pPr>
+            <a:r>
+              <a:rPr lang="en-US" sz="1500" dirty="0">
+                <a:solidFill>
+                  <a:srgbClr val="C9D6EE"/>
                 </a:solidFill>
               </a:rPr>
               <a:t>Explicas como atingiste os objetivos; a reunião de Equipa decide.</a:t>
@@ -6975,18 +7068,18 @@
         </p:nvSpPr>
         <p:spPr>
           <a:xfrm>
-            <a:off x="548640" y="4581144"/>
+            <a:off x="548640" y="4892040"/>
             <a:ext cx="566928" cy="566928"/>
           </a:xfrm>
           <a:prstGeom prst="ellipse">
             <a:avLst/>
           </a:prstGeom>
           <a:solidFill>
-            <a:srgbClr val="1D4FA3"/>
+            <a:srgbClr val="2F6BD8"/>
           </a:solidFill>
           <a:ln w="12700">
             <a:solidFill>
-              <a:srgbClr val="1D4FA3"/>
+              <a:srgbClr val="2F6BD8"/>
             </a:solidFill>
             <a:prstDash val="solid"/>
           </a:ln>
@@ -7008,7 +7101,7 @@
         </p:blipFill>
         <p:spPr>
           <a:xfrm>
-            <a:off x="685800" y="4718304"/>
+            <a:off x="685800" y="5029200"/>
             <a:ext cx="292608" cy="292608"/>
           </a:xfrm>
           <a:prstGeom prst="rect">
@@ -7024,8 +7117,8 @@
         </p:nvSpPr>
         <p:spPr>
           <a:xfrm>
-            <a:off x="1325880" y="4544568"/>
-            <a:ext cx="6172200" cy="932688"/>
+            <a:off x="1371600" y="4855464"/>
+            <a:ext cx="6126480" cy="1024128"/>
           </a:xfrm>
           <a:prstGeom prst="rect">
             <a:avLst/>
@@ -7038,15 +7131,18 @@
           <a:lstStyle/>
           <a:p>
             <a:pPr indent="0" marL="0">
+              <a:lnSpc>
+                <a:spcPct val="115000"/>
+              </a:lnSpc>
               <a:spcAft>
-                <a:spcPts val="200"/>
+                <a:spcPts val="400"/>
               </a:spcAft>
               <a:buNone/>
             </a:pPr>
             <a:r>
               <a:rPr lang="en-US" sz="1700" b="1" dirty="0">
                 <a:solidFill>
-                  <a:schemeClr val="tx1"/>
+                  <a:srgbClr val="FFFFFF"/>
                 </a:solidFill>
               </a:rPr>
               <a:t>Saber o que mudou</a:t>
@@ -7055,15 +7151,15 @@
           </a:p>
           <a:p>
             <a:pPr indent="0" marL="0">
-              <a:spcAft>
-                <a:spcPts val="200"/>
-              </a:spcAft>
-              <a:buNone/>
-            </a:pPr>
-            <a:r>
-              <a:rPr lang="en-US" sz="1400" dirty="0">
-                <a:solidFill>
-                  <a:srgbClr val="44506A"/>
+              <a:lnSpc>
+                <a:spcPct val="115000"/>
+              </a:lnSpc>
+              <a:buNone/>
+            </a:pPr>
+            <a:r>
+              <a:rPr lang="en-US" sz="1500" dirty="0">
+                <a:solidFill>
+                  <a:srgbClr val="C9D6EE"/>
                 </a:solidFill>
               </a:rPr>
               <a:t>Notificações quando há respostas, decisões ou algo a rever.</a:t>
@@ -7089,11 +7185,11 @@
             </a:avLst>
           </a:prstGeom>
           <a:solidFill>
-            <a:srgbClr val="EEF3FA"/>
+            <a:srgbClr val="1B2A4A"/>
           </a:solidFill>
           <a:ln w="12700">
             <a:solidFill>
-              <a:srgbClr val="EEF3FA"/>
+              <a:srgbClr val="2C3E63"/>
             </a:solidFill>
             <a:prstDash val="solid"/>
           </a:ln>
@@ -7126,7 +7222,7 @@
             <a:r>
               <a:rPr lang="en-US" sz="7200" b="1" dirty="0">
                 <a:solidFill>
-                  <a:schemeClr val="accent1"/>
+                  <a:srgbClr val="8DB4FF"/>
                 </a:solidFill>
               </a:rPr>
               <a:t>6</a:t>
@@ -7162,10 +7258,10 @@
             <a:r>
               <a:rPr lang="en-US" sz="1800" dirty="0">
                 <a:solidFill>
-                  <a:schemeClr val="tx1"/>
-                </a:solidFill>
-              </a:rPr>
-              <a:t>áreas FACEIS</a:t>
+                  <a:srgbClr val="FFFFFF"/>
+                </a:solidFill>
+              </a:rPr>
+              <a:t>Áreas FACEIS</a:t>
             </a:r>
             <a:endParaRPr lang="en-US" sz="1800" dirty="0"/>
           </a:p>
@@ -7198,7 +7294,7 @@
             <a:r>
               <a:rPr lang="en-US" sz="1600" dirty="0">
                 <a:solidFill>
-                  <a:srgbClr val="44506A"/>
+                  <a:srgbClr val="C9D6EE"/>
                 </a:solidFill>
               </a:rPr>
               <a:t>18 trilhos · 38 objetivos</a:t>
@@ -7234,7 +7330,7 @@
             <a:r>
               <a:rPr lang="en-US" sz="1500" b="1" dirty="0">
                 <a:solidFill>
-                  <a:schemeClr val="accent1"/>
+                  <a:srgbClr val="8DB4FF"/>
                 </a:solidFill>
               </a:rPr>
               <a:t>Físico · Afetivo · Caráter</a:t>
@@ -7248,7 +7344,7 @@
             <a:r>
               <a:rPr lang="en-US" sz="1500" b="1" dirty="0">
                 <a:solidFill>
-                  <a:schemeClr val="accent1"/>
+                  <a:srgbClr val="8DB4FF"/>
                 </a:solidFill>
               </a:rPr>
               <a:t>Espiritual · Intelectual · Social</a:t>
@@ -7287,7 +7383,7 @@
             <a:lvl1pPr>
               <a:defRPr sz="1000">
                 <a:solidFill>
-                  <a:srgbClr val="6B7A90"/>
+                  <a:srgbClr val="8FA3C7"/>
                 </a:solidFill>
               </a:defRPr>
             </a:lvl1pPr>
@@ -7356,7 +7452,7 @@
             <a:r>
               <a:rPr lang="en-US" sz="3200" b="1" dirty="0">
                 <a:solidFill>
-                  <a:schemeClr val="tx1"/>
+                  <a:srgbClr val="FFFFFF"/>
                 </a:solidFill>
               </a:rPr>
               <a:t>Entrar na app</a:t>
@@ -7373,18 +7469,18 @@
         </p:nvSpPr>
         <p:spPr>
           <a:xfrm>
-            <a:off x="548640" y="1508760"/>
+            <a:off x="548640" y="1600200"/>
             <a:ext cx="566928" cy="566928"/>
           </a:xfrm>
           <a:prstGeom prst="ellipse">
             <a:avLst/>
           </a:prstGeom>
           <a:solidFill>
-            <a:srgbClr val="1D4FA3"/>
+            <a:srgbClr val="2F6BD8"/>
           </a:solidFill>
           <a:ln w="12700">
             <a:solidFill>
-              <a:srgbClr val="1D4FA3"/>
+              <a:srgbClr val="2F6BD8"/>
             </a:solidFill>
             <a:prstDash val="solid"/>
           </a:ln>
@@ -7406,7 +7502,7 @@
         </p:blipFill>
         <p:spPr>
           <a:xfrm>
-            <a:off x="685800" y="1645920"/>
+            <a:off x="685800" y="1737360"/>
             <a:ext cx="292608" cy="292608"/>
           </a:xfrm>
           <a:prstGeom prst="rect">
@@ -7422,8 +7518,8 @@
         </p:nvSpPr>
         <p:spPr>
           <a:xfrm>
-            <a:off x="1325880" y="1472184"/>
-            <a:ext cx="5257800" cy="932688"/>
+            <a:off x="1371600" y="1563624"/>
+            <a:ext cx="5212080" cy="1024128"/>
           </a:xfrm>
           <a:prstGeom prst="rect">
             <a:avLst/>
@@ -7436,15 +7532,18 @@
           <a:lstStyle/>
           <a:p>
             <a:pPr indent="0" marL="0">
+              <a:lnSpc>
+                <a:spcPct val="115000"/>
+              </a:lnSpc>
               <a:spcAft>
-                <a:spcPts val="200"/>
+                <a:spcPts val="400"/>
               </a:spcAft>
               <a:buNone/>
             </a:pPr>
             <a:r>
               <a:rPr lang="en-US" sz="1700" b="1" dirty="0">
                 <a:solidFill>
-                  <a:schemeClr val="tx1"/>
+                  <a:srgbClr val="FFFFFF"/>
                 </a:solidFill>
               </a:rPr>
               <a:t>1. Recebes um convite</a:t>
@@ -7453,15 +7552,15 @@
           </a:p>
           <a:p>
             <a:pPr indent="0" marL="0">
-              <a:spcAft>
-                <a:spcPts val="200"/>
-              </a:spcAft>
-              <a:buNone/>
-            </a:pPr>
-            <a:r>
-              <a:rPr lang="en-US" sz="1400" dirty="0">
-                <a:solidFill>
-                  <a:srgbClr val="44506A"/>
+              <a:lnSpc>
+                <a:spcPct val="115000"/>
+              </a:lnSpc>
+              <a:buNone/>
+            </a:pPr>
+            <a:r>
+              <a:rPr lang="en-US" sz="1500" dirty="0">
+                <a:solidFill>
+                  <a:srgbClr val="C9D6EE"/>
                 </a:solidFill>
               </a:rPr>
               <a:t>Um link ou um código como AB7K-9M2P, dado pela Equipa de Animação.</a:t>
@@ -7478,18 +7577,18 @@
         </p:nvSpPr>
         <p:spPr>
           <a:xfrm>
-            <a:off x="548640" y="2532888"/>
+            <a:off x="548640" y="2697480"/>
             <a:ext cx="566928" cy="566928"/>
           </a:xfrm>
           <a:prstGeom prst="ellipse">
             <a:avLst/>
           </a:prstGeom>
           <a:solidFill>
-            <a:srgbClr val="1D4FA3"/>
+            <a:srgbClr val="2F6BD8"/>
           </a:solidFill>
           <a:ln w="12700">
             <a:solidFill>
-              <a:srgbClr val="1D4FA3"/>
+              <a:srgbClr val="2F6BD8"/>
             </a:solidFill>
             <a:prstDash val="solid"/>
           </a:ln>
@@ -7511,7 +7610,7 @@
         </p:blipFill>
         <p:spPr>
           <a:xfrm>
-            <a:off x="685800" y="2670048"/>
+            <a:off x="685800" y="2834640"/>
             <a:ext cx="292608" cy="292608"/>
           </a:xfrm>
           <a:prstGeom prst="rect">
@@ -7527,8 +7626,8 @@
         </p:nvSpPr>
         <p:spPr>
           <a:xfrm>
-            <a:off x="1325880" y="2496312"/>
-            <a:ext cx="5257800" cy="932688"/>
+            <a:off x="1371600" y="2660904"/>
+            <a:ext cx="5212080" cy="1024128"/>
           </a:xfrm>
           <a:prstGeom prst="rect">
             <a:avLst/>
@@ -7541,15 +7640,18 @@
           <a:lstStyle/>
           <a:p>
             <a:pPr indent="0" marL="0">
+              <a:lnSpc>
+                <a:spcPct val="115000"/>
+              </a:lnSpc>
               <a:spcAft>
-                <a:spcPts val="200"/>
+                <a:spcPts val="400"/>
               </a:spcAft>
               <a:buNone/>
             </a:pPr>
             <a:r>
               <a:rPr lang="en-US" sz="1700" b="1" dirty="0">
                 <a:solidFill>
-                  <a:schemeClr val="tx1"/>
+                  <a:srgbClr val="FFFFFF"/>
                 </a:solidFill>
               </a:rPr>
               <a:t>2. Crias a tua conta</a:t>
@@ -7558,15 +7660,15 @@
           </a:p>
           <a:p>
             <a:pPr indent="0" marL="0">
-              <a:spcAft>
-                <a:spcPts val="200"/>
-              </a:spcAft>
-              <a:buNone/>
-            </a:pPr>
-            <a:r>
-              <a:rPr lang="en-US" sz="1400" dirty="0">
-                <a:solidFill>
-                  <a:srgbClr val="44506A"/>
+              <a:lnSpc>
+                <a:spcPct val="115000"/>
+              </a:lnSpc>
+              <a:buNone/>
+            </a:pPr>
+            <a:r>
+              <a:rPr lang="en-US" sz="1500" dirty="0">
+                <a:solidFill>
+                  <a:srgbClr val="C9D6EE"/>
                 </a:solidFill>
               </a:rPr>
               <a:t>Email e palavra-passe. Confirmas o email.</a:t>
@@ -7583,18 +7685,18 @@
         </p:nvSpPr>
         <p:spPr>
           <a:xfrm>
-            <a:off x="548640" y="3557016"/>
+            <a:off x="548640" y="3794760"/>
             <a:ext cx="566928" cy="566928"/>
           </a:xfrm>
           <a:prstGeom prst="ellipse">
             <a:avLst/>
           </a:prstGeom>
           <a:solidFill>
-            <a:srgbClr val="1D4FA3"/>
+            <a:srgbClr val="2F6BD8"/>
           </a:solidFill>
           <a:ln w="12700">
             <a:solidFill>
-              <a:srgbClr val="1D4FA3"/>
+              <a:srgbClr val="2F6BD8"/>
             </a:solidFill>
             <a:prstDash val="solid"/>
           </a:ln>
@@ -7616,7 +7718,7 @@
         </p:blipFill>
         <p:spPr>
           <a:xfrm>
-            <a:off x="685800" y="3694176"/>
+            <a:off x="685800" y="3931920"/>
             <a:ext cx="292608" cy="292608"/>
           </a:xfrm>
           <a:prstGeom prst="rect">
@@ -7632,8 +7734,8 @@
         </p:nvSpPr>
         <p:spPr>
           <a:xfrm>
-            <a:off x="1325880" y="3520440"/>
-            <a:ext cx="5257800" cy="932688"/>
+            <a:off x="1371600" y="3758184"/>
+            <a:ext cx="5212080" cy="1024128"/>
           </a:xfrm>
           <a:prstGeom prst="rect">
             <a:avLst/>
@@ -7646,15 +7748,18 @@
           <a:lstStyle/>
           <a:p>
             <a:pPr indent="0" marL="0">
+              <a:lnSpc>
+                <a:spcPct val="115000"/>
+              </a:lnSpc>
               <a:spcAft>
-                <a:spcPts val="200"/>
+                <a:spcPts val="400"/>
               </a:spcAft>
               <a:buNone/>
             </a:pPr>
             <a:r>
               <a:rPr lang="en-US" sz="1700" b="1" dirty="0">
                 <a:solidFill>
-                  <a:schemeClr val="tx1"/>
+                  <a:srgbClr val="FFFFFF"/>
                 </a:solidFill>
               </a:rPr>
               <a:t>3. Escolhes a tua equipa</a:t>
@@ -7663,15 +7768,15 @@
           </a:p>
           <a:p>
             <a:pPr indent="0" marL="0">
-              <a:spcAft>
-                <a:spcPts val="200"/>
-              </a:spcAft>
-              <a:buNone/>
-            </a:pPr>
-            <a:r>
-              <a:rPr lang="en-US" sz="1400" dirty="0">
-                <a:solidFill>
-                  <a:srgbClr val="44506A"/>
+              <a:lnSpc>
+                <a:spcPct val="115000"/>
+              </a:lnSpc>
+              <a:buNone/>
+            </a:pPr>
+            <a:r>
+              <a:rPr lang="en-US" sz="1500" dirty="0">
+                <a:solidFill>
+                  <a:srgbClr val="C9D6EE"/>
                 </a:solidFill>
               </a:rPr>
               <a:t>Os dirigentes confirmam a tua entrada.</a:t>
@@ -7688,18 +7793,18 @@
         </p:nvSpPr>
         <p:spPr>
           <a:xfrm>
-            <a:off x="548640" y="4581144"/>
+            <a:off x="548640" y="4892040"/>
             <a:ext cx="566928" cy="566928"/>
           </a:xfrm>
           <a:prstGeom prst="ellipse">
             <a:avLst/>
           </a:prstGeom>
           <a:solidFill>
-            <a:srgbClr val="1D4FA3"/>
+            <a:srgbClr val="2F6BD8"/>
           </a:solidFill>
           <a:ln w="12700">
             <a:solidFill>
-              <a:srgbClr val="1D4FA3"/>
+              <a:srgbClr val="2F6BD8"/>
             </a:solidFill>
             <a:prstDash val="solid"/>
           </a:ln>
@@ -7721,7 +7826,7 @@
         </p:blipFill>
         <p:spPr>
           <a:xfrm>
-            <a:off x="685800" y="4718304"/>
+            <a:off x="685800" y="5029200"/>
             <a:ext cx="292608" cy="292608"/>
           </a:xfrm>
           <a:prstGeom prst="rect">
@@ -7737,8 +7842,8 @@
         </p:nvSpPr>
         <p:spPr>
           <a:xfrm>
-            <a:off x="1325880" y="4544568"/>
-            <a:ext cx="5257800" cy="932688"/>
+            <a:off x="1371600" y="4855464"/>
+            <a:ext cx="5212080" cy="1024128"/>
           </a:xfrm>
           <a:prstGeom prst="rect">
             <a:avLst/>
@@ -7751,15 +7856,18 @@
           <a:lstStyle/>
           <a:p>
             <a:pPr indent="0" marL="0">
+              <a:lnSpc>
+                <a:spcPct val="115000"/>
+              </a:lnSpc>
               <a:spcAft>
-                <a:spcPts val="200"/>
+                <a:spcPts val="400"/>
               </a:spcAft>
               <a:buNone/>
             </a:pPr>
             <a:r>
               <a:rPr lang="en-US" sz="1700" b="1" dirty="0">
                 <a:solidFill>
-                  <a:schemeClr val="tx1"/>
+                  <a:srgbClr val="FFFFFF"/>
                 </a:solidFill>
               </a:rPr>
               <a:t>4. Instalas no telemóvel</a:t>
@@ -7768,15 +7876,15 @@
           </a:p>
           <a:p>
             <a:pPr indent="0" marL="0">
-              <a:spcAft>
-                <a:spcPts val="200"/>
-              </a:spcAft>
-              <a:buNone/>
-            </a:pPr>
-            <a:r>
-              <a:rPr lang="en-US" sz="1400" dirty="0">
-                <a:solidFill>
-                  <a:srgbClr val="44506A"/>
+              <a:lnSpc>
+                <a:spcPct val="115000"/>
+              </a:lnSpc>
+              <a:buNone/>
+            </a:pPr>
+            <a:r>
+              <a:rPr lang="en-US" sz="1500" dirty="0">
+                <a:solidFill>
+                  <a:srgbClr val="C9D6EE"/>
                 </a:solidFill>
               </a:rPr>
               <a:t>iPhone: Partilhar › Adicionar ao ecrã principal. Android: Instalar app.</a:t>
@@ -7802,11 +7910,11 @@
             </a:avLst>
           </a:prstGeom>
           <a:solidFill>
-            <a:srgbClr val="14213D"/>
+            <a:srgbClr val="3A4D75"/>
           </a:solidFill>
           <a:ln w="12700">
             <a:solidFill>
-              <a:srgbClr val="14213D"/>
+              <a:srgbClr val="3A4D75"/>
             </a:solidFill>
             <a:prstDash val="solid"/>
           </a:ln>
@@ -7860,11 +7968,11 @@
             </a:avLst>
           </a:prstGeom>
           <a:solidFill>
-            <a:srgbClr val="14213D"/>
+            <a:srgbClr val="3A4D75"/>
           </a:solidFill>
           <a:ln w="12700">
             <a:solidFill>
-              <a:srgbClr val="14213D"/>
+              <a:srgbClr val="3A4D75"/>
             </a:solidFill>
             <a:prstDash val="solid"/>
           </a:ln>
@@ -7931,7 +8039,7 @@
             <a:lvl1pPr>
               <a:defRPr sz="1000">
                 <a:solidFill>
-                  <a:srgbClr val="6B7A90"/>
+                  <a:srgbClr val="8FA3C7"/>
                 </a:solidFill>
               </a:defRPr>
             </a:lvl1pPr>
@@ -8000,7 +8108,7 @@
             <a:r>
               <a:rPr lang="en-US" sz="3200" b="1" dirty="0">
                 <a:solidFill>
-                  <a:schemeClr val="tx1"/>
+                  <a:srgbClr val="FFFFFF"/>
                 </a:solidFill>
               </a:rPr>
               <a:t>O ecrã de Início</a:t>
@@ -8017,18 +8125,18 @@
         </p:nvSpPr>
         <p:spPr>
           <a:xfrm>
-            <a:off x="548640" y="1508760"/>
+            <a:off x="548640" y="1600200"/>
             <a:ext cx="566928" cy="566928"/>
           </a:xfrm>
           <a:prstGeom prst="ellipse">
             <a:avLst/>
           </a:prstGeom>
           <a:solidFill>
-            <a:srgbClr val="1D4FA3"/>
+            <a:srgbClr val="2F6BD8"/>
           </a:solidFill>
           <a:ln w="12700">
             <a:solidFill>
-              <a:srgbClr val="1D4FA3"/>
+              <a:srgbClr val="2F6BD8"/>
             </a:solidFill>
             <a:prstDash val="solid"/>
           </a:ln>
@@ -8050,7 +8158,7 @@
         </p:blipFill>
         <p:spPr>
           <a:xfrm>
-            <a:off x="685800" y="1645920"/>
+            <a:off x="685800" y="1737360"/>
             <a:ext cx="292608" cy="292608"/>
           </a:xfrm>
           <a:prstGeom prst="rect">
@@ -8066,8 +8174,8 @@
         </p:nvSpPr>
         <p:spPr>
           <a:xfrm>
-            <a:off x="1325880" y="1472184"/>
-            <a:ext cx="6172200" cy="932688"/>
+            <a:off x="1371600" y="1563624"/>
+            <a:ext cx="6126480" cy="1024128"/>
           </a:xfrm>
           <a:prstGeom prst="rect">
             <a:avLst/>
@@ -8080,15 +8188,18 @@
           <a:lstStyle/>
           <a:p>
             <a:pPr indent="0" marL="0">
+              <a:lnSpc>
+                <a:spcPct val="115000"/>
+              </a:lnSpc>
               <a:spcAft>
-                <a:spcPts val="200"/>
+                <a:spcPts val="400"/>
               </a:spcAft>
               <a:buNone/>
             </a:pPr>
             <a:r>
               <a:rPr lang="en-US" sz="1700" b="1" dirty="0">
                 <a:solidFill>
-                  <a:schemeClr val="tx1"/>
+                  <a:srgbClr val="FFFFFF"/>
                 </a:solidFill>
               </a:rPr>
               <a:t>A tua etapa</a:t>
@@ -8097,15 +8208,15 @@
           </a:p>
           <a:p>
             <a:pPr indent="0" marL="0">
-              <a:spcAft>
-                <a:spcPts val="200"/>
-              </a:spcAft>
-              <a:buNone/>
-            </a:pPr>
-            <a:r>
-              <a:rPr lang="en-US" sz="1400" dirty="0">
-                <a:solidFill>
-                  <a:srgbClr val="44506A"/>
+              <a:lnSpc>
+                <a:spcPct val="115000"/>
+              </a:lnSpc>
+              <a:buNone/>
+            </a:pPr>
+            <a:r>
+              <a:rPr lang="en-US" sz="1500" dirty="0">
+                <a:solidFill>
+                  <a:srgbClr val="C9D6EE"/>
                 </a:solidFill>
               </a:rPr>
               <a:t>Em que etapa estás (Conhecimento, Vontade, Construção).</a:t>
@@ -8122,18 +8233,18 @@
         </p:nvSpPr>
         <p:spPr>
           <a:xfrm>
-            <a:off x="548640" y="2532888"/>
+            <a:off x="548640" y="2697480"/>
             <a:ext cx="566928" cy="566928"/>
           </a:xfrm>
           <a:prstGeom prst="ellipse">
             <a:avLst/>
           </a:prstGeom>
           <a:solidFill>
-            <a:srgbClr val="1D4FA3"/>
+            <a:srgbClr val="2F6BD8"/>
           </a:solidFill>
           <a:ln w="12700">
             <a:solidFill>
-              <a:srgbClr val="1D4FA3"/>
+              <a:srgbClr val="2F6BD8"/>
             </a:solidFill>
             <a:prstDash val="solid"/>
           </a:ln>
@@ -8155,7 +8266,7 @@
         </p:blipFill>
         <p:spPr>
           <a:xfrm>
-            <a:off x="685800" y="2670048"/>
+            <a:off x="685800" y="2834640"/>
             <a:ext cx="292608" cy="292608"/>
           </a:xfrm>
           <a:prstGeom prst="rect">
@@ -8171,8 +8282,8 @@
         </p:nvSpPr>
         <p:spPr>
           <a:xfrm>
-            <a:off x="1325880" y="2496312"/>
-            <a:ext cx="6172200" cy="932688"/>
+            <a:off x="1371600" y="2660904"/>
+            <a:ext cx="6126480" cy="1024128"/>
           </a:xfrm>
           <a:prstGeom prst="rect">
             <a:avLst/>
@@ -8185,15 +8296,18 @@
           <a:lstStyle/>
           <a:p>
             <a:pPr indent="0" marL="0">
+              <a:lnSpc>
+                <a:spcPct val="115000"/>
+              </a:lnSpc>
               <a:spcAft>
-                <a:spcPts val="200"/>
+                <a:spcPts val="400"/>
               </a:spcAft>
               <a:buNone/>
             </a:pPr>
             <a:r>
               <a:rPr lang="en-US" sz="1700" b="1" dirty="0">
                 <a:solidFill>
-                  <a:schemeClr val="tx1"/>
+                  <a:srgbClr val="FFFFFF"/>
                 </a:solidFill>
               </a:rPr>
               <a:t>Pedidos em validação e a rever</a:t>
@@ -8202,15 +8316,15 @@
           </a:p>
           <a:p>
             <a:pPr indent="0" marL="0">
-              <a:spcAft>
-                <a:spcPts val="200"/>
-              </a:spcAft>
-              <a:buNone/>
-            </a:pPr>
-            <a:r>
-              <a:rPr lang="en-US" sz="1400" dirty="0">
-                <a:solidFill>
-                  <a:srgbClr val="44506A"/>
+              <a:lnSpc>
+                <a:spcPct val="115000"/>
+              </a:lnSpc>
+              <a:buNone/>
+            </a:pPr>
+            <a:r>
+              <a:rPr lang="en-US" sz="1500" dirty="0">
+                <a:solidFill>
+                  <a:srgbClr val="C9D6EE"/>
                 </a:solidFill>
               </a:rPr>
               <a:t>Quantos pedidos esperam decisão e quantos tens de corrigir.</a:t>
@@ -8227,18 +8341,18 @@
         </p:nvSpPr>
         <p:spPr>
           <a:xfrm>
-            <a:off x="548640" y="3557016"/>
+            <a:off x="548640" y="3794760"/>
             <a:ext cx="566928" cy="566928"/>
           </a:xfrm>
           <a:prstGeom prst="ellipse">
             <a:avLst/>
           </a:prstGeom>
           <a:solidFill>
-            <a:srgbClr val="1D4FA3"/>
+            <a:srgbClr val="2F6BD8"/>
           </a:solidFill>
           <a:ln w="12700">
             <a:solidFill>
-              <a:srgbClr val="1D4FA3"/>
+              <a:srgbClr val="2F6BD8"/>
             </a:solidFill>
             <a:prstDash val="solid"/>
           </a:ln>
@@ -8260,7 +8374,7 @@
         </p:blipFill>
         <p:spPr>
           <a:xfrm>
-            <a:off x="685800" y="3694176"/>
+            <a:off x="685800" y="3931920"/>
             <a:ext cx="292608" cy="292608"/>
           </a:xfrm>
           <a:prstGeom prst="rect">
@@ -8276,8 +8390,8 @@
         </p:nvSpPr>
         <p:spPr>
           <a:xfrm>
-            <a:off x="1325880" y="3520440"/>
-            <a:ext cx="6172200" cy="932688"/>
+            <a:off x="1371600" y="3758184"/>
+            <a:ext cx="6126480" cy="1024128"/>
           </a:xfrm>
           <a:prstGeom prst="rect">
             <a:avLst/>
@@ -8290,15 +8404,18 @@
           <a:lstStyle/>
           <a:p>
             <a:pPr indent="0" marL="0">
+              <a:lnSpc>
+                <a:spcPct val="115000"/>
+              </a:lnSpc>
               <a:spcAft>
-                <a:spcPts val="200"/>
+                <a:spcPts val="400"/>
               </a:spcAft>
               <a:buNone/>
             </a:pPr>
             <a:r>
               <a:rPr lang="en-US" sz="1700" b="1" dirty="0">
                 <a:solidFill>
-                  <a:schemeClr val="tx1"/>
+                  <a:srgbClr val="FFFFFF"/>
                 </a:solidFill>
               </a:rPr>
               <a:t>Próximo passo</a:t>
@@ -8307,15 +8424,15 @@
           </a:p>
           <a:p>
             <a:pPr indent="0" marL="0">
-              <a:spcAft>
-                <a:spcPts val="200"/>
-              </a:spcAft>
-              <a:buNone/>
-            </a:pPr>
-            <a:r>
-              <a:rPr lang="en-US" sz="1400" dirty="0">
-                <a:solidFill>
-                  <a:srgbClr val="44506A"/>
+              <a:lnSpc>
+                <a:spcPct val="115000"/>
+              </a:lnSpc>
+              <a:buNone/>
+            </a:pPr>
+            <a:r>
+              <a:rPr lang="en-US" sz="1500" dirty="0">
+                <a:solidFill>
+                  <a:srgbClr val="C9D6EE"/>
                 </a:solidFill>
               </a:rPr>
               <a:t>A app diz-te o que fazer a seguir, com um botão direto.</a:t>
@@ -8332,18 +8449,18 @@
         </p:nvSpPr>
         <p:spPr>
           <a:xfrm>
-            <a:off x="548640" y="4581144"/>
+            <a:off x="548640" y="4892040"/>
             <a:ext cx="566928" cy="566928"/>
           </a:xfrm>
           <a:prstGeom prst="ellipse">
             <a:avLst/>
           </a:prstGeom>
           <a:solidFill>
-            <a:srgbClr val="1D4FA3"/>
+            <a:srgbClr val="2F6BD8"/>
           </a:solidFill>
           <a:ln w="12700">
             <a:solidFill>
-              <a:srgbClr val="1D4FA3"/>
+              <a:srgbClr val="2F6BD8"/>
             </a:solidFill>
             <a:prstDash val="solid"/>
           </a:ln>
@@ -8365,7 +8482,7 @@
         </p:blipFill>
         <p:spPr>
           <a:xfrm>
-            <a:off x="685800" y="4718304"/>
+            <a:off x="685800" y="5029200"/>
             <a:ext cx="292608" cy="292608"/>
           </a:xfrm>
           <a:prstGeom prst="rect">
@@ -8381,8 +8498,8 @@
         </p:nvSpPr>
         <p:spPr>
           <a:xfrm>
-            <a:off x="1325880" y="4544568"/>
-            <a:ext cx="6172200" cy="932688"/>
+            <a:off x="1371600" y="4855464"/>
+            <a:ext cx="6126480" cy="1024128"/>
           </a:xfrm>
           <a:prstGeom prst="rect">
             <a:avLst/>
@@ -8395,15 +8512,18 @@
           <a:lstStyle/>
           <a:p>
             <a:pPr indent="0" marL="0">
+              <a:lnSpc>
+                <a:spcPct val="115000"/>
+              </a:lnSpc>
               <a:spcAft>
-                <a:spcPts val="200"/>
+                <a:spcPts val="400"/>
               </a:spcAft>
               <a:buNone/>
             </a:pPr>
             <a:r>
               <a:rPr lang="en-US" sz="1700" b="1" dirty="0">
                 <a:solidFill>
-                  <a:schemeClr val="tx1"/>
+                  <a:srgbClr val="FFFFFF"/>
                 </a:solidFill>
               </a:rPr>
               <a:t>Feedback recebido</a:t>
@@ -8412,15 +8532,15 @@
           </a:p>
           <a:p>
             <a:pPr indent="0" marL="0">
-              <a:spcAft>
-                <a:spcPts val="200"/>
-              </a:spcAft>
-              <a:buNone/>
-            </a:pPr>
-            <a:r>
-              <a:rPr lang="en-US" sz="1400" dirty="0">
-                <a:solidFill>
-                  <a:srgbClr val="44506A"/>
+              <a:lnSpc>
+                <a:spcPct val="115000"/>
+              </a:lnSpc>
+              <a:buNone/>
+            </a:pPr>
+            <a:r>
+              <a:rPr lang="en-US" sz="1500" dirty="0">
+                <a:solidFill>
+                  <a:srgbClr val="C9D6EE"/>
                 </a:solidFill>
               </a:rPr>
               <a:t>Os últimos comentários dos guias e dirigentes.</a:t>
@@ -8446,11 +8566,11 @@
             </a:avLst>
           </a:prstGeom>
           <a:solidFill>
-            <a:srgbClr val="14213D"/>
+            <a:srgbClr val="3A4D75"/>
           </a:solidFill>
           <a:ln w="12700">
             <a:solidFill>
-              <a:srgbClr val="14213D"/>
+              <a:srgbClr val="3A4D75"/>
             </a:solidFill>
             <a:prstDash val="solid"/>
           </a:ln>
@@ -8517,7 +8637,7 @@
             <a:lvl1pPr>
               <a:defRPr sz="1000">
                 <a:solidFill>
-                  <a:srgbClr val="6B7A90"/>
+                  <a:srgbClr val="8FA3C7"/>
                 </a:solidFill>
               </a:defRPr>
             </a:lvl1pPr>
@@ -8586,7 +8706,7 @@
             <a:r>
               <a:rPr lang="en-US" sz="3200" b="1" dirty="0">
                 <a:solidFill>
-                  <a:schemeClr val="tx1"/>
+                  <a:srgbClr val="FFFFFF"/>
                 </a:solidFill>
               </a:rPr>
               <a:t>Meu progresso: as seis áreas</a:t>
@@ -8622,7 +8742,7 @@
             <a:r>
               <a:rPr lang="en-US" sz="1600" dirty="0">
                 <a:solidFill>
-                  <a:srgbClr val="44506A"/>
+                  <a:srgbClr val="C9D6EE"/>
                 </a:solidFill>
               </a:rPr>
               <a:t>Cada cartão é uma área FACEIS. As três barrinhas são os três trilhos da área: preenchida = trilho validado.</a:t>
@@ -8648,11 +8768,11 @@
             </a:avLst>
           </a:prstGeom>
           <a:solidFill>
-            <a:srgbClr val="F6F8FC"/>
+            <a:srgbClr val="1B2A4A"/>
           </a:solidFill>
           <a:ln w="12700">
             <a:solidFill>
-              <a:srgbClr val="DCE3EF"/>
+              <a:srgbClr val="2C3E63"/>
             </a:solidFill>
             <a:prstDash val="solid"/>
           </a:ln>
@@ -8685,7 +8805,7 @@
             <a:r>
               <a:rPr lang="en-US" sz="1800" b="1" dirty="0">
                 <a:solidFill>
-                  <a:srgbClr val="C2410C"/>
+                  <a:srgbClr val="FDBA74"/>
                 </a:solidFill>
               </a:rPr>
               <a:t>Físico</a:t>
@@ -8699,10 +8819,10 @@
             <a:r>
               <a:rPr lang="en-US" sz="1400" dirty="0">
                 <a:solidFill>
-                  <a:srgbClr val="44506A"/>
-                </a:solidFill>
-              </a:rPr>
-              <a:t>o corpo</a:t>
+                  <a:srgbClr val="C9D6EE"/>
+                </a:solidFill>
+              </a:rPr>
+              <a:t>O corpo</a:t>
             </a:r>
             <a:endParaRPr lang="en-US" sz="1800" dirty="0"/>
           </a:p>
@@ -8725,11 +8845,11 @@
             </a:avLst>
           </a:prstGeom>
           <a:solidFill>
-            <a:srgbClr val="F6F8FC"/>
+            <a:srgbClr val="1B2A4A"/>
           </a:solidFill>
           <a:ln w="12700">
             <a:solidFill>
-              <a:srgbClr val="DCE3EF"/>
+              <a:srgbClr val="2C3E63"/>
             </a:solidFill>
             <a:prstDash val="solid"/>
           </a:ln>
@@ -8762,7 +8882,7 @@
             <a:r>
               <a:rPr lang="en-US" sz="1800" b="1" dirty="0">
                 <a:solidFill>
-                  <a:srgbClr val="BE185D"/>
+                  <a:srgbClr val="F9A8D4"/>
                 </a:solidFill>
               </a:rPr>
               <a:t>Afetivo</a:t>
@@ -8776,10 +8896,10 @@
             <a:r>
               <a:rPr lang="en-US" sz="1400" dirty="0">
                 <a:solidFill>
-                  <a:srgbClr val="44506A"/>
-                </a:solidFill>
-              </a:rPr>
-              <a:t>os sentimentos</a:t>
+                  <a:srgbClr val="C9D6EE"/>
+                </a:solidFill>
+              </a:rPr>
+              <a:t>Os sentimentos</a:t>
             </a:r>
             <a:endParaRPr lang="en-US" sz="1800" dirty="0"/>
           </a:p>
@@ -8802,11 +8922,11 @@
             </a:avLst>
           </a:prstGeom>
           <a:solidFill>
-            <a:srgbClr val="F6F8FC"/>
+            <a:srgbClr val="1B2A4A"/>
           </a:solidFill>
           <a:ln w="12700">
             <a:solidFill>
-              <a:srgbClr val="DCE3EF"/>
+              <a:srgbClr val="2C3E63"/>
             </a:solidFill>
             <a:prstDash val="solid"/>
           </a:ln>
@@ -8839,7 +8959,7 @@
             <a:r>
               <a:rPr lang="en-US" sz="1800" b="1" dirty="0">
                 <a:solidFill>
-                  <a:srgbClr val="1D4FA3"/>
+                  <a:srgbClr val="93C5FD"/>
                 </a:solidFill>
               </a:rPr>
               <a:t>Caráter</a:t>
@@ -8853,10 +8973,10 @@
             <a:r>
               <a:rPr lang="en-US" sz="1400" dirty="0">
                 <a:solidFill>
-                  <a:srgbClr val="44506A"/>
-                </a:solidFill>
-              </a:rPr>
-              <a:t>a atitude</a:t>
+                  <a:srgbClr val="C9D6EE"/>
+                </a:solidFill>
+              </a:rPr>
+              <a:t>A atitude</a:t>
             </a:r>
             <a:endParaRPr lang="en-US" sz="1800" dirty="0"/>
           </a:p>
@@ -8879,11 +8999,11 @@
             </a:avLst>
           </a:prstGeom>
           <a:solidFill>
-            <a:srgbClr val="F6F8FC"/>
+            <a:srgbClr val="1B2A4A"/>
           </a:solidFill>
           <a:ln w="12700">
             <a:solidFill>
-              <a:srgbClr val="DCE3EF"/>
+              <a:srgbClr val="2C3E63"/>
             </a:solidFill>
             <a:prstDash val="solid"/>
           </a:ln>
@@ -8916,7 +9036,7 @@
             <a:r>
               <a:rPr lang="en-US" sz="1800" b="1" dirty="0">
                 <a:solidFill>
-                  <a:srgbClr val="6D28D9"/>
+                  <a:srgbClr val="C4B5FD"/>
                 </a:solidFill>
               </a:rPr>
               <a:t>Espiritual</a:t>
@@ -8930,10 +9050,10 @@
             <a:r>
               <a:rPr lang="en-US" sz="1400" dirty="0">
                 <a:solidFill>
-                  <a:srgbClr val="44506A"/>
-                </a:solidFill>
-              </a:rPr>
-              <a:t>a fé</a:t>
+                  <a:srgbClr val="C9D6EE"/>
+                </a:solidFill>
+              </a:rPr>
+              <a:t>A fé</a:t>
             </a:r>
             <a:endParaRPr lang="en-US" sz="1800" dirty="0"/>
           </a:p>
@@ -8956,11 +9076,11 @@
             </a:avLst>
           </a:prstGeom>
           <a:solidFill>
-            <a:srgbClr val="F6F8FC"/>
+            <a:srgbClr val="1B2A4A"/>
           </a:solidFill>
           <a:ln w="12700">
             <a:solidFill>
-              <a:srgbClr val="DCE3EF"/>
+              <a:srgbClr val="2C3E63"/>
             </a:solidFill>
             <a:prstDash val="solid"/>
           </a:ln>
@@ -8993,7 +9113,7 @@
             <a:r>
               <a:rPr lang="en-US" sz="1800" b="1" dirty="0">
                 <a:solidFill>
-                  <a:srgbClr val="B45309"/>
+                  <a:srgbClr val="FCD34D"/>
                 </a:solidFill>
               </a:rPr>
               <a:t>Intelectual</a:t>
@@ -9007,10 +9127,10 @@
             <a:r>
               <a:rPr lang="en-US" sz="1400" dirty="0">
                 <a:solidFill>
-                  <a:srgbClr val="44506A"/>
-                </a:solidFill>
-              </a:rPr>
-              <a:t>a mente</a:t>
+                  <a:srgbClr val="C9D6EE"/>
+                </a:solidFill>
+              </a:rPr>
+              <a:t>A mente</a:t>
             </a:r>
             <a:endParaRPr lang="en-US" sz="1800" dirty="0"/>
           </a:p>
@@ -9033,11 +9153,11 @@
             </a:avLst>
           </a:prstGeom>
           <a:solidFill>
-            <a:srgbClr val="F6F8FC"/>
+            <a:srgbClr val="1B2A4A"/>
           </a:solidFill>
           <a:ln w="12700">
             <a:solidFill>
-              <a:srgbClr val="DCE3EF"/>
+              <a:srgbClr val="2C3E63"/>
             </a:solidFill>
             <a:prstDash val="solid"/>
           </a:ln>
@@ -9070,7 +9190,7 @@
             <a:r>
               <a:rPr lang="en-US" sz="1800" b="1" dirty="0">
                 <a:solidFill>
-                  <a:srgbClr val="2E8B57"/>
+                  <a:srgbClr val="86EFAC"/>
                 </a:solidFill>
               </a:rPr>
               <a:t>Social</a:t>
@@ -9084,10 +9204,10 @@
             <a:r>
               <a:rPr lang="en-US" sz="1400" dirty="0">
                 <a:solidFill>
-                  <a:srgbClr val="44506A"/>
-                </a:solidFill>
-              </a:rPr>
-              <a:t>os outros</a:t>
+                  <a:srgbClr val="C9D6EE"/>
+                </a:solidFill>
+              </a:rPr>
+              <a:t>Os outros</a:t>
             </a:r>
             <a:endParaRPr lang="en-US" sz="1800" dirty="0"/>
           </a:p>
@@ -9120,7 +9240,7 @@
             <a:r>
               <a:rPr lang="en-US" sz="1400" b="1" dirty="0">
                 <a:solidFill>
-                  <a:schemeClr val="accent1"/>
+                  <a:srgbClr val="8DB4FF"/>
                 </a:solidFill>
               </a:rPr>
               <a:t>Por baixo: Os meus pedidos · Progresso validado · Ver o meu percurso</a:t>
@@ -9146,11 +9266,11 @@
             </a:avLst>
           </a:prstGeom>
           <a:solidFill>
-            <a:srgbClr val="14213D"/>
+            <a:srgbClr val="3A4D75"/>
           </a:solidFill>
           <a:ln w="12700">
             <a:solidFill>
-              <a:srgbClr val="14213D"/>
+              <a:srgbClr val="3A4D75"/>
             </a:solidFill>
             <a:prstDash val="solid"/>
           </a:ln>
@@ -9217,7 +9337,7 @@
             <a:lvl1pPr>
               <a:defRPr sz="1000">
                 <a:solidFill>
-                  <a:srgbClr val="6B7A90"/>
+                  <a:srgbClr val="8FA3C7"/>
                 </a:solidFill>
               </a:defRPr>
             </a:lvl1pPr>
@@ -9286,7 +9406,7 @@
             <a:r>
               <a:rPr lang="en-US" sz="3200" b="1" dirty="0">
                 <a:solidFill>
-                  <a:schemeClr val="tx1"/>
+                  <a:srgbClr val="FFFFFF"/>
                 </a:solidFill>
               </a:rPr>
               <a:t>Abrir uma área e escolher o trilho</a:t>
@@ -9322,7 +9442,7 @@
             <a:r>
               <a:rPr lang="en-US" sz="1600" dirty="0">
                 <a:solidFill>
-                  <a:srgbClr val="44506A"/>
+                  <a:srgbClr val="C9D6EE"/>
                 </a:solidFill>
               </a:rPr>
               <a:t>Vês os três trilhos da área, os códigos dos objetivos (F1, F2…) e o estado de cada um:</a:t>
@@ -9348,11 +9468,11 @@
             </a:avLst>
           </a:prstGeom>
           <a:solidFill>
-            <a:srgbClr val="EEF0F4"/>
+            <a:srgbClr val="E2E8F0"/>
           </a:solidFill>
           <a:ln w="12700">
             <a:solidFill>
-              <a:srgbClr val="EEF0F4"/>
+              <a:srgbClr val="E2E8F0"/>
             </a:solidFill>
             <a:prstDash val="solid"/>
           </a:ln>
@@ -9385,7 +9505,7 @@
             <a:r>
               <a:rPr lang="en-US" sz="1400" b="1" dirty="0">
                 <a:solidFill>
-                  <a:srgbClr val="44506A"/>
+                  <a:srgbClr val="334155"/>
                 </a:solidFill>
               </a:rPr>
               <a:t>Por fechar</a:t>
@@ -9421,7 +9541,7 @@
             <a:r>
               <a:rPr lang="en-US" sz="1500" dirty="0">
                 <a:solidFill>
-                  <a:schemeClr val="tx1"/>
+                  <a:srgbClr val="FFFFFF"/>
                 </a:solidFill>
               </a:rPr>
               <a:t>Ainda não pediste a validação.</a:t>
@@ -9520,7 +9640,7 @@
             <a:r>
               <a:rPr lang="en-US" sz="1500" dirty="0">
                 <a:solidFill>
-                  <a:schemeClr val="tx1"/>
+                  <a:srgbClr val="FFFFFF"/>
                 </a:solidFill>
               </a:rPr>
               <a:t>Pediste; espera a reunião de Equipa.</a:t>
@@ -9619,7 +9739,7 @@
             <a:r>
               <a:rPr lang="en-US" sz="1500" dirty="0">
                 <a:solidFill>
-                  <a:schemeClr val="tx1"/>
+                  <a:srgbClr val="FFFFFF"/>
                 </a:solidFill>
               </a:rPr>
               <a:t>Tens de corrigir e voltar a enviar.</a:t>
@@ -9718,7 +9838,7 @@
             <a:r>
               <a:rPr lang="en-US" sz="1500" dirty="0">
                 <a:solidFill>
-                  <a:schemeClr val="tx1"/>
+                  <a:srgbClr val="FFFFFF"/>
                 </a:solidFill>
               </a:rPr>
               <a:t>Trilho fechado!</a:t>
@@ -9754,7 +9874,7 @@
             <a:r>
               <a:rPr lang="en-US" sz="1500" b="1" dirty="0">
                 <a:solidFill>
-                  <a:schemeClr val="accent1"/>
+                  <a:srgbClr val="8DB4FF"/>
                 </a:solidFill>
               </a:rPr>
               <a:t>Toca no trilho para o abrir.</a:t>
@@ -9780,11 +9900,11 @@
             </a:avLst>
           </a:prstGeom>
           <a:solidFill>
-            <a:srgbClr val="14213D"/>
+            <a:srgbClr val="3A4D75"/>
           </a:solidFill>
           <a:ln w="12700">
             <a:solidFill>
-              <a:srgbClr val="14213D"/>
+              <a:srgbClr val="3A4D75"/>
             </a:solidFill>
             <a:prstDash val="solid"/>
           </a:ln>
@@ -9851,7 +9971,7 @@
             <a:lvl1pPr>
               <a:defRPr sz="1000">
                 <a:solidFill>
-                  <a:srgbClr val="6B7A90"/>
+                  <a:srgbClr val="8FA3C7"/>
                 </a:solidFill>
               </a:defRPr>
             </a:lvl1pPr>
@@ -9920,7 +10040,7 @@
             <a:r>
               <a:rPr lang="en-US" sz="3200" b="1" dirty="0">
                 <a:solidFill>
-                  <a:schemeClr val="tx1"/>
+                  <a:srgbClr val="FFFFFF"/>
                 </a:solidFill>
               </a:rPr>
               <a:t>Trabalhar ou fechar?</a:t>
@@ -9946,11 +10066,11 @@
             </a:avLst>
           </a:prstGeom>
           <a:solidFill>
-            <a:srgbClr val="F6F8FC"/>
+            <a:srgbClr val="1B2A4A"/>
           </a:solidFill>
           <a:ln w="12700">
             <a:solidFill>
-              <a:srgbClr val="DCE3EF"/>
+              <a:srgbClr val="2C3E63"/>
             </a:solidFill>
             <a:prstDash val="solid"/>
           </a:ln>
@@ -10032,7 +10152,7 @@
             <a:r>
               <a:rPr lang="en-US" sz="2000" b="1" dirty="0">
                 <a:solidFill>
-                  <a:schemeClr val="tx1"/>
+                  <a:srgbClr val="FFFFFF"/>
                 </a:solidFill>
               </a:rPr>
               <a:t>Trabalhar neste trilho</a:t>
@@ -10063,8 +10183,11 @@
           <a:lstStyle/>
           <a:p>
             <a:pPr marL="342900" indent="-342900">
+              <a:lnSpc>
+                <a:spcPct val="115000"/>
+              </a:lnSpc>
               <a:spcAft>
-                <a:spcPts val="600"/>
+                <a:spcPts val="1000"/>
               </a:spcAft>
               <a:buSzPct val="100000"/>
               <a:buChar char="•"/>
@@ -10072,7 +10195,7 @@
             <a:r>
               <a:rPr lang="en-US" sz="1500" dirty="0">
                 <a:solidFill>
-                  <a:srgbClr val="2A3550"/>
+                  <a:srgbClr val="DCE5F5"/>
                 </a:solidFill>
               </a:rPr>
               <a:t>Queres trabalhar este trilho na tua etapa</a:t>
@@ -10081,8 +10204,11 @@
           </a:p>
           <a:p>
             <a:pPr marL="342900" indent="-342900">
+              <a:lnSpc>
+                <a:spcPct val="115000"/>
+              </a:lnSpc>
               <a:spcAft>
-                <a:spcPts val="600"/>
+                <a:spcPts val="1000"/>
               </a:spcAft>
               <a:buSzPct val="100000"/>
               <a:buChar char="•"/>
@@ -10090,7 +10216,7 @@
             <a:r>
               <a:rPr lang="en-US" sz="1500" dirty="0">
                 <a:solidFill>
-                  <a:srgbClr val="2A3550"/>
+                  <a:srgbClr val="DCE5F5"/>
                 </a:solidFill>
               </a:rPr>
               <a:t>Propões à Equipa de Animação</a:t>
@@ -10099,8 +10225,11 @@
           </a:p>
           <a:p>
             <a:pPr marL="342900" indent="-342900">
+              <a:lnSpc>
+                <a:spcPct val="115000"/>
+              </a:lnSpc>
               <a:spcAft>
-                <a:spcPts val="600"/>
+                <a:spcPts val="1000"/>
               </a:spcAft>
               <a:buSzPct val="100000"/>
               <a:buChar char="•"/>
@@ -10108,7 +10237,7 @@
             <a:r>
               <a:rPr lang="en-US" sz="1500" dirty="0">
                 <a:solidFill>
-                  <a:srgbClr val="2A3550"/>
+                  <a:srgbClr val="DCE5F5"/>
                 </a:solidFill>
               </a:rPr>
               <a:t>Os dirigentes combinam contigo</a:t>
@@ -10134,11 +10263,11 @@
             </a:avLst>
           </a:prstGeom>
           <a:solidFill>
-            <a:srgbClr val="F6F8FC"/>
+            <a:srgbClr val="1B2A4A"/>
           </a:solidFill>
           <a:ln w="12700">
             <a:solidFill>
-              <a:srgbClr val="DCE3EF"/>
+              <a:srgbClr val="2C3E63"/>
             </a:solidFill>
             <a:prstDash val="solid"/>
           </a:ln>
@@ -10220,7 +10349,7 @@
             <a:r>
               <a:rPr lang="en-US" sz="2000" b="1" dirty="0">
                 <a:solidFill>
-                  <a:schemeClr val="tx1"/>
+                  <a:srgbClr val="FFFFFF"/>
                 </a:solidFill>
               </a:rPr>
               <a:t>Fechar este trilho</a:t>
@@ -10251,8 +10380,11 @@
           <a:lstStyle/>
           <a:p>
             <a:pPr marL="342900" indent="-342900">
+              <a:lnSpc>
+                <a:spcPct val="115000"/>
+              </a:lnSpc>
               <a:spcAft>
-                <a:spcPts val="600"/>
+                <a:spcPts val="1000"/>
               </a:spcAft>
               <a:buSzPct val="100000"/>
               <a:buChar char="•"/>
@@ -10260,7 +10392,7 @@
             <a:r>
               <a:rPr lang="en-US" sz="1500" dirty="0">
                 <a:solidFill>
-                  <a:srgbClr val="2A3550"/>
+                  <a:srgbClr val="DCE5F5"/>
                 </a:solidFill>
               </a:rPr>
               <a:t>Já atingiste os objetivos</a:t>
@@ -10269,8 +10401,11 @@
           </a:p>
           <a:p>
             <a:pPr marL="342900" indent="-342900">
+              <a:lnSpc>
+                <a:spcPct val="115000"/>
+              </a:lnSpc>
               <a:spcAft>
-                <a:spcPts val="600"/>
+                <a:spcPts val="1000"/>
               </a:spcAft>
               <a:buSzPct val="100000"/>
               <a:buChar char="•"/>
@@ -10278,7 +10413,7 @@
             <a:r>
               <a:rPr lang="en-US" sz="1500" dirty="0">
                 <a:solidFill>
-                  <a:srgbClr val="2A3550"/>
+                  <a:srgbClr val="DCE5F5"/>
                 </a:solidFill>
               </a:rPr>
               <a:t>Explicas como os demonstraste</a:t>
@@ -10287,8 +10422,11 @@
           </a:p>
           <a:p>
             <a:pPr marL="342900" indent="-342900">
+              <a:lnSpc>
+                <a:spcPct val="115000"/>
+              </a:lnSpc>
               <a:spcAft>
-                <a:spcPts val="600"/>
+                <a:spcPts val="1000"/>
               </a:spcAft>
               <a:buSzPct val="100000"/>
               <a:buChar char="•"/>
@@ -10296,7 +10434,7 @@
             <a:r>
               <a:rPr lang="en-US" sz="1500" dirty="0">
                 <a:solidFill>
-                  <a:srgbClr val="2A3550"/>
+                  <a:srgbClr val="DCE5F5"/>
                 </a:solidFill>
               </a:rPr>
               <a:t>A reunião de Equipa decide</a:t>
@@ -10322,11 +10460,11 @@
             </a:avLst>
           </a:prstGeom>
           <a:solidFill>
-            <a:srgbClr val="14213D"/>
+            <a:srgbClr val="3A4D75"/>
           </a:solidFill>
           <a:ln w="12700">
             <a:solidFill>
-              <a:srgbClr val="14213D"/>
+              <a:srgbClr val="3A4D75"/>
             </a:solidFill>
             <a:prstDash val="solid"/>
           </a:ln>
@@ -10393,7 +10531,7 @@
             <a:lvl1pPr>
               <a:defRPr sz="1000">
                 <a:solidFill>
-                  <a:srgbClr val="6B7A90"/>
+                  <a:srgbClr val="8FA3C7"/>
                 </a:solidFill>
               </a:defRPr>
             </a:lvl1pPr>
@@ -10462,7 +10600,7 @@
             <a:r>
               <a:rPr lang="en-US" sz="3200" b="1" dirty="0">
                 <a:solidFill>
-                  <a:schemeClr val="tx1"/>
+                  <a:srgbClr val="FFFFFF"/>
                 </a:solidFill>
               </a:rPr>
               <a:t>Trabalhar num trilho</a:t>
@@ -10479,18 +10617,18 @@
         </p:nvSpPr>
         <p:spPr>
           <a:xfrm>
-            <a:off x="548640" y="1508760"/>
+            <a:off x="548640" y="1600200"/>
             <a:ext cx="566928" cy="566928"/>
           </a:xfrm>
           <a:prstGeom prst="ellipse">
             <a:avLst/>
           </a:prstGeom>
           <a:solidFill>
-            <a:srgbClr val="1D4FA3"/>
+            <a:srgbClr val="2F6BD8"/>
           </a:solidFill>
           <a:ln w="12700">
             <a:solidFill>
-              <a:srgbClr val="1D4FA3"/>
+              <a:srgbClr val="2F6BD8"/>
             </a:solidFill>
             <a:prstDash val="solid"/>
           </a:ln>
@@ -10512,7 +10650,7 @@
         </p:blipFill>
         <p:spPr>
           <a:xfrm>
-            <a:off x="685800" y="1645920"/>
+            <a:off x="685800" y="1737360"/>
             <a:ext cx="292608" cy="292608"/>
           </a:xfrm>
           <a:prstGeom prst="rect">
@@ -10528,8 +10666,8 @@
         </p:nvSpPr>
         <p:spPr>
           <a:xfrm>
-            <a:off x="1325880" y="1472184"/>
-            <a:ext cx="6172200" cy="932688"/>
+            <a:off x="1371600" y="1563624"/>
+            <a:ext cx="6126480" cy="1024128"/>
           </a:xfrm>
           <a:prstGeom prst="rect">
             <a:avLst/>
@@ -10542,15 +10680,18 @@
           <a:lstStyle/>
           <a:p>
             <a:pPr indent="0" marL="0">
+              <a:lnSpc>
+                <a:spcPct val="115000"/>
+              </a:lnSpc>
               <a:spcAft>
-                <a:spcPts val="200"/>
+                <a:spcPts val="400"/>
               </a:spcAft>
               <a:buNone/>
             </a:pPr>
             <a:r>
               <a:rPr lang="en-US" sz="1700" b="1" dirty="0">
                 <a:solidFill>
-                  <a:schemeClr val="tx1"/>
+                  <a:srgbClr val="FFFFFF"/>
                 </a:solidFill>
               </a:rPr>
               <a:t>1. Escolhe «Trabalhar neste trilho»</a:t>
@@ -10559,15 +10700,15 @@
           </a:p>
           <a:p>
             <a:pPr indent="0" marL="0">
-              <a:spcAft>
-                <a:spcPts val="200"/>
-              </a:spcAft>
-              <a:buNone/>
-            </a:pPr>
-            <a:r>
-              <a:rPr lang="en-US" sz="1400" dirty="0">
-                <a:solidFill>
-                  <a:srgbClr val="44506A"/>
+              <a:lnSpc>
+                <a:spcPct val="115000"/>
+              </a:lnSpc>
+              <a:buNone/>
+            </a:pPr>
+            <a:r>
+              <a:rPr lang="en-US" sz="1500" dirty="0">
+                <a:solidFill>
+                  <a:srgbClr val="C9D6EE"/>
                 </a:solidFill>
               </a:rPr>
               <a:t>No topo da página do trilho.</a:t>
@@ -10584,18 +10725,18 @@
         </p:nvSpPr>
         <p:spPr>
           <a:xfrm>
-            <a:off x="548640" y="2532888"/>
+            <a:off x="548640" y="2697480"/>
             <a:ext cx="566928" cy="566928"/>
           </a:xfrm>
           <a:prstGeom prst="ellipse">
             <a:avLst/>
           </a:prstGeom>
           <a:solidFill>
-            <a:srgbClr val="1D4FA3"/>
+            <a:srgbClr val="2F6BD8"/>
           </a:solidFill>
           <a:ln w="12700">
             <a:solidFill>
-              <a:srgbClr val="1D4FA3"/>
+              <a:srgbClr val="2F6BD8"/>
             </a:solidFill>
             <a:prstDash val="solid"/>
           </a:ln>
@@ -10617,7 +10758,7 @@
         </p:blipFill>
         <p:spPr>
           <a:xfrm>
-            <a:off x="685800" y="2670048"/>
+            <a:off x="685800" y="2834640"/>
             <a:ext cx="292608" cy="292608"/>
           </a:xfrm>
           <a:prstGeom prst="rect">
@@ -10633,8 +10774,8 @@
         </p:nvSpPr>
         <p:spPr>
           <a:xfrm>
-            <a:off x="1325880" y="2496312"/>
-            <a:ext cx="6172200" cy="932688"/>
+            <a:off x="1371600" y="2660904"/>
+            <a:ext cx="6126480" cy="1024128"/>
           </a:xfrm>
           <a:prstGeom prst="rect">
             <a:avLst/>
@@ -10647,15 +10788,18 @@
           <a:lstStyle/>
           <a:p>
             <a:pPr indent="0" marL="0">
+              <a:lnSpc>
+                <a:spcPct val="115000"/>
+              </a:lnSpc>
               <a:spcAft>
-                <a:spcPts val="200"/>
+                <a:spcPts val="400"/>
               </a:spcAft>
               <a:buNone/>
             </a:pPr>
             <a:r>
               <a:rPr lang="en-US" sz="1700" b="1" dirty="0">
                 <a:solidFill>
-                  <a:schemeClr val="tx1"/>
+                  <a:srgbClr val="FFFFFF"/>
                 </a:solidFill>
               </a:rPr>
               <a:t>2. Conta como o pensas trabalhar</a:t>
@@ -10664,15 +10808,15 @@
           </a:p>
           <a:p>
             <a:pPr indent="0" marL="0">
-              <a:spcAft>
-                <a:spcPts val="200"/>
-              </a:spcAft>
-              <a:buNone/>
-            </a:pPr>
-            <a:r>
-              <a:rPr lang="en-US" sz="1400" dirty="0">
-                <a:solidFill>
-                  <a:srgbClr val="44506A"/>
+              <a:lnSpc>
+                <a:spcPct val="115000"/>
+              </a:lnSpc>
+              <a:buNone/>
+            </a:pPr>
+            <a:r>
+              <a:rPr lang="en-US" sz="1500" dirty="0">
+                <a:solidFill>
+                  <a:srgbClr val="C9D6EE"/>
                 </a:solidFill>
               </a:rPr>
               <a:t>Opcional: atividades ou oportunidades que queres viver.</a:t>
@@ -10689,18 +10833,18 @@
         </p:nvSpPr>
         <p:spPr>
           <a:xfrm>
-            <a:off x="548640" y="3557016"/>
+            <a:off x="548640" y="3794760"/>
             <a:ext cx="566928" cy="566928"/>
           </a:xfrm>
           <a:prstGeom prst="ellipse">
             <a:avLst/>
           </a:prstGeom>
           <a:solidFill>
-            <a:srgbClr val="1D4FA3"/>
+            <a:srgbClr val="2F6BD8"/>
           </a:solidFill>
           <a:ln w="12700">
             <a:solidFill>
-              <a:srgbClr val="1D4FA3"/>
+              <a:srgbClr val="2F6BD8"/>
             </a:solidFill>
             <a:prstDash val="solid"/>
           </a:ln>
@@ -10722,7 +10866,7 @@
         </p:blipFill>
         <p:spPr>
           <a:xfrm>
-            <a:off x="685800" y="3694176"/>
+            <a:off x="685800" y="3931920"/>
             <a:ext cx="292608" cy="292608"/>
           </a:xfrm>
           <a:prstGeom prst="rect">
@@ -10738,8 +10882,8 @@
         </p:nvSpPr>
         <p:spPr>
           <a:xfrm>
-            <a:off x="1325880" y="3520440"/>
-            <a:ext cx="6172200" cy="932688"/>
+            <a:off x="1371600" y="3758184"/>
+            <a:ext cx="6126480" cy="1024128"/>
           </a:xfrm>
           <a:prstGeom prst="rect">
             <a:avLst/>
@@ -10752,15 +10896,18 @@
           <a:lstStyle/>
           <a:p>
             <a:pPr indent="0" marL="0">
+              <a:lnSpc>
+                <a:spcPct val="115000"/>
+              </a:lnSpc>
               <a:spcAft>
-                <a:spcPts val="200"/>
+                <a:spcPts val="400"/>
               </a:spcAft>
               <a:buNone/>
             </a:pPr>
             <a:r>
               <a:rPr lang="en-US" sz="1700" b="1" dirty="0">
                 <a:solidFill>
-                  <a:schemeClr val="tx1"/>
+                  <a:srgbClr val="FFFFFF"/>
                 </a:solidFill>
               </a:rPr>
               <a:t>3. Carrega em «Propor trabalhar neste trilho»</a:t>
@@ -10769,15 +10916,15 @@
           </a:p>
           <a:p>
             <a:pPr indent="0" marL="0">
-              <a:spcAft>
-                <a:spcPts val="200"/>
-              </a:spcAft>
-              <a:buNone/>
-            </a:pPr>
-            <a:r>
-              <a:rPr lang="en-US" sz="1400" dirty="0">
-                <a:solidFill>
-                  <a:srgbClr val="44506A"/>
+              <a:lnSpc>
+                <a:spcPct val="115000"/>
+              </a:lnSpc>
+              <a:buNone/>
+            </a:pPr>
+            <a:r>
+              <a:rPr lang="en-US" sz="1500" dirty="0">
+                <a:solidFill>
+                  <a:srgbClr val="C9D6EE"/>
                 </a:solidFill>
               </a:rPr>
               <a:t>Os dirigentes recebem logo a tua proposta.</a:t>
@@ -10794,18 +10941,18 @@
         </p:nvSpPr>
         <p:spPr>
           <a:xfrm>
-            <a:off x="548640" y="4581144"/>
+            <a:off x="548640" y="4892040"/>
             <a:ext cx="566928" cy="566928"/>
           </a:xfrm>
           <a:prstGeom prst="ellipse">
             <a:avLst/>
           </a:prstGeom>
           <a:solidFill>
-            <a:srgbClr val="1D4FA3"/>
+            <a:srgbClr val="2F6BD8"/>
           </a:solidFill>
           <a:ln w="12700">
             <a:solidFill>
-              <a:srgbClr val="1D4FA3"/>
+              <a:srgbClr val="2F6BD8"/>
             </a:solidFill>
             <a:prstDash val="solid"/>
           </a:ln>
@@ -10827,7 +10974,7 @@
         </p:blipFill>
         <p:spPr>
           <a:xfrm>
-            <a:off x="685800" y="4718304"/>
+            <a:off x="685800" y="5029200"/>
             <a:ext cx="292608" cy="292608"/>
           </a:xfrm>
           <a:prstGeom prst="rect">
@@ -10843,8 +10990,8 @@
         </p:nvSpPr>
         <p:spPr>
           <a:xfrm>
-            <a:off x="1325880" y="4544568"/>
-            <a:ext cx="6172200" cy="932688"/>
+            <a:off x="1371600" y="4855464"/>
+            <a:ext cx="6126480" cy="1024128"/>
           </a:xfrm>
           <a:prstGeom prst="rect">
             <a:avLst/>
@@ -10857,15 +11004,18 @@
           <a:lstStyle/>
           <a:p>
             <a:pPr indent="0" marL="0">
+              <a:lnSpc>
+                <a:spcPct val="115000"/>
+              </a:lnSpc>
               <a:spcAft>
-                <a:spcPts val="200"/>
+                <a:spcPts val="400"/>
               </a:spcAft>
               <a:buNone/>
             </a:pPr>
             <a:r>
               <a:rPr lang="en-US" sz="1700" b="1" dirty="0">
                 <a:solidFill>
-                  <a:schemeClr val="tx1"/>
+                  <a:srgbClr val="FFFFFF"/>
                 </a:solidFill>
               </a:rPr>
               <a:t>4. A Equipa de Animação responde</a:t>
@@ -10874,15 +11024,15 @@
           </a:p>
           <a:p>
             <a:pPr indent="0" marL="0">
-              <a:spcAft>
-                <a:spcPts val="200"/>
-              </a:spcAft>
-              <a:buNone/>
-            </a:pPr>
-            <a:r>
-              <a:rPr lang="en-US" sz="1400" dirty="0">
-                <a:solidFill>
-                  <a:srgbClr val="44506A"/>
+              <a:lnSpc>
+                <a:spcPct val="115000"/>
+              </a:lnSpc>
+              <a:buNone/>
+            </a:pPr>
+            <a:r>
+              <a:rPr lang="en-US" sz="1500" dirty="0">
+                <a:solidFill>
+                  <a:srgbClr val="C9D6EE"/>
                 </a:solidFill>
               </a:rPr>
               <a:t>Fica «Combinado para a etapa». Podes retirar enquanto espera.</a:t>
@@ -10918,7 +11068,7 @@
             <a:r>
               <a:rPr lang="en-US" sz="1400" i="1" dirty="0">
                 <a:solidFill>
-                  <a:srgbClr val="44506A"/>
+                  <a:srgbClr val="C9D6EE"/>
                 </a:solidFill>
               </a:rPr>
               <a:t>Um trilho por área em cada etapa.</a:t>
@@ -10944,11 +11094,11 @@
             </a:avLst>
           </a:prstGeom>
           <a:solidFill>
-            <a:srgbClr val="14213D"/>
+            <a:srgbClr val="3A4D75"/>
           </a:solidFill>
           <a:ln w="12700">
             <a:solidFill>
-              <a:srgbClr val="14213D"/>
+              <a:srgbClr val="3A4D75"/>
             </a:solidFill>
             <a:prstDash val="solid"/>
           </a:ln>
@@ -11015,7 +11165,7 @@
             <a:lvl1pPr>
               <a:defRPr sz="1000">
                 <a:solidFill>
-                  <a:srgbClr val="6B7A90"/>
+                  <a:srgbClr val="8FA3C7"/>
                 </a:solidFill>
               </a:defRPr>
             </a:lvl1pPr>
@@ -11084,7 +11234,7 @@
             <a:r>
               <a:rPr lang="en-US" sz="3200" b="1" dirty="0">
                 <a:solidFill>
-                  <a:schemeClr val="tx1"/>
+                  <a:srgbClr val="FFFFFF"/>
                 </a:solidFill>
               </a:rPr>
               <a:t>Fechar um trilho</a:t>
@@ -11101,18 +11251,18 @@
         </p:nvSpPr>
         <p:spPr>
           <a:xfrm>
-            <a:off x="548640" y="1508760"/>
+            <a:off x="548640" y="1600200"/>
             <a:ext cx="566928" cy="566928"/>
           </a:xfrm>
           <a:prstGeom prst="ellipse">
             <a:avLst/>
           </a:prstGeom>
           <a:solidFill>
-            <a:srgbClr val="1D4FA3"/>
+            <a:srgbClr val="2F6BD8"/>
           </a:solidFill>
           <a:ln w="12700">
             <a:solidFill>
-              <a:srgbClr val="1D4FA3"/>
+              <a:srgbClr val="2F6BD8"/>
             </a:solidFill>
             <a:prstDash val="solid"/>
           </a:ln>
@@ -11134,7 +11284,7 @@
         </p:blipFill>
         <p:spPr>
           <a:xfrm>
-            <a:off x="685800" y="1645920"/>
+            <a:off x="685800" y="1737360"/>
             <a:ext cx="292608" cy="292608"/>
           </a:xfrm>
           <a:prstGeom prst="rect">
@@ -11150,8 +11300,8 @@
         </p:nvSpPr>
         <p:spPr>
           <a:xfrm>
-            <a:off x="1325880" y="1472184"/>
-            <a:ext cx="6172200" cy="932688"/>
+            <a:off x="1371600" y="1563624"/>
+            <a:ext cx="6126480" cy="1024128"/>
           </a:xfrm>
           <a:prstGeom prst="rect">
             <a:avLst/>
@@ -11164,15 +11314,18 @@
           <a:lstStyle/>
           <a:p>
             <a:pPr indent="0" marL="0">
+              <a:lnSpc>
+                <a:spcPct val="115000"/>
+              </a:lnSpc>
               <a:spcAft>
-                <a:spcPts val="200"/>
+                <a:spcPts val="400"/>
               </a:spcAft>
               <a:buNone/>
             </a:pPr>
             <a:r>
               <a:rPr lang="en-US" sz="1700" b="1" dirty="0">
                 <a:solidFill>
-                  <a:schemeClr val="tx1"/>
+                  <a:srgbClr val="FFFFFF"/>
                 </a:solidFill>
               </a:rPr>
               <a:t>1. Escolhe «Fechar este trilho»</a:t>
@@ -11181,15 +11334,15 @@
           </a:p>
           <a:p>
             <a:pPr indent="0" marL="0">
-              <a:spcAft>
-                <a:spcPts val="200"/>
-              </a:spcAft>
-              <a:buNone/>
-            </a:pPr>
-            <a:r>
-              <a:rPr lang="en-US" sz="1400" dirty="0">
-                <a:solidFill>
-                  <a:srgbClr val="44506A"/>
+              <a:lnSpc>
+                <a:spcPct val="115000"/>
+              </a:lnSpc>
+              <a:buNone/>
+            </a:pPr>
+            <a:r>
+              <a:rPr lang="en-US" sz="1500" dirty="0">
+                <a:solidFill>
+                  <a:srgbClr val="C9D6EE"/>
                 </a:solidFill>
               </a:rPr>
               <a:t>Vês todos os objetivos do trilho.</a:t>
@@ -11206,18 +11359,18 @@
         </p:nvSpPr>
         <p:spPr>
           <a:xfrm>
-            <a:off x="548640" y="2532888"/>
+            <a:off x="548640" y="2697480"/>
             <a:ext cx="566928" cy="566928"/>
           </a:xfrm>
           <a:prstGeom prst="ellipse">
             <a:avLst/>
           </a:prstGeom>
           <a:solidFill>
-            <a:srgbClr val="1D4FA3"/>
+            <a:srgbClr val="2F6BD8"/>
           </a:solidFill>
           <a:ln w="12700">
             <a:solidFill>
-              <a:srgbClr val="1D4FA3"/>
+              <a:srgbClr val="2F6BD8"/>
             </a:solidFill>
             <a:prstDash val="solid"/>
           </a:ln>
@@ -11239,7 +11392,7 @@
         </p:blipFill>
         <p:spPr>
           <a:xfrm>
-            <a:off x="685800" y="2670048"/>
+            <a:off x="685800" y="2834640"/>
             <a:ext cx="292608" cy="292608"/>
           </a:xfrm>
           <a:prstGeom prst="rect">
@@ -11255,8 +11408,8 @@
         </p:nvSpPr>
         <p:spPr>
           <a:xfrm>
-            <a:off x="1325880" y="2496312"/>
-            <a:ext cx="6172200" cy="932688"/>
+            <a:off x="1371600" y="2660904"/>
+            <a:ext cx="6126480" cy="1024128"/>
           </a:xfrm>
           <a:prstGeom prst="rect">
             <a:avLst/>
@@ -11269,15 +11422,18 @@
           <a:lstStyle/>
           <a:p>
             <a:pPr indent="0" marL="0">
+              <a:lnSpc>
+                <a:spcPct val="115000"/>
+              </a:lnSpc>
               <a:spcAft>
-                <a:spcPts val="200"/>
+                <a:spcPts val="400"/>
               </a:spcAft>
               <a:buNone/>
             </a:pPr>
             <a:r>
               <a:rPr lang="en-US" sz="1700" b="1" dirty="0">
                 <a:solidFill>
-                  <a:schemeClr val="tx1"/>
+                  <a:srgbClr val="FFFFFF"/>
                 </a:solidFill>
               </a:rPr>
               <a:t>2. Escreve como os atingiste</a:t>
@@ -11286,15 +11442,15 @@
           </a:p>
           <a:p>
             <a:pPr indent="0" marL="0">
-              <a:spcAft>
-                <a:spcPts val="200"/>
-              </a:spcAft>
-              <a:buNone/>
-            </a:pPr>
-            <a:r>
-              <a:rPr lang="en-US" sz="1400" dirty="0">
-                <a:solidFill>
-                  <a:srgbClr val="44506A"/>
+              <a:lnSpc>
+                <a:spcPct val="115000"/>
+              </a:lnSpc>
+              <a:buNone/>
+            </a:pPr>
+            <a:r>
+              <a:rPr lang="en-US" sz="1500" dirty="0">
+                <a:solidFill>
+                  <a:srgbClr val="C9D6EE"/>
                 </a:solidFill>
               </a:rPr>
               <a:t>O que fizeste, em que situação e o que aprendeste.</a:t>
@@ -11311,18 +11467,18 @@
         </p:nvSpPr>
         <p:spPr>
           <a:xfrm>
-            <a:off x="548640" y="3557016"/>
+            <a:off x="548640" y="3794760"/>
             <a:ext cx="566928" cy="566928"/>
           </a:xfrm>
           <a:prstGeom prst="ellipse">
             <a:avLst/>
           </a:prstGeom>
           <a:solidFill>
-            <a:srgbClr val="1D4FA3"/>
+            <a:srgbClr val="2F6BD8"/>
           </a:solidFill>
           <a:ln w="12700">
             <a:solidFill>
-              <a:srgbClr val="1D4FA3"/>
+              <a:srgbClr val="2F6BD8"/>
             </a:solidFill>
             <a:prstDash val="solid"/>
           </a:ln>
@@ -11344,7 +11500,7 @@
         </p:blipFill>
         <p:spPr>
           <a:xfrm>
-            <a:off x="685800" y="3694176"/>
+            <a:off x="685800" y="3931920"/>
             <a:ext cx="292608" cy="292608"/>
           </a:xfrm>
           <a:prstGeom prst="rect">
@@ -11360,8 +11516,8 @@
         </p:nvSpPr>
         <p:spPr>
           <a:xfrm>
-            <a:off x="1325880" y="3520440"/>
-            <a:ext cx="6172200" cy="932688"/>
+            <a:off x="1371600" y="3758184"/>
+            <a:ext cx="6126480" cy="1024128"/>
           </a:xfrm>
           <a:prstGeom prst="rect">
             <a:avLst/>
@@ -11374,15 +11530,18 @@
           <a:lstStyle/>
           <a:p>
             <a:pPr indent="0" marL="0">
+              <a:lnSpc>
+                <a:spcPct val="115000"/>
+              </a:lnSpc>
               <a:spcAft>
-                <a:spcPts val="200"/>
+                <a:spcPts val="400"/>
               </a:spcAft>
               <a:buNone/>
             </a:pPr>
             <a:r>
               <a:rPr lang="en-US" sz="1700" b="1" dirty="0">
                 <a:solidFill>
-                  <a:schemeClr val="tx1"/>
+                  <a:srgbClr val="FFFFFF"/>
                 </a:solidFill>
               </a:rPr>
               <a:t>3. Junta fotografias (opcional)</a:t>
@@ -11391,15 +11550,15 @@
           </a:p>
           <a:p>
             <a:pPr indent="0" marL="0">
-              <a:spcAft>
-                <a:spcPts val="200"/>
-              </a:spcAft>
-              <a:buNone/>
-            </a:pPr>
-            <a:r>
-              <a:rPr lang="en-US" sz="1400" dirty="0">
-                <a:solidFill>
-                  <a:srgbClr val="44506A"/>
+              <a:lnSpc>
+                <a:spcPct val="115000"/>
+              </a:lnSpc>
+              <a:buNone/>
+            </a:pPr>
+            <a:r>
+              <a:rPr lang="en-US" sz="1500" dirty="0">
+                <a:solidFill>
+                  <a:srgbClr val="C9D6EE"/>
                 </a:solidFill>
               </a:rPr>
               <a:t>Imagens ou PDF que ajudem a mostrar.</a:t>
@@ -11416,18 +11575,18 @@
         </p:nvSpPr>
         <p:spPr>
           <a:xfrm>
-            <a:off x="548640" y="4581144"/>
+            <a:off x="548640" y="4892040"/>
             <a:ext cx="566928" cy="566928"/>
           </a:xfrm>
           <a:prstGeom prst="ellipse">
             <a:avLst/>
           </a:prstGeom>
           <a:solidFill>
-            <a:srgbClr val="1D4FA3"/>
+            <a:srgbClr val="2F6BD8"/>
           </a:solidFill>
           <a:ln w="12700">
             <a:solidFill>
-              <a:srgbClr val="1D4FA3"/>
+              <a:srgbClr val="2F6BD8"/>
             </a:solidFill>
             <a:prstDash val="solid"/>
           </a:ln>
@@ -11449,7 +11608,7 @@
         </p:blipFill>
         <p:spPr>
           <a:xfrm>
-            <a:off x="685800" y="4718304"/>
+            <a:off x="685800" y="5029200"/>
             <a:ext cx="292608" cy="292608"/>
           </a:xfrm>
           <a:prstGeom prst="rect">
@@ -11465,8 +11624,8 @@
         </p:nvSpPr>
         <p:spPr>
           <a:xfrm>
-            <a:off x="1325880" y="4544568"/>
-            <a:ext cx="6172200" cy="932688"/>
+            <a:off x="1371600" y="4855464"/>
+            <a:ext cx="6126480" cy="1024128"/>
           </a:xfrm>
           <a:prstGeom prst="rect">
             <a:avLst/>
@@ -11479,15 +11638,18 @@
           <a:lstStyle/>
           <a:p>
             <a:pPr indent="0" marL="0">
+              <a:lnSpc>
+                <a:spcPct val="115000"/>
+              </a:lnSpc>
               <a:spcAft>
-                <a:spcPts val="200"/>
+                <a:spcPts val="400"/>
               </a:spcAft>
               <a:buNone/>
             </a:pPr>
             <a:r>
               <a:rPr lang="en-US" sz="1700" b="1" dirty="0">
                 <a:solidFill>
-                  <a:schemeClr val="tx1"/>
+                  <a:srgbClr val="FFFFFF"/>
                 </a:solidFill>
               </a:rPr>
               <a:t>4. Carrega em «Pedir validação do trilho»</a:t>
@@ -11496,15 +11658,15 @@
           </a:p>
           <a:p>
             <a:pPr indent="0" marL="0">
-              <a:spcAft>
-                <a:spcPts val="200"/>
-              </a:spcAft>
-              <a:buNone/>
-            </a:pPr>
-            <a:r>
-              <a:rPr lang="en-US" sz="1400" dirty="0">
-                <a:solidFill>
-                  <a:srgbClr val="44506A"/>
+              <a:lnSpc>
+                <a:spcPct val="115000"/>
+              </a:lnSpc>
+              <a:buNone/>
+            </a:pPr>
+            <a:r>
+              <a:rPr lang="en-US" sz="1500" dirty="0">
+                <a:solidFill>
+                  <a:srgbClr val="C9D6EE"/>
                 </a:solidFill>
               </a:rPr>
               <a:t>Fica «Em validação» até à reunião de Equipa.</a:t>
@@ -11540,7 +11702,7 @@
             <a:r>
               <a:rPr lang="en-US" sz="1400" i="1" dirty="0">
                 <a:solidFill>
-                  <a:srgbClr val="44506A"/>
+                  <a:srgbClr val="C9D6EE"/>
                 </a:solidFill>
               </a:rPr>
               <a:t>Enviar não fecha o trilho: só a decisão da reunião de Equipa o valida.</a:t>
@@ -11566,11 +11728,11 @@
             </a:avLst>
           </a:prstGeom>
           <a:solidFill>
-            <a:srgbClr val="14213D"/>
+            <a:srgbClr val="3A4D75"/>
           </a:solidFill>
           <a:ln w="12700">
             <a:solidFill>
-              <a:srgbClr val="14213D"/>
+              <a:srgbClr val="3A4D75"/>
             </a:solidFill>
             <a:prstDash val="solid"/>
           </a:ln>
@@ -11637,7 +11799,7 @@
             <a:lvl1pPr>
               <a:defRPr sz="1000">
                 <a:solidFill>
-                  <a:srgbClr val="6B7A90"/>
+                  <a:srgbClr val="8FA3C7"/>
                 </a:solidFill>
               </a:defRPr>
             </a:lvl1pPr>

</xml_diff>

<commit_message>
Apresentação revista e etapa no Início sem palavras partidas
- Capturas todas no mesmo formato de telemóvel, sem campos em foco e enquadradas no início de cada secção
- Telemóveis na mesma posição, sem tocar no número da página; mais espaço entre passos
- Verificação automática da geometria: margens, sobreposições e proporções
- Início: o nome da etapa no cartão já não se parte a meio da palavra no telemóvel

Co-Authored-By: Claude Opus 5.5 <noreply@anthropic.com>
Claude-Session: https://claude.ai/code/session_01RHnng4HnqckYC12h8qqyAi
</commit_message>
<xml_diff>
--- a/docs/apresentacao/Pioneiros-app-apresentacao.pptx
+++ b/docs/apresentacao/Pioneiros-app-apresentacao.pptx
@@ -123,25 +123,25 @@
   <p:extLst>
     <p:ext uri="{521415D9-36F7-43E2-AB2F-B90AF26B5E84}">
       <p14:sectionLst xmlns:p14="http://schemas.microsoft.com/office/powerpoint/2010/main">
-        <p14:section name="Abertura" id="{dd864e87-9929-ca5d-8c0e-10546947a114}">
+        <p14:section name="Abertura" id="{3d454a78-1572-a805-7bd4-a6462203bb86}">
           <p14:sldIdLst>
             <p14:sldId id="256"/>
             <p14:sldId id="257"/>
           </p14:sldIdLst>
         </p14:section>
-        <p14:section name="Começar" id="{93c5cc62-e24b-ff00-1637-bd0d487f0b27}">
+        <p14:section name="Começar" id="{27b65276-25d4-a14b-e0b0-0e1a66413996}">
           <p14:sldIdLst>
             <p14:sldId id="258"/>
             <p14:sldId id="259"/>
           </p14:sldIdLst>
         </p14:section>
-        <p14:section name="Os teus trilhos" id="{9edac593-ff65-0b20-fd0a-d25ba54dc8c3}">
+        <p14:section name="Os teus trilhos" id="{8cf9cc8f-4c36-caab-18c8-8d6f04ceef2c}">
           <p14:sldIdLst>
             <p14:sldId id="260"/>
             <p14:sldId id="261"/>
           </p14:sldIdLst>
         </p14:section>
-        <p14:section name="Trabalhar e fechar" id="{85c956f4-7797-0cd3-0e2f-0d554da48952}">
+        <p14:section name="Trabalhar e fechar" id="{972add72-f850-2206-0163-976482fc257a}">
           <p14:sldIdLst>
             <p14:sldId id="262"/>
             <p14:sldId id="263"/>
@@ -149,21 +149,21 @@
             <p14:sldId id="265"/>
           </p14:sldIdLst>
         </p14:section>
-        <p14:section name="Acompanhar" id="{dcba1786-9c2f-9ea7-0350-0bfe4d62bc01}">
+        <p14:section name="Acompanhar" id="{a15523e2-4b08-55cb-4d2e-2c4253eb87a7}">
           <p14:sldIdLst>
             <p14:sldId id="266"/>
             <p14:sldId id="267"/>
             <p14:sldId id="268"/>
           </p14:sldIdLst>
         </p14:section>
-        <p14:section name="Mais" id="{1bc90961-8b15-4e02-eeb0-375679aab73f}">
+        <p14:section name="Mais" id="{9d366acd-c32f-6598-724c-ae43d5486945}">
           <p14:sldIdLst>
             <p14:sldId id="269"/>
             <p14:sldId id="270"/>
             <p14:sldId id="271"/>
           </p14:sldIdLst>
         </p14:section>
-        <p14:section name="Fecho" id="{150c3ad5-7f94-7c6a-ce5f-e532a92c3867}">
+        <p14:section name="Fecho" id="{648243a4-1d45-19b0-45ce-d574e909ca2e}">
           <p14:sldIdLst>
             <p14:sldId id="272"/>
           </p14:sldIdLst>
@@ -2237,8 +2237,8 @@
         </p:nvSpPr>
         <p:spPr>
           <a:xfrm>
-            <a:off x="11338560" y="6400800"/>
-            <a:ext cx="548640" cy="274320"/>
+            <a:off x="11064240" y="6355080"/>
+            <a:ext cx="548640" cy="228600"/>
           </a:xfrm>
           <a:prstGeom prst="rect">
             <a:avLst/>
@@ -2307,8 +2307,8 @@
         </p:nvSpPr>
         <p:spPr>
           <a:xfrm>
-            <a:off x="11338560" y="6400800"/>
-            <a:ext cx="548640" cy="274320"/>
+            <a:off x="11064240" y="6355080"/>
+            <a:ext cx="548640" cy="228600"/>
           </a:xfrm>
           <a:prstGeom prst="rect">
             <a:avLst/>
@@ -2763,12 +2763,12 @@
         </p:nvSpPr>
         <p:spPr>
           <a:xfrm>
-            <a:off x="8513064" y="420624"/>
-            <a:ext cx="3040177" cy="6016752"/>
+            <a:off x="8833104" y="484632"/>
+            <a:ext cx="2784283" cy="5833872"/>
           </a:xfrm>
           <a:prstGeom prst="roundRect">
             <a:avLst>
-              <a:gd name="adj" fmla="val 6617"/>
+              <a:gd name="adj" fmla="val 7225"/>
             </a:avLst>
           </a:prstGeom>
           <a:solidFill>
@@ -2805,8 +2805,8 @@
         </p:blipFill>
         <p:spPr>
           <a:xfrm>
-            <a:off x="8595360" y="502920"/>
-            <a:ext cx="2875585" cy="5852160"/>
+            <a:off x="8915400" y="566928"/>
+            <a:ext cx="2619691" cy="5669280"/>
           </a:xfrm>
           <a:prstGeom prst="rect">
             <a:avLst/>
@@ -2934,7 +2934,7 @@
         <p:spPr>
           <a:xfrm>
             <a:off x="1371600" y="1563624"/>
-            <a:ext cx="6126480" cy="1115568"/>
+            <a:ext cx="6126480" cy="868680"/>
           </a:xfrm>
           <a:prstGeom prst="rect">
             <a:avLst/>
@@ -3042,7 +3042,7 @@
         <p:spPr>
           <a:xfrm>
             <a:off x="1371600" y="2752344"/>
-            <a:ext cx="6126480" cy="1115568"/>
+            <a:ext cx="6126480" cy="868680"/>
           </a:xfrm>
           <a:prstGeom prst="rect">
             <a:avLst/>
@@ -3150,7 +3150,7 @@
         <p:spPr>
           <a:xfrm>
             <a:off x="1371600" y="3941064"/>
-            <a:ext cx="6126480" cy="1115568"/>
+            <a:ext cx="6126480" cy="868680"/>
           </a:xfrm>
           <a:prstGeom prst="rect">
             <a:avLst/>
@@ -3307,12 +3307,12 @@
         </p:nvSpPr>
         <p:spPr>
           <a:xfrm>
-            <a:off x="8513064" y="420624"/>
-            <a:ext cx="3040177" cy="6016752"/>
+            <a:off x="8833104" y="484632"/>
+            <a:ext cx="2784283" cy="5833872"/>
           </a:xfrm>
           <a:prstGeom prst="roundRect">
             <a:avLst>
-              <a:gd name="adj" fmla="val 6617"/>
+              <a:gd name="adj" fmla="val 7225"/>
             </a:avLst>
           </a:prstGeom>
           <a:solidFill>
@@ -3349,8 +3349,8 @@
         </p:blipFill>
         <p:spPr>
           <a:xfrm>
-            <a:off x="8595360" y="502920"/>
-            <a:ext cx="2875585" cy="5852160"/>
+            <a:off x="8915400" y="566928"/>
+            <a:ext cx="2619691" cy="5669280"/>
           </a:xfrm>
           <a:prstGeom prst="rect">
             <a:avLst/>
@@ -3369,8 +3369,8 @@
         </p:nvSpPr>
         <p:spPr>
           <a:xfrm>
-            <a:off x="11338560" y="6400800"/>
-            <a:ext cx="548640" cy="274320"/>
+            <a:off x="11064240" y="6355080"/>
+            <a:ext cx="548640" cy="228600"/>
           </a:xfrm>
           <a:prstGeom prst="rect">
             <a:avLst/>
@@ -3580,12 +3580,12 @@
         </p:nvSpPr>
         <p:spPr>
           <a:xfrm>
-            <a:off x="6592824" y="1335024"/>
-            <a:ext cx="2590866" cy="5102352"/>
+            <a:off x="6638544" y="1335024"/>
+            <a:ext cx="2404005" cy="5010912"/>
           </a:xfrm>
           <a:prstGeom prst="roundRect">
             <a:avLst>
-              <a:gd name="adj" fmla="val 7765"/>
+              <a:gd name="adj" fmla="val 8368"/>
             </a:avLst>
           </a:prstGeom>
           <a:solidFill>
@@ -3622,8 +3622,8 @@
         </p:blipFill>
         <p:spPr>
           <a:xfrm>
-            <a:off x="6675120" y="1417320"/>
-            <a:ext cx="2426274" cy="4937760"/>
+            <a:off x="6720840" y="1417320"/>
+            <a:ext cx="2239413" cy="4846320"/>
           </a:xfrm>
           <a:prstGeom prst="rect">
             <a:avLst/>
@@ -3638,12 +3638,12 @@
         </p:nvSpPr>
         <p:spPr>
           <a:xfrm>
-            <a:off x="9290304" y="1335024"/>
-            <a:ext cx="2590866" cy="5102352"/>
+            <a:off x="9198864" y="1335024"/>
+            <a:ext cx="2404005" cy="5010912"/>
           </a:xfrm>
           <a:prstGeom prst="roundRect">
             <a:avLst>
-              <a:gd name="adj" fmla="val 7765"/>
+              <a:gd name="adj" fmla="val 8368"/>
             </a:avLst>
           </a:prstGeom>
           <a:solidFill>
@@ -3680,8 +3680,8 @@
         </p:blipFill>
         <p:spPr>
           <a:xfrm>
-            <a:off x="9372600" y="1417320"/>
-            <a:ext cx="2426274" cy="4937760"/>
+            <a:off x="9281160" y="1417320"/>
+            <a:ext cx="2239413" cy="4846320"/>
           </a:xfrm>
           <a:prstGeom prst="rect">
             <a:avLst/>
@@ -3700,8 +3700,8 @@
         </p:nvSpPr>
         <p:spPr>
           <a:xfrm>
-            <a:off x="11338560" y="6400800"/>
-            <a:ext cx="548640" cy="274320"/>
+            <a:off x="11064240" y="6355080"/>
+            <a:ext cx="548640" cy="228600"/>
           </a:xfrm>
           <a:prstGeom prst="rect">
             <a:avLst/>
@@ -3854,7 +3854,7 @@
         <p:spPr>
           <a:xfrm>
             <a:off x="1371600" y="1563624"/>
-            <a:ext cx="6126480" cy="1024128"/>
+            <a:ext cx="6126480" cy="868680"/>
           </a:xfrm>
           <a:prstGeom prst="rect">
             <a:avLst/>
@@ -3912,7 +3912,7 @@
         </p:nvSpPr>
         <p:spPr>
           <a:xfrm>
-            <a:off x="548640" y="2697480"/>
+            <a:off x="548640" y="2770632"/>
             <a:ext cx="566928" cy="566928"/>
           </a:xfrm>
           <a:prstGeom prst="ellipse">
@@ -3945,7 +3945,7 @@
         </p:blipFill>
         <p:spPr>
           <a:xfrm>
-            <a:off x="685800" y="2834640"/>
+            <a:off x="685800" y="2907792"/>
             <a:ext cx="292608" cy="292608"/>
           </a:xfrm>
           <a:prstGeom prst="rect">
@@ -3961,8 +3961,8 @@
         </p:nvSpPr>
         <p:spPr>
           <a:xfrm>
-            <a:off x="1371600" y="2660904"/>
-            <a:ext cx="6126480" cy="1024128"/>
+            <a:off x="1371600" y="2734056"/>
+            <a:ext cx="6126480" cy="868680"/>
           </a:xfrm>
           <a:prstGeom prst="rect">
             <a:avLst/>
@@ -4020,7 +4020,7 @@
         </p:nvSpPr>
         <p:spPr>
           <a:xfrm>
-            <a:off x="548640" y="3794760"/>
+            <a:off x="548640" y="3941064"/>
             <a:ext cx="566928" cy="566928"/>
           </a:xfrm>
           <a:prstGeom prst="ellipse">
@@ -4053,7 +4053,7 @@
         </p:blipFill>
         <p:spPr>
           <a:xfrm>
-            <a:off x="685800" y="3931920"/>
+            <a:off x="685800" y="4078224"/>
             <a:ext cx="292608" cy="292608"/>
           </a:xfrm>
           <a:prstGeom prst="rect">
@@ -4069,8 +4069,8 @@
         </p:nvSpPr>
         <p:spPr>
           <a:xfrm>
-            <a:off x="1371600" y="3758184"/>
-            <a:ext cx="6126480" cy="1024128"/>
+            <a:off x="1371600" y="3904488"/>
+            <a:ext cx="6126480" cy="868680"/>
           </a:xfrm>
           <a:prstGeom prst="rect">
             <a:avLst/>
@@ -4128,7 +4128,7 @@
         </p:nvSpPr>
         <p:spPr>
           <a:xfrm>
-            <a:off x="548640" y="4892040"/>
+            <a:off x="548640" y="5111496"/>
             <a:ext cx="566928" cy="566928"/>
           </a:xfrm>
           <a:prstGeom prst="ellipse">
@@ -4161,7 +4161,7 @@
         </p:blipFill>
         <p:spPr>
           <a:xfrm>
-            <a:off x="685800" y="5029200"/>
+            <a:off x="685800" y="5248656"/>
             <a:ext cx="292608" cy="292608"/>
           </a:xfrm>
           <a:prstGeom prst="rect">
@@ -4177,8 +4177,8 @@
         </p:nvSpPr>
         <p:spPr>
           <a:xfrm>
-            <a:off x="1371600" y="4855464"/>
-            <a:ext cx="6126480" cy="1024128"/>
+            <a:off x="1371600" y="5074920"/>
+            <a:ext cx="6126480" cy="868680"/>
           </a:xfrm>
           <a:prstGeom prst="rect">
             <a:avLst/>
@@ -4236,12 +4236,12 @@
         </p:nvSpPr>
         <p:spPr>
           <a:xfrm>
-            <a:off x="8513064" y="420624"/>
-            <a:ext cx="3040177" cy="6016752"/>
+            <a:off x="8833104" y="484632"/>
+            <a:ext cx="2784283" cy="5833872"/>
           </a:xfrm>
           <a:prstGeom prst="roundRect">
             <a:avLst>
-              <a:gd name="adj" fmla="val 6617"/>
+              <a:gd name="adj" fmla="val 7225"/>
             </a:avLst>
           </a:prstGeom>
           <a:solidFill>
@@ -4278,8 +4278,8 @@
         </p:blipFill>
         <p:spPr>
           <a:xfrm>
-            <a:off x="8595360" y="502920"/>
-            <a:ext cx="2875585" cy="5852160"/>
+            <a:off x="8915400" y="566928"/>
+            <a:ext cx="2619691" cy="5669280"/>
           </a:xfrm>
           <a:prstGeom prst="rect">
             <a:avLst/>
@@ -4298,8 +4298,8 @@
         </p:nvSpPr>
         <p:spPr>
           <a:xfrm>
-            <a:off x="11338560" y="6400800"/>
-            <a:ext cx="548640" cy="274320"/>
+            <a:off x="11064240" y="6355080"/>
+            <a:ext cx="548640" cy="228600"/>
           </a:xfrm>
           <a:prstGeom prst="rect">
             <a:avLst/>
@@ -4488,7 +4488,7 @@
         <p:spPr>
           <a:xfrm>
             <a:off x="1371600" y="2432304"/>
-            <a:ext cx="6126480" cy="1115568"/>
+            <a:ext cx="6126480" cy="868680"/>
           </a:xfrm>
           <a:prstGeom prst="rect">
             <a:avLst/>
@@ -4596,7 +4596,7 @@
         <p:spPr>
           <a:xfrm>
             <a:off x="1371600" y="3621024"/>
-            <a:ext cx="6126480" cy="1115568"/>
+            <a:ext cx="6126480" cy="868680"/>
           </a:xfrm>
           <a:prstGeom prst="rect">
             <a:avLst/>
@@ -4654,12 +4654,12 @@
         </p:nvSpPr>
         <p:spPr>
           <a:xfrm>
-            <a:off x="8513064" y="420624"/>
-            <a:ext cx="3040177" cy="6016752"/>
+            <a:off x="8833104" y="484632"/>
+            <a:ext cx="2784283" cy="5833872"/>
           </a:xfrm>
           <a:prstGeom prst="roundRect">
             <a:avLst>
-              <a:gd name="adj" fmla="val 6617"/>
+              <a:gd name="adj" fmla="val 7225"/>
             </a:avLst>
           </a:prstGeom>
           <a:solidFill>
@@ -4696,8 +4696,8 @@
         </p:blipFill>
         <p:spPr>
           <a:xfrm>
-            <a:off x="8595360" y="502920"/>
-            <a:ext cx="2875585" cy="5852160"/>
+            <a:off x="8915400" y="566928"/>
+            <a:ext cx="2619691" cy="5669280"/>
           </a:xfrm>
           <a:prstGeom prst="rect">
             <a:avLst/>
@@ -4716,8 +4716,8 @@
         </p:nvSpPr>
         <p:spPr>
           <a:xfrm>
-            <a:off x="11338560" y="6400800"/>
-            <a:ext cx="548640" cy="274320"/>
+            <a:off x="11064240" y="6355080"/>
+            <a:ext cx="548640" cy="228600"/>
           </a:xfrm>
           <a:prstGeom prst="rect">
             <a:avLst/>
@@ -4870,7 +4870,7 @@
         <p:spPr>
           <a:xfrm>
             <a:off x="1371600" y="1563624"/>
-            <a:ext cx="6126480" cy="1115568"/>
+            <a:ext cx="6126480" cy="868680"/>
           </a:xfrm>
           <a:prstGeom prst="rect">
             <a:avLst/>
@@ -4978,7 +4978,7 @@
         <p:spPr>
           <a:xfrm>
             <a:off x="1371600" y="2752344"/>
-            <a:ext cx="6126480" cy="1115568"/>
+            <a:ext cx="6126480" cy="868680"/>
           </a:xfrm>
           <a:prstGeom prst="rect">
             <a:avLst/>
@@ -5086,7 +5086,7 @@
         <p:spPr>
           <a:xfrm>
             <a:off x="1371600" y="3941064"/>
-            <a:ext cx="6126480" cy="1115568"/>
+            <a:ext cx="6126480" cy="868680"/>
           </a:xfrm>
           <a:prstGeom prst="rect">
             <a:avLst/>
@@ -5144,12 +5144,12 @@
         </p:nvSpPr>
         <p:spPr>
           <a:xfrm>
-            <a:off x="8513064" y="420624"/>
-            <a:ext cx="3040177" cy="6016752"/>
+            <a:off x="8833104" y="484632"/>
+            <a:ext cx="2784283" cy="5833872"/>
           </a:xfrm>
           <a:prstGeom prst="roundRect">
             <a:avLst>
-              <a:gd name="adj" fmla="val 6617"/>
+              <a:gd name="adj" fmla="val 7225"/>
             </a:avLst>
           </a:prstGeom>
           <a:solidFill>
@@ -5186,8 +5186,8 @@
         </p:blipFill>
         <p:spPr>
           <a:xfrm>
-            <a:off x="8595360" y="502920"/>
-            <a:ext cx="2875585" cy="5852160"/>
+            <a:off x="8915400" y="566928"/>
+            <a:ext cx="2619691" cy="5669280"/>
           </a:xfrm>
           <a:prstGeom prst="rect">
             <a:avLst/>
@@ -5206,8 +5206,8 @@
         </p:nvSpPr>
         <p:spPr>
           <a:xfrm>
-            <a:off x="11338560" y="6400800"/>
-            <a:ext cx="548640" cy="274320"/>
+            <a:off x="11064240" y="6355080"/>
+            <a:ext cx="548640" cy="228600"/>
           </a:xfrm>
           <a:prstGeom prst="rect">
             <a:avLst/>
@@ -5360,7 +5360,7 @@
         <p:spPr>
           <a:xfrm>
             <a:off x="1371600" y="1563624"/>
-            <a:ext cx="6126480" cy="1115568"/>
+            <a:ext cx="6126480" cy="868680"/>
           </a:xfrm>
           <a:prstGeom prst="rect">
             <a:avLst/>
@@ -5468,7 +5468,7 @@
         <p:spPr>
           <a:xfrm>
             <a:off x="1371600" y="2752344"/>
-            <a:ext cx="6126480" cy="1115568"/>
+            <a:ext cx="6126480" cy="868680"/>
           </a:xfrm>
           <a:prstGeom prst="rect">
             <a:avLst/>
@@ -5576,7 +5576,7 @@
         <p:spPr>
           <a:xfrm>
             <a:off x="1371600" y="3941064"/>
-            <a:ext cx="6126480" cy="1115568"/>
+            <a:ext cx="6126480" cy="868680"/>
           </a:xfrm>
           <a:prstGeom prst="rect">
             <a:avLst/>
@@ -5634,12 +5634,12 @@
         </p:nvSpPr>
         <p:spPr>
           <a:xfrm>
-            <a:off x="8513064" y="420624"/>
-            <a:ext cx="3040177" cy="6016752"/>
+            <a:off x="8833104" y="484632"/>
+            <a:ext cx="2784283" cy="5833872"/>
           </a:xfrm>
           <a:prstGeom prst="roundRect">
             <a:avLst>
-              <a:gd name="adj" fmla="val 6617"/>
+              <a:gd name="adj" fmla="val 7225"/>
             </a:avLst>
           </a:prstGeom>
           <a:solidFill>
@@ -5676,8 +5676,8 @@
         </p:blipFill>
         <p:spPr>
           <a:xfrm>
-            <a:off x="8595360" y="502920"/>
-            <a:ext cx="2875585" cy="5852160"/>
+            <a:off x="8915400" y="566928"/>
+            <a:ext cx="2619691" cy="5669280"/>
           </a:xfrm>
           <a:prstGeom prst="rect">
             <a:avLst/>
@@ -5696,8 +5696,8 @@
         </p:nvSpPr>
         <p:spPr>
           <a:xfrm>
-            <a:off x="11338560" y="6400800"/>
-            <a:ext cx="548640" cy="274320"/>
+            <a:off x="11064240" y="6355080"/>
+            <a:ext cx="548640" cy="228600"/>
           </a:xfrm>
           <a:prstGeom prst="rect">
             <a:avLst/>
@@ -5958,12 +5958,12 @@
         </p:nvSpPr>
         <p:spPr>
           <a:xfrm>
-            <a:off x="6592824" y="1335024"/>
-            <a:ext cx="2590866" cy="5102352"/>
+            <a:off x="6638544" y="1335024"/>
+            <a:ext cx="2404005" cy="5010912"/>
           </a:xfrm>
           <a:prstGeom prst="roundRect">
             <a:avLst>
-              <a:gd name="adj" fmla="val 7765"/>
+              <a:gd name="adj" fmla="val 8368"/>
             </a:avLst>
           </a:prstGeom>
           <a:solidFill>
@@ -6000,8 +6000,8 @@
         </p:blipFill>
         <p:spPr>
           <a:xfrm>
-            <a:off x="6675120" y="1417320"/>
-            <a:ext cx="2426274" cy="4937760"/>
+            <a:off x="6720840" y="1417320"/>
+            <a:ext cx="2239413" cy="4846320"/>
           </a:xfrm>
           <a:prstGeom prst="rect">
             <a:avLst/>
@@ -6016,12 +6016,12 @@
         </p:nvSpPr>
         <p:spPr>
           <a:xfrm>
-            <a:off x="9290304" y="1335024"/>
-            <a:ext cx="2590866" cy="5102352"/>
+            <a:off x="9198864" y="1335024"/>
+            <a:ext cx="2404005" cy="5010912"/>
           </a:xfrm>
           <a:prstGeom prst="roundRect">
             <a:avLst>
-              <a:gd name="adj" fmla="val 7765"/>
+              <a:gd name="adj" fmla="val 8368"/>
             </a:avLst>
           </a:prstGeom>
           <a:solidFill>
@@ -6058,8 +6058,8 @@
         </p:blipFill>
         <p:spPr>
           <a:xfrm>
-            <a:off x="9372600" y="1417320"/>
-            <a:ext cx="2426274" cy="4937760"/>
+            <a:off x="9281160" y="1417320"/>
+            <a:ext cx="2239413" cy="4846320"/>
           </a:xfrm>
           <a:prstGeom prst="rect">
             <a:avLst/>
@@ -6078,8 +6078,8 @@
         </p:nvSpPr>
         <p:spPr>
           <a:xfrm>
-            <a:off x="11338560" y="6400800"/>
-            <a:ext cx="548640" cy="274320"/>
+            <a:off x="11064240" y="6355080"/>
+            <a:ext cx="548640" cy="228600"/>
           </a:xfrm>
           <a:prstGeom prst="rect">
             <a:avLst/>
@@ -6220,8 +6220,8 @@
         </p:nvSpPr>
         <p:spPr>
           <a:xfrm>
-            <a:off x="731520" y="5212080"/>
-            <a:ext cx="822960" cy="822960"/>
+            <a:off x="731520" y="5349240"/>
+            <a:ext cx="685800" cy="685800"/>
           </a:xfrm>
           <a:prstGeom prst="ellipse">
             <a:avLst/>
@@ -6253,8 +6253,8 @@
         </p:blipFill>
         <p:spPr>
           <a:xfrm>
-            <a:off x="932688" y="5413248"/>
-            <a:ext cx="420624" cy="420624"/>
+            <a:off x="900684" y="5518404"/>
+            <a:ext cx="347472" cy="347472"/>
           </a:xfrm>
           <a:prstGeom prst="rect">
             <a:avLst/>
@@ -6269,8 +6269,8 @@
         </p:nvSpPr>
         <p:spPr>
           <a:xfrm>
-            <a:off x="365760" y="6126480"/>
-            <a:ext cx="1554480" cy="365760"/>
+            <a:off x="297180" y="6053328"/>
+            <a:ext cx="1554480" cy="274320"/>
           </a:xfrm>
           <a:prstGeom prst="rect">
             <a:avLst/>
@@ -6305,8 +6305,8 @@
         </p:nvSpPr>
         <p:spPr>
           <a:xfrm>
-            <a:off x="2880360" y="5212080"/>
-            <a:ext cx="822960" cy="822960"/>
+            <a:off x="2880360" y="5349240"/>
+            <a:ext cx="685800" cy="685800"/>
           </a:xfrm>
           <a:prstGeom prst="ellipse">
             <a:avLst/>
@@ -6338,8 +6338,8 @@
         </p:blipFill>
         <p:spPr>
           <a:xfrm>
-            <a:off x="3081528" y="5413248"/>
-            <a:ext cx="420624" cy="420624"/>
+            <a:off x="3049524" y="5518404"/>
+            <a:ext cx="347472" cy="347472"/>
           </a:xfrm>
           <a:prstGeom prst="rect">
             <a:avLst/>
@@ -6354,8 +6354,8 @@
         </p:nvSpPr>
         <p:spPr>
           <a:xfrm>
-            <a:off x="2514600" y="6126480"/>
-            <a:ext cx="1554480" cy="365760"/>
+            <a:off x="2446020" y="6053328"/>
+            <a:ext cx="1554480" cy="274320"/>
           </a:xfrm>
           <a:prstGeom prst="rect">
             <a:avLst/>
@@ -6390,8 +6390,8 @@
         </p:nvSpPr>
         <p:spPr>
           <a:xfrm>
-            <a:off x="5029200" y="5212080"/>
-            <a:ext cx="822960" cy="822960"/>
+            <a:off x="5029200" y="5349240"/>
+            <a:ext cx="685800" cy="685800"/>
           </a:xfrm>
           <a:prstGeom prst="ellipse">
             <a:avLst/>
@@ -6423,8 +6423,8 @@
         </p:blipFill>
         <p:spPr>
           <a:xfrm>
-            <a:off x="5230368" y="5413248"/>
-            <a:ext cx="420624" cy="420624"/>
+            <a:off x="5198364" y="5518404"/>
+            <a:ext cx="347472" cy="347472"/>
           </a:xfrm>
           <a:prstGeom prst="rect">
             <a:avLst/>
@@ -6439,8 +6439,8 @@
         </p:nvSpPr>
         <p:spPr>
           <a:xfrm>
-            <a:off x="4663440" y="6126480"/>
-            <a:ext cx="1554480" cy="365760"/>
+            <a:off x="4594860" y="6053328"/>
+            <a:ext cx="1554480" cy="274320"/>
           </a:xfrm>
           <a:prstGeom prst="rect">
             <a:avLst/>
@@ -6475,8 +6475,8 @@
         </p:nvSpPr>
         <p:spPr>
           <a:xfrm>
-            <a:off x="7178040" y="5212080"/>
-            <a:ext cx="822960" cy="822960"/>
+            <a:off x="7178040" y="5349240"/>
+            <a:ext cx="685800" cy="685800"/>
           </a:xfrm>
           <a:prstGeom prst="ellipse">
             <a:avLst/>
@@ -6508,8 +6508,8 @@
         </p:blipFill>
         <p:spPr>
           <a:xfrm>
-            <a:off x="7379208" y="5413248"/>
-            <a:ext cx="420624" cy="420624"/>
+            <a:off x="7347204" y="5518404"/>
+            <a:ext cx="347472" cy="347472"/>
           </a:xfrm>
           <a:prstGeom prst="rect">
             <a:avLst/>
@@ -6524,8 +6524,8 @@
         </p:nvSpPr>
         <p:spPr>
           <a:xfrm>
-            <a:off x="6812280" y="6126480"/>
-            <a:ext cx="1554480" cy="365760"/>
+            <a:off x="6743700" y="6053328"/>
+            <a:ext cx="1554480" cy="274320"/>
           </a:xfrm>
           <a:prstGeom prst="rect">
             <a:avLst/>
@@ -6560,8 +6560,8 @@
         </p:nvSpPr>
         <p:spPr>
           <a:xfrm>
-            <a:off x="9326880" y="5212080"/>
-            <a:ext cx="822960" cy="822960"/>
+            <a:off x="9326880" y="5349240"/>
+            <a:ext cx="685800" cy="685800"/>
           </a:xfrm>
           <a:prstGeom prst="ellipse">
             <a:avLst/>
@@ -6593,8 +6593,8 @@
         </p:blipFill>
         <p:spPr>
           <a:xfrm>
-            <a:off x="9528048" y="5413248"/>
-            <a:ext cx="420624" cy="420624"/>
+            <a:off x="9496044" y="5518404"/>
+            <a:ext cx="347472" cy="347472"/>
           </a:xfrm>
           <a:prstGeom prst="rect">
             <a:avLst/>
@@ -6609,8 +6609,8 @@
         </p:nvSpPr>
         <p:spPr>
           <a:xfrm>
-            <a:off x="8961120" y="6126480"/>
-            <a:ext cx="1554480" cy="365760"/>
+            <a:off x="8892540" y="6053328"/>
+            <a:ext cx="1554480" cy="274320"/>
           </a:xfrm>
           <a:prstGeom prst="rect">
             <a:avLst/>
@@ -6645,7 +6645,7 @@
         </p:nvSpPr>
         <p:spPr>
           <a:xfrm>
-            <a:off x="731520" y="4617720"/>
+            <a:off x="731520" y="4892040"/>
             <a:ext cx="10058400" cy="320040"/>
           </a:xfrm>
           <a:prstGeom prst="rect">
@@ -6794,7 +6794,7 @@
         <p:spPr>
           <a:xfrm>
             <a:off x="1371600" y="1563624"/>
-            <a:ext cx="6126480" cy="1024128"/>
+            <a:ext cx="6126480" cy="868680"/>
           </a:xfrm>
           <a:prstGeom prst="rect">
             <a:avLst/>
@@ -6852,7 +6852,7 @@
         </p:nvSpPr>
         <p:spPr>
           <a:xfrm>
-            <a:off x="548640" y="2697480"/>
+            <a:off x="548640" y="2770632"/>
             <a:ext cx="566928" cy="566928"/>
           </a:xfrm>
           <a:prstGeom prst="ellipse">
@@ -6885,7 +6885,7 @@
         </p:blipFill>
         <p:spPr>
           <a:xfrm>
-            <a:off x="685800" y="2834640"/>
+            <a:off x="685800" y="2907792"/>
             <a:ext cx="292608" cy="292608"/>
           </a:xfrm>
           <a:prstGeom prst="rect">
@@ -6901,8 +6901,8 @@
         </p:nvSpPr>
         <p:spPr>
           <a:xfrm>
-            <a:off x="1371600" y="2660904"/>
-            <a:ext cx="6126480" cy="1024128"/>
+            <a:off x="1371600" y="2734056"/>
+            <a:ext cx="6126480" cy="868680"/>
           </a:xfrm>
           <a:prstGeom prst="rect">
             <a:avLst/>
@@ -6960,7 +6960,7 @@
         </p:nvSpPr>
         <p:spPr>
           <a:xfrm>
-            <a:off x="548640" y="3794760"/>
+            <a:off x="548640" y="3941064"/>
             <a:ext cx="566928" cy="566928"/>
           </a:xfrm>
           <a:prstGeom prst="ellipse">
@@ -6993,7 +6993,7 @@
         </p:blipFill>
         <p:spPr>
           <a:xfrm>
-            <a:off x="685800" y="3931920"/>
+            <a:off x="685800" y="4078224"/>
             <a:ext cx="292608" cy="292608"/>
           </a:xfrm>
           <a:prstGeom prst="rect">
@@ -7009,8 +7009,8 @@
         </p:nvSpPr>
         <p:spPr>
           <a:xfrm>
-            <a:off x="1371600" y="3758184"/>
-            <a:ext cx="6126480" cy="1024128"/>
+            <a:off x="1371600" y="3904488"/>
+            <a:ext cx="6126480" cy="868680"/>
           </a:xfrm>
           <a:prstGeom prst="rect">
             <a:avLst/>
@@ -7068,7 +7068,7 @@
         </p:nvSpPr>
         <p:spPr>
           <a:xfrm>
-            <a:off x="548640" y="4892040"/>
+            <a:off x="548640" y="5111496"/>
             <a:ext cx="566928" cy="566928"/>
           </a:xfrm>
           <a:prstGeom prst="ellipse">
@@ -7101,7 +7101,7 @@
         </p:blipFill>
         <p:spPr>
           <a:xfrm>
-            <a:off x="685800" y="5029200"/>
+            <a:off x="685800" y="5248656"/>
             <a:ext cx="292608" cy="292608"/>
           </a:xfrm>
           <a:prstGeom prst="rect">
@@ -7117,8 +7117,8 @@
         </p:nvSpPr>
         <p:spPr>
           <a:xfrm>
-            <a:off x="1371600" y="4855464"/>
-            <a:ext cx="6126480" cy="1024128"/>
+            <a:off x="1371600" y="5074920"/>
+            <a:ext cx="6126480" cy="868680"/>
           </a:xfrm>
           <a:prstGeom prst="rect">
             <a:avLst/>
@@ -7239,8 +7239,8 @@
         </p:nvSpPr>
         <p:spPr>
           <a:xfrm>
-            <a:off x="8138160" y="2926080"/>
-            <a:ext cx="3474720" cy="457200"/>
+            <a:off x="8138160" y="3017520"/>
+            <a:ext cx="3474720" cy="411480"/>
           </a:xfrm>
           <a:prstGeom prst="rect">
             <a:avLst/>
@@ -7365,8 +7365,8 @@
         </p:nvSpPr>
         <p:spPr>
           <a:xfrm>
-            <a:off x="11338560" y="6400800"/>
-            <a:ext cx="548640" cy="274320"/>
+            <a:off x="11064240" y="6355080"/>
+            <a:ext cx="548640" cy="228600"/>
           </a:xfrm>
           <a:prstGeom prst="rect">
             <a:avLst/>
@@ -7519,7 +7519,7 @@
         <p:spPr>
           <a:xfrm>
             <a:off x="1371600" y="1563624"/>
-            <a:ext cx="5212080" cy="1024128"/>
+            <a:ext cx="4937760" cy="868680"/>
           </a:xfrm>
           <a:prstGeom prst="rect">
             <a:avLst/>
@@ -7577,7 +7577,7 @@
         </p:nvSpPr>
         <p:spPr>
           <a:xfrm>
-            <a:off x="548640" y="2697480"/>
+            <a:off x="548640" y="2770632"/>
             <a:ext cx="566928" cy="566928"/>
           </a:xfrm>
           <a:prstGeom prst="ellipse">
@@ -7610,7 +7610,7 @@
         </p:blipFill>
         <p:spPr>
           <a:xfrm>
-            <a:off x="685800" y="2834640"/>
+            <a:off x="685800" y="2907792"/>
             <a:ext cx="292608" cy="292608"/>
           </a:xfrm>
           <a:prstGeom prst="rect">
@@ -7626,8 +7626,8 @@
         </p:nvSpPr>
         <p:spPr>
           <a:xfrm>
-            <a:off x="1371600" y="2660904"/>
-            <a:ext cx="5212080" cy="1024128"/>
+            <a:off x="1371600" y="2734056"/>
+            <a:ext cx="4937760" cy="868680"/>
           </a:xfrm>
           <a:prstGeom prst="rect">
             <a:avLst/>
@@ -7685,7 +7685,7 @@
         </p:nvSpPr>
         <p:spPr>
           <a:xfrm>
-            <a:off x="548640" y="3794760"/>
+            <a:off x="548640" y="3941064"/>
             <a:ext cx="566928" cy="566928"/>
           </a:xfrm>
           <a:prstGeom prst="ellipse">
@@ -7718,7 +7718,7 @@
         </p:blipFill>
         <p:spPr>
           <a:xfrm>
-            <a:off x="685800" y="3931920"/>
+            <a:off x="685800" y="4078224"/>
             <a:ext cx="292608" cy="292608"/>
           </a:xfrm>
           <a:prstGeom prst="rect">
@@ -7734,8 +7734,8 @@
         </p:nvSpPr>
         <p:spPr>
           <a:xfrm>
-            <a:off x="1371600" y="3758184"/>
-            <a:ext cx="5212080" cy="1024128"/>
+            <a:off x="1371600" y="3904488"/>
+            <a:ext cx="4937760" cy="868680"/>
           </a:xfrm>
           <a:prstGeom prst="rect">
             <a:avLst/>
@@ -7793,7 +7793,7 @@
         </p:nvSpPr>
         <p:spPr>
           <a:xfrm>
-            <a:off x="548640" y="4892040"/>
+            <a:off x="548640" y="5111496"/>
             <a:ext cx="566928" cy="566928"/>
           </a:xfrm>
           <a:prstGeom prst="ellipse">
@@ -7826,7 +7826,7 @@
         </p:blipFill>
         <p:spPr>
           <a:xfrm>
-            <a:off x="685800" y="5029200"/>
+            <a:off x="685800" y="5248656"/>
             <a:ext cx="292608" cy="292608"/>
           </a:xfrm>
           <a:prstGeom prst="rect">
@@ -7842,8 +7842,8 @@
         </p:nvSpPr>
         <p:spPr>
           <a:xfrm>
-            <a:off x="1371600" y="4855464"/>
-            <a:ext cx="5212080" cy="1024128"/>
+            <a:off x="1371600" y="5074920"/>
+            <a:ext cx="4937760" cy="868680"/>
           </a:xfrm>
           <a:prstGeom prst="rect">
             <a:avLst/>
@@ -7901,12 +7901,12 @@
         </p:nvSpPr>
         <p:spPr>
           <a:xfrm>
-            <a:off x="7187184" y="1197864"/>
-            <a:ext cx="2319499" cy="4828032"/>
+            <a:off x="6638544" y="1335024"/>
+            <a:ext cx="2404005" cy="5010912"/>
           </a:xfrm>
           <a:prstGeom prst="roundRect">
             <a:avLst>
-              <a:gd name="adj" fmla="val 8673"/>
+              <a:gd name="adj" fmla="val 8368"/>
             </a:avLst>
           </a:prstGeom>
           <a:solidFill>
@@ -7943,8 +7943,8 @@
         </p:blipFill>
         <p:spPr>
           <a:xfrm>
-            <a:off x="7269480" y="1280160"/>
-            <a:ext cx="2154907" cy="4663440"/>
+            <a:off x="6720840" y="1417320"/>
+            <a:ext cx="2239413" cy="4846320"/>
           </a:xfrm>
           <a:prstGeom prst="rect">
             <a:avLst/>
@@ -7959,12 +7959,12 @@
         </p:nvSpPr>
         <p:spPr>
           <a:xfrm>
-            <a:off x="9610344" y="1197864"/>
-            <a:ext cx="2319499" cy="4828032"/>
+            <a:off x="9198864" y="1335024"/>
+            <a:ext cx="2404005" cy="5010912"/>
           </a:xfrm>
           <a:prstGeom prst="roundRect">
             <a:avLst>
-              <a:gd name="adj" fmla="val 8673"/>
+              <a:gd name="adj" fmla="val 8368"/>
             </a:avLst>
           </a:prstGeom>
           <a:solidFill>
@@ -8001,8 +8001,8 @@
         </p:blipFill>
         <p:spPr>
           <a:xfrm>
-            <a:off x="9692640" y="1280160"/>
-            <a:ext cx="2154907" cy="4663440"/>
+            <a:off x="9281160" y="1417320"/>
+            <a:ext cx="2239413" cy="4846320"/>
           </a:xfrm>
           <a:prstGeom prst="rect">
             <a:avLst/>
@@ -8021,8 +8021,8 @@
         </p:nvSpPr>
         <p:spPr>
           <a:xfrm>
-            <a:off x="11338560" y="6400800"/>
-            <a:ext cx="548640" cy="274320"/>
+            <a:off x="11064240" y="6355080"/>
+            <a:ext cx="548640" cy="228600"/>
           </a:xfrm>
           <a:prstGeom prst="rect">
             <a:avLst/>
@@ -8175,7 +8175,7 @@
         <p:spPr>
           <a:xfrm>
             <a:off x="1371600" y="1563624"/>
-            <a:ext cx="6126480" cy="1024128"/>
+            <a:ext cx="6126480" cy="868680"/>
           </a:xfrm>
           <a:prstGeom prst="rect">
             <a:avLst/>
@@ -8233,7 +8233,7 @@
         </p:nvSpPr>
         <p:spPr>
           <a:xfrm>
-            <a:off x="548640" y="2697480"/>
+            <a:off x="548640" y="2770632"/>
             <a:ext cx="566928" cy="566928"/>
           </a:xfrm>
           <a:prstGeom prst="ellipse">
@@ -8266,7 +8266,7 @@
         </p:blipFill>
         <p:spPr>
           <a:xfrm>
-            <a:off x="685800" y="2834640"/>
+            <a:off x="685800" y="2907792"/>
             <a:ext cx="292608" cy="292608"/>
           </a:xfrm>
           <a:prstGeom prst="rect">
@@ -8282,8 +8282,8 @@
         </p:nvSpPr>
         <p:spPr>
           <a:xfrm>
-            <a:off x="1371600" y="2660904"/>
-            <a:ext cx="6126480" cy="1024128"/>
+            <a:off x="1371600" y="2734056"/>
+            <a:ext cx="6126480" cy="868680"/>
           </a:xfrm>
           <a:prstGeom prst="rect">
             <a:avLst/>
@@ -8341,7 +8341,7 @@
         </p:nvSpPr>
         <p:spPr>
           <a:xfrm>
-            <a:off x="548640" y="3794760"/>
+            <a:off x="548640" y="3941064"/>
             <a:ext cx="566928" cy="566928"/>
           </a:xfrm>
           <a:prstGeom prst="ellipse">
@@ -8374,7 +8374,7 @@
         </p:blipFill>
         <p:spPr>
           <a:xfrm>
-            <a:off x="685800" y="3931920"/>
+            <a:off x="685800" y="4078224"/>
             <a:ext cx="292608" cy="292608"/>
           </a:xfrm>
           <a:prstGeom prst="rect">
@@ -8390,8 +8390,8 @@
         </p:nvSpPr>
         <p:spPr>
           <a:xfrm>
-            <a:off x="1371600" y="3758184"/>
-            <a:ext cx="6126480" cy="1024128"/>
+            <a:off x="1371600" y="3904488"/>
+            <a:ext cx="6126480" cy="868680"/>
           </a:xfrm>
           <a:prstGeom prst="rect">
             <a:avLst/>
@@ -8449,7 +8449,7 @@
         </p:nvSpPr>
         <p:spPr>
           <a:xfrm>
-            <a:off x="548640" y="4892040"/>
+            <a:off x="548640" y="5111496"/>
             <a:ext cx="566928" cy="566928"/>
           </a:xfrm>
           <a:prstGeom prst="ellipse">
@@ -8482,7 +8482,7 @@
         </p:blipFill>
         <p:spPr>
           <a:xfrm>
-            <a:off x="685800" y="5029200"/>
+            <a:off x="685800" y="5248656"/>
             <a:ext cx="292608" cy="292608"/>
           </a:xfrm>
           <a:prstGeom prst="rect">
@@ -8498,8 +8498,8 @@
         </p:nvSpPr>
         <p:spPr>
           <a:xfrm>
-            <a:off x="1371600" y="4855464"/>
-            <a:ext cx="6126480" cy="1024128"/>
+            <a:off x="1371600" y="5074920"/>
+            <a:ext cx="6126480" cy="868680"/>
           </a:xfrm>
           <a:prstGeom prst="rect">
             <a:avLst/>
@@ -8557,12 +8557,12 @@
         </p:nvSpPr>
         <p:spPr>
           <a:xfrm>
-            <a:off x="8513064" y="420624"/>
-            <a:ext cx="3040177" cy="6016752"/>
+            <a:off x="8833104" y="484632"/>
+            <a:ext cx="2784283" cy="5833872"/>
           </a:xfrm>
           <a:prstGeom prst="roundRect">
             <a:avLst>
-              <a:gd name="adj" fmla="val 6617"/>
+              <a:gd name="adj" fmla="val 7225"/>
             </a:avLst>
           </a:prstGeom>
           <a:solidFill>
@@ -8599,8 +8599,8 @@
         </p:blipFill>
         <p:spPr>
           <a:xfrm>
-            <a:off x="8595360" y="502920"/>
-            <a:ext cx="2875585" cy="5852160"/>
+            <a:off x="8915400" y="566928"/>
+            <a:ext cx="2619691" cy="5669280"/>
           </a:xfrm>
           <a:prstGeom prst="rect">
             <a:avLst/>
@@ -8619,8 +8619,8 @@
         </p:nvSpPr>
         <p:spPr>
           <a:xfrm>
-            <a:off x="11338560" y="6400800"/>
-            <a:ext cx="548640" cy="274320"/>
+            <a:off x="11064240" y="6355080"/>
+            <a:ext cx="548640" cy="228600"/>
           </a:xfrm>
           <a:prstGeom prst="rect">
             <a:avLst/>
@@ -9257,12 +9257,12 @@
         </p:nvSpPr>
         <p:spPr>
           <a:xfrm>
-            <a:off x="8513064" y="420624"/>
-            <a:ext cx="3040177" cy="6016752"/>
+            <a:off x="8833104" y="484632"/>
+            <a:ext cx="2784283" cy="5833872"/>
           </a:xfrm>
           <a:prstGeom prst="roundRect">
             <a:avLst>
-              <a:gd name="adj" fmla="val 6617"/>
+              <a:gd name="adj" fmla="val 7225"/>
             </a:avLst>
           </a:prstGeom>
           <a:solidFill>
@@ -9299,8 +9299,8 @@
         </p:blipFill>
         <p:spPr>
           <a:xfrm>
-            <a:off x="8595360" y="502920"/>
-            <a:ext cx="2875585" cy="5852160"/>
+            <a:off x="8915400" y="566928"/>
+            <a:ext cx="2619691" cy="5669280"/>
           </a:xfrm>
           <a:prstGeom prst="rect">
             <a:avLst/>
@@ -9319,8 +9319,8 @@
         </p:nvSpPr>
         <p:spPr>
           <a:xfrm>
-            <a:off x="11338560" y="6400800"/>
-            <a:ext cx="548640" cy="274320"/>
+            <a:off x="11064240" y="6355080"/>
+            <a:ext cx="548640" cy="228600"/>
           </a:xfrm>
           <a:prstGeom prst="rect">
             <a:avLst/>
@@ -9891,12 +9891,12 @@
         </p:nvSpPr>
         <p:spPr>
           <a:xfrm>
-            <a:off x="8513064" y="420624"/>
-            <a:ext cx="3040177" cy="6016752"/>
+            <a:off x="8833104" y="484632"/>
+            <a:ext cx="2784283" cy="5833872"/>
           </a:xfrm>
           <a:prstGeom prst="roundRect">
             <a:avLst>
-              <a:gd name="adj" fmla="val 6617"/>
+              <a:gd name="adj" fmla="val 7225"/>
             </a:avLst>
           </a:prstGeom>
           <a:solidFill>
@@ -9933,8 +9933,8 @@
         </p:blipFill>
         <p:spPr>
           <a:xfrm>
-            <a:off x="8595360" y="502920"/>
-            <a:ext cx="2875585" cy="5852160"/>
+            <a:off x="8915400" y="566928"/>
+            <a:ext cx="2619691" cy="5669280"/>
           </a:xfrm>
           <a:prstGeom prst="rect">
             <a:avLst/>
@@ -9953,8 +9953,8 @@
         </p:nvSpPr>
         <p:spPr>
           <a:xfrm>
-            <a:off x="11338560" y="6400800"/>
-            <a:ext cx="548640" cy="274320"/>
+            <a:off x="11064240" y="6355080"/>
+            <a:ext cx="548640" cy="228600"/>
           </a:xfrm>
           <a:prstGeom prst="rect">
             <a:avLst/>
@@ -10451,12 +10451,12 @@
         </p:nvSpPr>
         <p:spPr>
           <a:xfrm>
-            <a:off x="8513064" y="420624"/>
-            <a:ext cx="3040177" cy="6016752"/>
+            <a:off x="8833104" y="484632"/>
+            <a:ext cx="2784283" cy="5833872"/>
           </a:xfrm>
           <a:prstGeom prst="roundRect">
             <a:avLst>
-              <a:gd name="adj" fmla="val 6617"/>
+              <a:gd name="adj" fmla="val 7225"/>
             </a:avLst>
           </a:prstGeom>
           <a:solidFill>
@@ -10493,8 +10493,8 @@
         </p:blipFill>
         <p:spPr>
           <a:xfrm>
-            <a:off x="8595360" y="502920"/>
-            <a:ext cx="2875585" cy="5852160"/>
+            <a:off x="8915400" y="566928"/>
+            <a:ext cx="2619691" cy="5669280"/>
           </a:xfrm>
           <a:prstGeom prst="rect">
             <a:avLst/>
@@ -10513,8 +10513,8 @@
         </p:nvSpPr>
         <p:spPr>
           <a:xfrm>
-            <a:off x="11338560" y="6400800"/>
-            <a:ext cx="548640" cy="274320"/>
+            <a:off x="11064240" y="6355080"/>
+            <a:ext cx="548640" cy="228600"/>
           </a:xfrm>
           <a:prstGeom prst="rect">
             <a:avLst/>
@@ -10667,7 +10667,7 @@
         <p:spPr>
           <a:xfrm>
             <a:off x="1371600" y="1563624"/>
-            <a:ext cx="6126480" cy="1024128"/>
+            <a:ext cx="6126480" cy="868680"/>
           </a:xfrm>
           <a:prstGeom prst="rect">
             <a:avLst/>
@@ -10725,7 +10725,7 @@
         </p:nvSpPr>
         <p:spPr>
           <a:xfrm>
-            <a:off x="548640" y="2697480"/>
+            <a:off x="548640" y="2770632"/>
             <a:ext cx="566928" cy="566928"/>
           </a:xfrm>
           <a:prstGeom prst="ellipse">
@@ -10758,7 +10758,7 @@
         </p:blipFill>
         <p:spPr>
           <a:xfrm>
-            <a:off x="685800" y="2834640"/>
+            <a:off x="685800" y="2907792"/>
             <a:ext cx="292608" cy="292608"/>
           </a:xfrm>
           <a:prstGeom prst="rect">
@@ -10774,8 +10774,8 @@
         </p:nvSpPr>
         <p:spPr>
           <a:xfrm>
-            <a:off x="1371600" y="2660904"/>
-            <a:ext cx="6126480" cy="1024128"/>
+            <a:off x="1371600" y="2734056"/>
+            <a:ext cx="6126480" cy="868680"/>
           </a:xfrm>
           <a:prstGeom prst="rect">
             <a:avLst/>
@@ -10833,7 +10833,7 @@
         </p:nvSpPr>
         <p:spPr>
           <a:xfrm>
-            <a:off x="548640" y="3794760"/>
+            <a:off x="548640" y="3941064"/>
             <a:ext cx="566928" cy="566928"/>
           </a:xfrm>
           <a:prstGeom prst="ellipse">
@@ -10866,7 +10866,7 @@
         </p:blipFill>
         <p:spPr>
           <a:xfrm>
-            <a:off x="685800" y="3931920"/>
+            <a:off x="685800" y="4078224"/>
             <a:ext cx="292608" cy="292608"/>
           </a:xfrm>
           <a:prstGeom prst="rect">
@@ -10882,8 +10882,8 @@
         </p:nvSpPr>
         <p:spPr>
           <a:xfrm>
-            <a:off x="1371600" y="3758184"/>
-            <a:ext cx="6126480" cy="1024128"/>
+            <a:off x="1371600" y="3904488"/>
+            <a:ext cx="6126480" cy="868680"/>
           </a:xfrm>
           <a:prstGeom prst="rect">
             <a:avLst/>
@@ -10941,7 +10941,7 @@
         </p:nvSpPr>
         <p:spPr>
           <a:xfrm>
-            <a:off x="548640" y="4892040"/>
+            <a:off x="548640" y="5111496"/>
             <a:ext cx="566928" cy="566928"/>
           </a:xfrm>
           <a:prstGeom prst="ellipse">
@@ -10974,7 +10974,7 @@
         </p:blipFill>
         <p:spPr>
           <a:xfrm>
-            <a:off x="685800" y="5029200"/>
+            <a:off x="685800" y="5248656"/>
             <a:ext cx="292608" cy="292608"/>
           </a:xfrm>
           <a:prstGeom prst="rect">
@@ -10990,8 +10990,8 @@
         </p:nvSpPr>
         <p:spPr>
           <a:xfrm>
-            <a:off x="1371600" y="4855464"/>
-            <a:ext cx="6126480" cy="1024128"/>
+            <a:off x="1371600" y="5074920"/>
+            <a:ext cx="6126480" cy="868680"/>
           </a:xfrm>
           <a:prstGeom prst="rect">
             <a:avLst/>
@@ -11049,8 +11049,8 @@
         </p:nvSpPr>
         <p:spPr>
           <a:xfrm>
-            <a:off x="548640" y="5669280"/>
-            <a:ext cx="6949440" cy="365760"/>
+            <a:off x="548640" y="5989320"/>
+            <a:ext cx="6949440" cy="320040"/>
           </a:xfrm>
           <a:prstGeom prst="rect">
             <a:avLst/>
@@ -11085,12 +11085,12 @@
         </p:nvSpPr>
         <p:spPr>
           <a:xfrm>
-            <a:off x="8513064" y="420624"/>
-            <a:ext cx="3040177" cy="6016752"/>
+            <a:off x="8833104" y="484632"/>
+            <a:ext cx="2784283" cy="5833872"/>
           </a:xfrm>
           <a:prstGeom prst="roundRect">
             <a:avLst>
-              <a:gd name="adj" fmla="val 6617"/>
+              <a:gd name="adj" fmla="val 7225"/>
             </a:avLst>
           </a:prstGeom>
           <a:solidFill>
@@ -11127,8 +11127,8 @@
         </p:blipFill>
         <p:spPr>
           <a:xfrm>
-            <a:off x="8595360" y="502920"/>
-            <a:ext cx="2875585" cy="5852160"/>
+            <a:off x="8915400" y="566928"/>
+            <a:ext cx="2619691" cy="5669280"/>
           </a:xfrm>
           <a:prstGeom prst="rect">
             <a:avLst/>
@@ -11147,8 +11147,8 @@
         </p:nvSpPr>
         <p:spPr>
           <a:xfrm>
-            <a:off x="11338560" y="6400800"/>
-            <a:ext cx="548640" cy="274320"/>
+            <a:off x="11064240" y="6355080"/>
+            <a:ext cx="548640" cy="228600"/>
           </a:xfrm>
           <a:prstGeom prst="rect">
             <a:avLst/>
@@ -11301,7 +11301,7 @@
         <p:spPr>
           <a:xfrm>
             <a:off x="1371600" y="1563624"/>
-            <a:ext cx="6126480" cy="1024128"/>
+            <a:ext cx="6126480" cy="868680"/>
           </a:xfrm>
           <a:prstGeom prst="rect">
             <a:avLst/>
@@ -11359,7 +11359,7 @@
         </p:nvSpPr>
         <p:spPr>
           <a:xfrm>
-            <a:off x="548640" y="2697480"/>
+            <a:off x="548640" y="2770632"/>
             <a:ext cx="566928" cy="566928"/>
           </a:xfrm>
           <a:prstGeom prst="ellipse">
@@ -11392,7 +11392,7 @@
         </p:blipFill>
         <p:spPr>
           <a:xfrm>
-            <a:off x="685800" y="2834640"/>
+            <a:off x="685800" y="2907792"/>
             <a:ext cx="292608" cy="292608"/>
           </a:xfrm>
           <a:prstGeom prst="rect">
@@ -11408,8 +11408,8 @@
         </p:nvSpPr>
         <p:spPr>
           <a:xfrm>
-            <a:off x="1371600" y="2660904"/>
-            <a:ext cx="6126480" cy="1024128"/>
+            <a:off x="1371600" y="2734056"/>
+            <a:ext cx="6126480" cy="868680"/>
           </a:xfrm>
           <a:prstGeom prst="rect">
             <a:avLst/>
@@ -11467,7 +11467,7 @@
         </p:nvSpPr>
         <p:spPr>
           <a:xfrm>
-            <a:off x="548640" y="3794760"/>
+            <a:off x="548640" y="3941064"/>
             <a:ext cx="566928" cy="566928"/>
           </a:xfrm>
           <a:prstGeom prst="ellipse">
@@ -11500,7 +11500,7 @@
         </p:blipFill>
         <p:spPr>
           <a:xfrm>
-            <a:off x="685800" y="3931920"/>
+            <a:off x="685800" y="4078224"/>
             <a:ext cx="292608" cy="292608"/>
           </a:xfrm>
           <a:prstGeom prst="rect">
@@ -11516,8 +11516,8 @@
         </p:nvSpPr>
         <p:spPr>
           <a:xfrm>
-            <a:off x="1371600" y="3758184"/>
-            <a:ext cx="6126480" cy="1024128"/>
+            <a:off x="1371600" y="3904488"/>
+            <a:ext cx="6126480" cy="868680"/>
           </a:xfrm>
           <a:prstGeom prst="rect">
             <a:avLst/>
@@ -11575,7 +11575,7 @@
         </p:nvSpPr>
         <p:spPr>
           <a:xfrm>
-            <a:off x="548640" y="4892040"/>
+            <a:off x="548640" y="5111496"/>
             <a:ext cx="566928" cy="566928"/>
           </a:xfrm>
           <a:prstGeom prst="ellipse">
@@ -11608,7 +11608,7 @@
         </p:blipFill>
         <p:spPr>
           <a:xfrm>
-            <a:off x="685800" y="5029200"/>
+            <a:off x="685800" y="5248656"/>
             <a:ext cx="292608" cy="292608"/>
           </a:xfrm>
           <a:prstGeom prst="rect">
@@ -11624,8 +11624,8 @@
         </p:nvSpPr>
         <p:spPr>
           <a:xfrm>
-            <a:off x="1371600" y="4855464"/>
-            <a:ext cx="6126480" cy="1024128"/>
+            <a:off x="1371600" y="5074920"/>
+            <a:ext cx="6126480" cy="868680"/>
           </a:xfrm>
           <a:prstGeom prst="rect">
             <a:avLst/>
@@ -11683,8 +11683,8 @@
         </p:nvSpPr>
         <p:spPr>
           <a:xfrm>
-            <a:off x="548640" y="5669280"/>
-            <a:ext cx="6949440" cy="365760"/>
+            <a:off x="548640" y="5989320"/>
+            <a:ext cx="6949440" cy="320040"/>
           </a:xfrm>
           <a:prstGeom prst="rect">
             <a:avLst/>
@@ -11719,12 +11719,12 @@
         </p:nvSpPr>
         <p:spPr>
           <a:xfrm>
-            <a:off x="8513064" y="420624"/>
-            <a:ext cx="3040177" cy="6016752"/>
+            <a:off x="8833104" y="484632"/>
+            <a:ext cx="2784283" cy="5833872"/>
           </a:xfrm>
           <a:prstGeom prst="roundRect">
             <a:avLst>
-              <a:gd name="adj" fmla="val 6617"/>
+              <a:gd name="adj" fmla="val 7225"/>
             </a:avLst>
           </a:prstGeom>
           <a:solidFill>
@@ -11761,8 +11761,8 @@
         </p:blipFill>
         <p:spPr>
           <a:xfrm>
-            <a:off x="8595360" y="502920"/>
-            <a:ext cx="2875585" cy="5852160"/>
+            <a:off x="8915400" y="566928"/>
+            <a:ext cx="2619691" cy="5669280"/>
           </a:xfrm>
           <a:prstGeom prst="rect">
             <a:avLst/>
@@ -11781,8 +11781,8 @@
         </p:nvSpPr>
         <p:spPr>
           <a:xfrm>
-            <a:off x="11338560" y="6400800"/>
-            <a:ext cx="548640" cy="274320"/>
+            <a:off x="11064240" y="6355080"/>
+            <a:ext cx="548640" cy="228600"/>
           </a:xfrm>
           <a:prstGeom prst="rect">
             <a:avLst/>

</xml_diff>